<commit_message>
M02: use Project Knowledge for product catalog continuity (positioning M1 + katalog M2 both auto-carry to M3-5); ripple fix to M3; update PPTX + outline xlsx to match
</commit_message>
<xml_diff>
--- a/Content-Marketing/M02-Deskripsi-Produk/K3-M02-Deskripsi-Produk.pptx
+++ b/Content-Marketing/M02-Deskripsi-Produk/K3-M02-Deskripsi-Produk.pptx
@@ -2622,12 +2622,12 @@
         </p:nvSpPr>
         <p:spPr>
           <a:xfrm>
-            <a:off x="502920" y="5074920"/>
-            <a:ext cx="11064240" cy="841248"/>
+            <a:off x="502920" y="5029200"/>
+            <a:ext cx="11064240" cy="1234440"/>
           </a:xfrm>
           <a:prstGeom prst="roundRect">
             <a:avLst>
-              <a:gd name="adj" fmla="val 10870"/>
+              <a:gd name="adj" fmla="val 7407"/>
             </a:avLst>
           </a:prstGeom>
           <a:solidFill>
@@ -2649,8 +2649,8 @@
         </p:nvSpPr>
         <p:spPr>
           <a:xfrm>
-            <a:off x="713232" y="5074920"/>
-            <a:ext cx="10643616" cy="841248"/>
+            <a:off x="713232" y="5029200"/>
+            <a:ext cx="10643616" cy="1234440"/>
           </a:xfrm>
           <a:prstGeom prst="rect">
             <a:avLst/>
@@ -2664,7 +2664,7 @@
           <a:p>
             <a:pPr indent="0" marL="0">
               <a:lnSpc>
-                <a:spcPct val="120000"/>
+                <a:spcPct val="125000"/>
               </a:lnSpc>
               <a:buNone/>
             </a:pPr>
@@ -2681,7 +2681,7 @@
             </a:r>
             <a:pPr indent="0" marL="0">
               <a:lnSpc>
-                <a:spcPct val="120000"/>
+                <a:spcPct val="125000"/>
               </a:lnSpc>
               <a:buNone/>
             </a:pPr>
@@ -2694,7 +2694,7 @@
                 <a:ea typeface="Helvetica" pitchFamily="34" charset="-122"/>
                 <a:cs typeface="Helvetica" pitchFamily="34" charset="-120"/>
               </a:rPr>
-              <a:t>file cm-data-produk.csv (isi minimal 5 produk), kalimat positioning dari Modul 1, dan akun Tokopedia/Shopee aktif.</a:t>
+              <a:t>file cm-data-produk.csv (isi minimal 5 produk) dan akun Tokopedia/Shopee aktif. Upload CSV-nya ke Project Knowledge — otomatis dipakai lagi di Modul 3-5, dan positioning dari Modul 1 pun sudah tersedia otomatis.</a:t>
             </a:r>
             <a:endParaRPr lang="en-US" sz="1250" dirty="0"/>
           </a:p>
@@ -3187,7 +3187,7 @@
                 <a:ea typeface="Helvetica" pitchFamily="34" charset="-122"/>
                 <a:cs typeface="Helvetica" pitchFamily="34" charset="-120"/>
               </a:rPr>
-              <a:t>"Ini data produkku [upload cm-data-produk.csv]. Positioning: Untuk keluarga muda yang ingin masakan daerah otentik tanpa masak lama. Buatkan deskripsi Tokopedia untuk tiap produk: hook 2 kalimat, keyword, benefit, spesifikasi, CTA. Maks 200 kata per produk."</a:t>
+              <a:t>"[Project ini sudah punya positioning dan data produk dari cm-data-produk.csv di Project Knowledge] Buatkan deskripsi Tokopedia untuk tiap produk: hook 2 kalimat, keyword, benefit, spesifikasi, CTA. Maks 200 kata per produk."</a:t>
             </a:r>
             <a:endParaRPr lang="en-US" sz="1200" dirty="0"/>
           </a:p>
@@ -3229,7 +3229,7 @@
                 <a:ea typeface="Helvetica" pitchFamily="34" charset="-122"/>
                 <a:cs typeface="Helvetica" pitchFamily="34" charset="-120"/>
               </a:rPr>
-              <a:t>Kenapa berhasil: upload CSV + positioning = semua produk selesai dalam 1 prompt, siap paste.</a:t>
+              <a:t>Kenapa berhasil: Project sudah tahu positioning dan semua data produk — tidak perlu ditulis ulang, siap paste.</a:t>
             </a:r>
             <a:endParaRPr lang="en-US" sz="1150" dirty="0"/>
           </a:p>
@@ -3674,7 +3674,7 @@
                 <a:ea typeface="Helvetica" pitchFamily="34" charset="-122"/>
                 <a:cs typeface="Helvetica" pitchFamily="34" charset="-120"/>
               </a:rPr>
-              <a:t>Upload File CSV — </a:t>
+              <a:t>Upload ke Project Knowledge — </a:t>
             </a:r>
             <a:pPr indent="0" marL="0">
               <a:buNone/>
@@ -3688,7 +3688,7 @@
                 <a:ea typeface="Helvetica" pitchFamily="34" charset="-122"/>
                 <a:cs typeface="Helvetica" pitchFamily="34" charset="-120"/>
               </a:rPr>
-              <a:t>ke Claude chat (klik ikon lampiran)</a:t>
+              <a:t>bukan cuma chat, supaya dipakai lagi di Modul 3-5</a:t>
             </a:r>
             <a:endParaRPr lang="en-US" sz="1300" dirty="0"/>
           </a:p>
@@ -3786,7 +3786,7 @@
                 <a:ea typeface="Helvetica" pitchFamily="34" charset="-122"/>
                 <a:cs typeface="Helvetica" pitchFamily="34" charset="-120"/>
               </a:rPr>
-              <a:t>Tambahkan Konteks — </a:t>
+              <a:t>Generate Langsung — </a:t>
             </a:r>
             <a:pPr indent="0" marL="0">
               <a:buNone/>
@@ -3800,7 +3800,7 @@
                 <a:ea typeface="Helvetica" pitchFamily="34" charset="-122"/>
                 <a:cs typeface="Helvetica" pitchFamily="34" charset="-120"/>
               </a:rPr>
-              <a:t>positioning dari Modul 1 + instruksi format, maks 200 kata/produk</a:t>
+              <a:t>positioning &amp; data produk otomatis dari Project, tinggal instruksi format maks 200 kata/produk</a:t>
             </a:r>
             <a:endParaRPr lang="en-US" sz="1300" dirty="0"/>
           </a:p>
@@ -4110,7 +4110,7 @@
                 <a:ea typeface="Helvetica" pitchFamily="34" charset="-122"/>
                 <a:cs typeface="Helvetica" pitchFamily="34" charset="-120"/>
               </a:rPr>
-              <a:t>Upload CSV membuat Claude melihat semua produk sekaligus — hasilnya 5-10 deskripsi lengkap dalam 1 respons, bukan diulang satu per satu.</a:t>
+              <a:t>Project Knowledge membuat Claude melihat semua produk sekaligus tanpa upload ulang — hasilnya 5-10 deskripsi lengkap dalam 1 respons, bukan diulang satu per satu.</a:t>
             </a:r>
             <a:endParaRPr lang="en-US" sz="1250" dirty="0"/>
           </a:p>
@@ -4445,7 +4445,7 @@
               <a:buNone/>
             </a:pPr>
             <a:r>
-              <a:rPr lang="en-US" sz="1300" dirty="0">
+              <a:rPr lang="en-US" sz="1250" dirty="0">
                 <a:solidFill>
                   <a:srgbClr val="23283A"/>
                 </a:solidFill>
@@ -4453,9 +4453,9 @@
                 <a:ea typeface="Helvetica" pitchFamily="34" charset="-122"/>
                 <a:cs typeface="Helvetica" pitchFamily="34" charset="-120"/>
               </a:rPr>
-              <a:t>Isi cm-data-produk.csv dengan minimal 5 produk bisnismu (atau produk Dapur Rara sebagai latihan). Upload ke Claude dan generate semua deskripsi sekaligus. Paste 1 deskripsi terbaik ke listing-mu, catat posisi ranking-nya setelah 7 hari.</a:t>
-            </a:r>
-            <a:endParaRPr lang="en-US" sz="1300" dirty="0"/>
+              <a:t>Isi cm-data-produk.csv dengan minimal 5 produk bisnismu (atau produk Dapur Rara sebagai latihan). Upload ke Project Knowledge dari Project yang sama dengan Modul 1, lalu generate semua deskripsi sekaligus — tanpa perlu ketik ulang positioning. Paste 1 deskripsi terbaik ke listing-mu, catat posisi ranking-nya setelah 7 hari.</a:t>
+            </a:r>
+            <a:endParaRPr lang="en-US" sz="1250" dirty="0"/>
           </a:p>
         </p:txBody>
       </p:sp>
@@ -4548,7 +4548,7 @@
               <a:buNone/>
             </a:pPr>
             <a:r>
-              <a:rPr lang="en-US" sz="1300" dirty="0">
+              <a:rPr lang="en-US" sz="1250" dirty="0">
                 <a:solidFill>
                   <a:srgbClr val="B7C0D8"/>
                 </a:solidFill>
@@ -4558,7 +4558,7 @@
               </a:rPr>
               <a:t>Minimal 5 deskripsi produk lengkap (hook + keyword + benefit + spesifikasi + CTA), siap dipaste langsung ke marketplace — waktu yang dihemat: sekitar 45 menit.</a:t>
             </a:r>
-            <a:endParaRPr lang="en-US" sz="1300" dirty="0"/>
+            <a:endParaRPr lang="en-US" sz="1250" dirty="0"/>
           </a:p>
           <a:p>
             <a:pPr indent="0" marL="0">
@@ -4568,7 +4568,7 @@
               <a:buNone/>
             </a:pPr>
             <a:r>
-              <a:rPr lang="en-US" sz="1300" dirty="0">
+              <a:rPr lang="en-US" sz="1250" dirty="0">
                 <a:solidFill>
                   <a:srgbClr val="B7C0D8"/>
                 </a:solidFill>
@@ -4576,9 +4576,9 @@
                 <a:ea typeface="Helvetica" pitchFamily="34" charset="-122"/>
                 <a:cs typeface="Helvetica" pitchFamily="34" charset="-120"/>
               </a:rPr>
-              <a:t>File pendukung: cm-data-produk.csv</a:t>
-            </a:r>
-            <a:endParaRPr lang="en-US" sz="1300" dirty="0"/>
+              <a:t>File pendukung: cm-data-produk.csv, sekarang juga tersimpan di Project Knowledge untuk dipakai lagi di Modul 3-5.</a:t>
+            </a:r>
+            <a:endParaRPr lang="en-US" sz="1250" dirty="0"/>
           </a:p>
         </p:txBody>
       </p:sp>

</xml_diff>

<commit_message>
Add copy-paste prompt-box to Latihan sections in M02-M05 (M01 intentionally excluded - prompt already lives in cm-template-kompetitor.txt); update M02 PPTX + outline xlsx to match
</commit_message>
<xml_diff>
--- a/Content-Marketing/M02-Deskripsi-Produk/K3-M02-Deskripsi-Produk.pptx
+++ b/Content-Marketing/M02-Deskripsi-Produk/K3-M02-Deskripsi-Produk.pptx
@@ -4360,11 +4360,11 @@
         <p:spPr>
           <a:xfrm>
             <a:off x="502920" y="2084832"/>
-            <a:ext cx="11064240" cy="1417320"/>
+            <a:ext cx="11064240" cy="1783080"/>
           </a:xfrm>
           <a:prstGeom prst="roundRect">
             <a:avLst>
-              <a:gd name="adj" fmla="val 7742"/>
+              <a:gd name="adj" fmla="val 6154"/>
             </a:avLst>
           </a:prstGeom>
           <a:solidFill>
@@ -4426,7 +4426,7 @@
         <p:spPr>
           <a:xfrm>
             <a:off x="713232" y="2542032"/>
-            <a:ext cx="10607040" cy="868680"/>
+            <a:ext cx="10607040" cy="502920"/>
           </a:xfrm>
           <a:prstGeom prst="rect">
             <a:avLst/>
@@ -4440,12 +4440,12 @@
           <a:p>
             <a:pPr indent="0" marL="0">
               <a:lnSpc>
-                <a:spcPct val="130000"/>
+                <a:spcPct val="125000"/>
               </a:lnSpc>
               <a:buNone/>
             </a:pPr>
             <a:r>
-              <a:rPr lang="en-US" sz="1250" dirty="0">
+              <a:rPr lang="en-US" sz="1200" dirty="0">
                 <a:solidFill>
                   <a:srgbClr val="23283A"/>
                 </a:solidFill>
@@ -4453,9 +4453,9 @@
                 <a:ea typeface="Helvetica" pitchFamily="34" charset="-122"/>
                 <a:cs typeface="Helvetica" pitchFamily="34" charset="-120"/>
               </a:rPr>
-              <a:t>Isi cm-data-produk.csv dengan minimal 5 produk bisnismu (atau produk Dapur Rara sebagai latihan). Upload ke Project Knowledge dari Project yang sama dengan Modul 1, lalu generate semua deskripsi sekaligus — tanpa perlu ketik ulang positioning. Paste 1 deskripsi terbaik ke listing-mu, catat posisi ranking-nya setelah 7 hari.</a:t>
-            </a:r>
-            <a:endParaRPr lang="en-US" sz="1250" dirty="0"/>
+              <a:t>Isi cm-data-produk.csv dengan minimal 5 produk bisnismu (atau produk Dapur Rara sebagai latihan). Upload ke Project Knowledge dari Project yang sama dengan Modul 1, lalu jalankan prompt ini:</a:t>
+            </a:r>
+            <a:endParaRPr lang="en-US" sz="1200" dirty="0"/>
           </a:p>
         </p:txBody>
       </p:sp>
@@ -4467,15 +4467,84 @@
         </p:nvSpPr>
         <p:spPr>
           <a:xfrm>
-            <a:off x="502920" y="3730752"/>
-            <a:ext cx="11064240" cy="1554480"/>
+            <a:off x="713232" y="3127248"/>
+            <a:ext cx="10607040" cy="548640"/>
           </a:xfrm>
           <a:prstGeom prst="roundRect">
             <a:avLst>
-              <a:gd name="adj" fmla="val 7059"/>
+              <a:gd name="adj" fmla="val 13333"/>
             </a:avLst>
           </a:prstGeom>
           <a:solidFill>
+            <a:srgbClr val="FFFFFF"/>
+          </a:solidFill>
+          <a:ln w="12700">
+            <a:solidFill>
+              <a:srgbClr val="B8E6C9"/>
+            </a:solidFill>
+            <a:prstDash val="solid"/>
+          </a:ln>
+        </p:spPr>
+      </p:sp>
+      <p:sp>
+        <p:nvSpPr>
+          <p:cNvPr id="12" name="Text 10"/>
+          <p:cNvSpPr/>
+          <p:nvPr/>
+        </p:nvSpPr>
+        <p:spPr>
+          <a:xfrm>
+            <a:off x="868680" y="3127248"/>
+            <a:ext cx="10296144" cy="548640"/>
+          </a:xfrm>
+          <a:prstGeom prst="rect">
+            <a:avLst/>
+          </a:prstGeom>
+          <a:noFill/>
+          <a:ln/>
+        </p:spPr>
+        <p:txBody>
+          <a:bodyPr wrap="square" lIns="0" tIns="0" rIns="0" bIns="0" rtlCol="0" anchor="ctr"/>
+          <a:lstStyle/>
+          <a:p>
+            <a:pPr indent="0" marL="0">
+              <a:lnSpc>
+                <a:spcPct val="120000"/>
+              </a:lnSpc>
+              <a:buNone/>
+            </a:pPr>
+            <a:r>
+              <a:rPr lang="en-US" sz="1050" i="1" dirty="0">
+                <a:solidFill>
+                  <a:srgbClr val="1A7A44"/>
+                </a:solidFill>
+                <a:latin typeface="Helvetica" pitchFamily="34" charset="0"/>
+                <a:ea typeface="Helvetica" pitchFamily="34" charset="-122"/>
+                <a:cs typeface="Helvetica" pitchFamily="34" charset="-120"/>
+              </a:rPr>
+              <a:t>[Project ini sudah punya positioning dan data produk] Buatkan deskripsi Tokopedia untuk tiap produk: hook 2 kalimat, keyword, benefit, spesifikasi, CTA. Maks 200 kata per produk.</a:t>
+            </a:r>
+            <a:endParaRPr lang="en-US" sz="1050" dirty="0"/>
+          </a:p>
+        </p:txBody>
+      </p:sp>
+      <p:sp>
+        <p:nvSpPr>
+          <p:cNvPr id="13" name="Shape 11"/>
+          <p:cNvSpPr/>
+          <p:nvPr/>
+        </p:nvSpPr>
+        <p:spPr>
+          <a:xfrm>
+            <a:off x="502920" y="4050792"/>
+            <a:ext cx="11064240" cy="1417320"/>
+          </a:xfrm>
+          <a:prstGeom prst="roundRect">
+            <a:avLst>
+              <a:gd name="adj" fmla="val 7742"/>
+            </a:avLst>
+          </a:prstGeom>
+          <a:solidFill>
             <a:srgbClr val="141D33"/>
           </a:solidFill>
           <a:ln/>
@@ -4483,13 +4552,13 @@
       </p:sp>
       <p:sp>
         <p:nvSpPr>
-          <p:cNvPr id="12" name="Text 10"/>
-          <p:cNvSpPr/>
-          <p:nvPr/>
-        </p:nvSpPr>
-        <p:spPr>
-          <a:xfrm>
-            <a:off x="713232" y="3895344"/>
+          <p:cNvPr id="14" name="Text 12"/>
+          <p:cNvSpPr/>
+          <p:nvPr/>
+        </p:nvSpPr>
+        <p:spPr>
+          <a:xfrm>
+            <a:off x="713232" y="4215384"/>
             <a:ext cx="10607040" cy="274320"/>
           </a:xfrm>
           <a:prstGeom prst="rect">
@@ -4522,14 +4591,14 @@
       </p:sp>
       <p:sp>
         <p:nvSpPr>
-          <p:cNvPr id="13" name="Text 11"/>
-          <p:cNvSpPr/>
-          <p:nvPr/>
-        </p:nvSpPr>
-        <p:spPr>
-          <a:xfrm>
-            <a:off x="713232" y="4187952"/>
-            <a:ext cx="10607040" cy="1005840"/>
+          <p:cNvPr id="15" name="Text 13"/>
+          <p:cNvSpPr/>
+          <p:nvPr/>
+        </p:nvSpPr>
+        <p:spPr>
+          <a:xfrm>
+            <a:off x="713232" y="4507992"/>
+            <a:ext cx="10607040" cy="914400"/>
           </a:xfrm>
           <a:prstGeom prst="rect">
             <a:avLst/>

</xml_diff>

<commit_message>
Julia's manual edits: M02 PPTX bracket fix (slide 5 Latihan prompt), cm-data-produk.csv trimmed to 5 filled Dapur Rara rows only
</commit_message>
<xml_diff>
--- a/Content-Marketing/M02-Deskripsi-Produk/K3-M02-Deskripsi-Produk.pptx
+++ b/Content-Marketing/M02-Deskripsi-Produk/K3-M02-Deskripsi-Produk.pptx
@@ -4,6 +4,9 @@
   <p:sldMasterIdLst>
     <p:sldMasterId id="2147483648" r:id="rId1"/>
   </p:sldMasterIdLst>
+  <p:notesMasterIdLst>
+    <p:notesMasterId r:id="rId7"/>
+  </p:notesMasterIdLst>
   <p:sldIdLst>
     <p:sldId id="256" r:id="rId2"/>
     <p:sldId id="257" r:id="rId3"/>
@@ -11,11 +14,8 @@
     <p:sldId id="259" r:id="rId5"/>
     <p:sldId id="260" r:id="rId6"/>
   </p:sldIdLst>
-  <p:notesMasterIdLst>
-    <p:notesMasterId r:id="rId7"/>
-  </p:notesMasterIdLst>
-  <p:sldSz cx="12191695" cy="6858000"/>
-  <p:notesSz cx="6858000" cy="12191695"/>
+  <p:sldSz cx="12192000" cy="6858000"/>
+  <p:notesSz cx="6858000" cy="12192000"/>
   <p:defaultTextStyle>
     <a:lvl1pPr marL="0" algn="l" defTabSz="914400" rtl="0" eaLnBrk="1" latinLnBrk="0" hangingPunct="1">
       <a:defRPr sz="1800" kern="1200">
@@ -108,6 +108,11 @@
       </a:defRPr>
     </a:lvl9pPr>
   </p:defaultTextStyle>
+  <p:extLst>
+    <p:ext uri="{EFAFB233-063F-42B5-8137-9DF3F51BA10A}">
+      <p15:sldGuideLst xmlns:p15="http://schemas.microsoft.com/office/powerpoint/2012/main"/>
+    </p:ext>
+  </p:extLst>
 </p:presentation>
 </file>
 
@@ -133,234 +138,10 @@
           <a:chExt cx="0" cy="0"/>
         </a:xfrm>
       </p:grpSpPr>
-      <p:sp>
-        <p:nvSpPr>
-          <p:cNvPr id="2" name="Header Placeholder 1"/>
-          <p:cNvSpPr>
-            <a:spLocks noGrp="1"/>
-          </p:cNvSpPr>
-          <p:nvPr>
-            <p:ph type="hdr" sz="quarter"/>
-          </p:nvPr>
-        </p:nvSpPr>
-        <p:spPr>
-          <a:xfrm>
-            <a:off x="0" y="0"/>
-            <a:ext cx="2971800" cy="458788"/>
-          </a:xfrm>
-          <a:prstGeom prst="rect">
-            <a:avLst/>
-          </a:prstGeom>
-        </p:spPr>
-        <p:txBody>
-          <a:bodyPr vert="horz" lIns="91440" tIns="45720" rIns="91440" bIns="45720" rtlCol="0"/>
-          <a:lstStyle>
-            <a:lvl1pPr algn="l">
-              <a:defRPr sz="1200"/>
-            </a:lvl1pPr>
-          </a:lstStyle>
-          <a:p>
-            <a:endParaRPr lang="en-US"/>
-          </a:p>
-        </p:txBody>
-      </p:sp>
-      <p:sp>
-        <p:nvSpPr>
-          <p:cNvPr id="3" name="Date Placeholder 2"/>
-          <p:cNvSpPr>
-            <a:spLocks noGrp="1"/>
-          </p:cNvSpPr>
-          <p:nvPr>
-            <p:ph type="dt" idx="1"/>
-          </p:nvPr>
-        </p:nvSpPr>
-        <p:spPr>
-          <a:xfrm>
-            <a:off x="3884613" y="0"/>
-            <a:ext cx="2971800" cy="458788"/>
-          </a:xfrm>
-          <a:prstGeom prst="rect">
-            <a:avLst/>
-          </a:prstGeom>
-        </p:spPr>
-        <p:txBody>
-          <a:bodyPr vert="horz" lIns="91440" tIns="45720" rIns="91440" bIns="45720" rtlCol="0"/>
-          <a:lstStyle>
-            <a:lvl1pPr algn="r">
-              <a:defRPr sz="1200"/>
-            </a:lvl1pPr>
-          </a:lstStyle>
-          <a:p>
-            <a:fld id="{5282F153-3F37-0F45-9E97-73ACFA13230C}" type="datetimeFigureOut">
-              <a:rPr lang="en-US"/>
-              <a:t>7/23/19</a:t>
-            </a:fld>
-            <a:endParaRPr lang="en-US"/>
-          </a:p>
-        </p:txBody>
-      </p:sp>
-      <p:sp>
-        <p:nvSpPr>
-          <p:cNvPr id="4" name="Slide Image Placeholder 3"/>
-          <p:cNvSpPr>
-            <a:spLocks noGrp="1" noRot="1" noChangeAspect="1"/>
-          </p:cNvSpPr>
-          <p:nvPr>
-            <p:ph type="sldImg" idx="2"/>
-          </p:nvPr>
-        </p:nvSpPr>
-        <p:spPr>
-          <a:xfrm>
-            <a:off x="685800" y="1143000"/>
-            <a:ext cx="5486400" cy="3086100"/>
-          </a:xfrm>
-          <a:prstGeom prst="rect">
-            <a:avLst/>
-          </a:prstGeom>
-          <a:noFill/>
-          <a:ln w="12700">
-            <a:solidFill>
-              <a:prstClr val="black"/>
-            </a:solidFill>
-          </a:ln>
-        </p:spPr>
-        <p:txBody>
-          <a:bodyPr vert="horz" lIns="91440" tIns="45720" rIns="91440" bIns="45720" rtlCol="0" anchor="ctr"/>
-          <a:lstStyle/>
-          <a:p>
-            <a:endParaRPr lang="en-US"/>
-          </a:p>
-        </p:txBody>
-      </p:sp>
-      <p:sp>
-        <p:nvSpPr>
-          <p:cNvPr id="5" name="Notes Placeholder 4"/>
-          <p:cNvSpPr>
-            <a:spLocks noGrp="1"/>
-          </p:cNvSpPr>
-          <p:nvPr>
-            <p:ph type="body" sz="quarter" idx="3"/>
-          </p:nvPr>
-        </p:nvSpPr>
-        <p:spPr>
-          <a:xfrm>
-            <a:off x="685800" y="4400550"/>
-            <a:ext cx="5486400" cy="3600450"/>
-          </a:xfrm>
-          <a:prstGeom prst="rect">
-            <a:avLst/>
-          </a:prstGeom>
-        </p:spPr>
-        <p:txBody>
-          <a:bodyPr vert="horz" lIns="91440" tIns="45720" rIns="91440" bIns="45720" rtlCol="0"/>
-          <a:lstStyle/>
-          <a:p>
-            <a:pPr lvl="0"/>
-            <a:r>
-              <a:rPr lang="en-US"/>
-              <a:t>Click to edit Master text styles</a:t>
-            </a:r>
-          </a:p>
-          <a:p>
-            <a:pPr lvl="1"/>
-            <a:r>
-              <a:rPr lang="en-US"/>
-              <a:t>Second level</a:t>
-            </a:r>
-          </a:p>
-          <a:p>
-            <a:pPr lvl="2"/>
-            <a:r>
-              <a:rPr lang="en-US"/>
-              <a:t>Third level</a:t>
-            </a:r>
-          </a:p>
-          <a:p>
-            <a:pPr lvl="3"/>
-            <a:r>
-              <a:rPr lang="en-US"/>
-              <a:t>Fourth level</a:t>
-            </a:r>
-          </a:p>
-          <a:p>
-            <a:pPr lvl="4"/>
-            <a:r>
-              <a:rPr lang="en-US"/>
-              <a:t>Fifth level</a:t>
-            </a:r>
-          </a:p>
-        </p:txBody>
-      </p:sp>
-      <p:sp>
-        <p:nvSpPr>
-          <p:cNvPr id="6" name="Footer Placeholder 5"/>
-          <p:cNvSpPr>
-            <a:spLocks noGrp="1"/>
-          </p:cNvSpPr>
-          <p:nvPr>
-            <p:ph type="ftr" sz="quarter" idx="4"/>
-          </p:nvPr>
-        </p:nvSpPr>
-        <p:spPr>
-          <a:xfrm>
-            <a:off x="0" y="8685213"/>
-            <a:ext cx="2971800" cy="458787"/>
-          </a:xfrm>
-          <a:prstGeom prst="rect">
-            <a:avLst/>
-          </a:prstGeom>
-        </p:spPr>
-        <p:txBody>
-          <a:bodyPr vert="horz" lIns="91440" tIns="45720" rIns="91440" bIns="45720" rtlCol="0" anchor="b"/>
-          <a:lstStyle>
-            <a:lvl1pPr algn="l">
-              <a:defRPr sz="1200"/>
-            </a:lvl1pPr>
-          </a:lstStyle>
-          <a:p>
-            <a:endParaRPr lang="en-US"/>
-          </a:p>
-        </p:txBody>
-      </p:sp>
-      <p:sp>
-        <p:nvSpPr>
-          <p:cNvPr id="7" name="Slide Number Placeholder 6"/>
-          <p:cNvSpPr>
-            <a:spLocks noGrp="1"/>
-          </p:cNvSpPr>
-          <p:nvPr>
-            <p:ph type="sldNum" sz="quarter" idx="5"/>
-          </p:nvPr>
-        </p:nvSpPr>
-        <p:spPr>
-          <a:xfrm>
-            <a:off x="3884613" y="8685213"/>
-            <a:ext cx="2971800" cy="458787"/>
-          </a:xfrm>
-          <a:prstGeom prst="rect">
-            <a:avLst/>
-          </a:prstGeom>
-        </p:spPr>
-        <p:txBody>
-          <a:bodyPr vert="horz" lIns="91440" tIns="45720" rIns="91440" bIns="45720" rtlCol="0" anchor="b"/>
-          <a:lstStyle>
-            <a:lvl1pPr algn="r">
-              <a:defRPr sz="1200"/>
-            </a:lvl1pPr>
-          </a:lstStyle>
-          <a:p>
-            <a:fld id="{CE5E9CC1-C706-0F49-92D6-E571CC5EEA8F}" type="slidenum">
-              <a:rPr lang="en-US"/>
-              <a:t>‹#›</a:t>
-            </a:fld>
-            <a:endParaRPr lang="en-US"/>
-          </a:p>
-        </p:txBody>
-      </p:sp>
     </p:spTree>
     <p:extLst>
       <p:ext uri="{BB962C8B-B14F-4D97-AF65-F5344CB8AC3E}">
-        <p14:creationId xmlns:p14="http://schemas.microsoft.com/office/powerpoint/2010/main" val="1024086991"/>
+        <p14:creationId xmlns:p14="http://schemas.microsoft.com/office/powerpoint/2010/main" val="1843419748"/>
       </p:ext>
     </p:extLst>
   </p:cSld>
@@ -504,10 +285,6 @@
           <a:bodyPr/>
           <a:lstStyle/>
           <a:p>
-            <a:r>
-              <a:rPr lang="en-US" dirty="0"/>
-              <a:t/>
-            </a:r>
             <a:endParaRPr lang="en-US" dirty="0"/>
           </a:p>
         </p:txBody>
@@ -592,10 +369,6 @@
           <a:bodyPr/>
           <a:lstStyle/>
           <a:p>
-            <a:r>
-              <a:rPr lang="en-US" dirty="0"/>
-              <a:t/>
-            </a:r>
             <a:endParaRPr lang="en-US" dirty="0"/>
           </a:p>
         </p:txBody>
@@ -680,10 +453,6 @@
           <a:bodyPr/>
           <a:lstStyle/>
           <a:p>
-            <a:r>
-              <a:rPr lang="en-US" dirty="0"/>
-              <a:t/>
-            </a:r>
             <a:endParaRPr lang="en-US" dirty="0"/>
           </a:p>
         </p:txBody>
@@ -768,10 +537,6 @@
           <a:bodyPr/>
           <a:lstStyle/>
           <a:p>
-            <a:r>
-              <a:rPr lang="en-US" dirty="0"/>
-              <a:t/>
-            </a:r>
             <a:endParaRPr lang="en-US" dirty="0"/>
           </a:p>
         </p:txBody>
@@ -856,10 +621,6 @@
           <a:bodyPr/>
           <a:lstStyle/>
           <a:p>
-            <a:r>
-              <a:rPr lang="en-US" dirty="0"/>
-              <a:t/>
-            </a:r>
             <a:endParaRPr lang="en-US" dirty="0"/>
           </a:p>
         </p:txBody>
@@ -933,6 +694,11 @@
 <file path=ppt/slideMasters/slideMaster1.xml><?xml version="1.0" encoding="utf-8"?>
 <p:sldMaster xmlns:a="http://schemas.openxmlformats.org/drawingml/2006/main" xmlns:r="http://schemas.openxmlformats.org/officeDocument/2006/relationships" xmlns:p="http://schemas.openxmlformats.org/presentationml/2006/main">
   <p:cSld>
+    <p:bg>
+      <p:bgRef idx="1001">
+        <a:schemeClr val="bg1"/>
+      </p:bgRef>
+    </p:bg>
     <p:spTree>
       <p:nvGrpSpPr>
         <p:cNvPr id="1" name=""/>
@@ -1215,6 +981,7 @@
         <a:solidFill>
           <a:srgbClr val="0D1321"/>
         </a:solidFill>
+        <a:effectLst/>
       </p:bgPr>
     </p:bg>
     <p:spTree>
@@ -1250,6 +1017,13 @@
           </a:solidFill>
           <a:ln/>
         </p:spPr>
+        <p:txBody>
+          <a:bodyPr/>
+          <a:lstStyle/>
+          <a:p>
+            <a:endParaRPr lang="en-ID"/>
+          </a:p>
+        </p:txBody>
       </p:sp>
       <p:sp>
         <p:nvSpPr>
@@ -1272,7 +1046,7 @@
           <a:bodyPr wrap="square" lIns="0" tIns="0" rIns="0" bIns="0" rtlCol="0" anchor="ctr"/>
           <a:lstStyle/>
           <a:p>
-            <a:pPr indent="0" marL="0">
+            <a:pPr marL="0" indent="0">
               <a:buNone/>
             </a:pPr>
             <a:r>
@@ -1286,9 +1060,6 @@
               </a:rPr>
               <a:t>belajar</a:t>
             </a:r>
-            <a:pPr indent="0" marL="0">
-              <a:buNone/>
-            </a:pPr>
             <a:r>
               <a:rPr lang="en-US" sz="2000" b="1" dirty="0">
                 <a:solidFill>
@@ -1325,6 +1096,13 @@
           </a:solidFill>
           <a:ln/>
         </p:spPr>
+        <p:txBody>
+          <a:bodyPr/>
+          <a:lstStyle/>
+          <a:p>
+            <a:endParaRPr lang="en-ID"/>
+          </a:p>
+        </p:txBody>
       </p:sp>
       <p:sp>
         <p:nvSpPr>
@@ -1347,7 +1125,7 @@
           <a:bodyPr wrap="square" lIns="0" tIns="0" rIns="0" bIns="0" rtlCol="0" anchor="ctr"/>
           <a:lstStyle/>
           <a:p>
-            <a:pPr algn="ctr" indent="0" marL="0">
+            <a:pPr marL="0" indent="0" algn="ctr">
               <a:buNone/>
             </a:pPr>
             <a:r>
@@ -1386,11 +1164,11 @@
           <a:bodyPr wrap="square" lIns="0" tIns="0" rIns="0" bIns="0" rtlCol="0" anchor="ctr"/>
           <a:lstStyle/>
           <a:p>
-            <a:pPr indent="0" marL="0">
-              <a:buNone/>
-            </a:pPr>
-            <a:r>
-              <a:rPr lang="en-US" sz="1300" b="1" spc="40" kern="0" dirty="0">
+            <a:pPr marL="0" indent="0">
+              <a:buNone/>
+            </a:pPr>
+            <a:r>
+              <a:rPr lang="en-US" sz="1300" b="1" kern="0" spc="40" dirty="0">
                 <a:solidFill>
                   <a:srgbClr val="8B7CF6"/>
                 </a:solidFill>
@@ -1425,7 +1203,7 @@
           <a:bodyPr wrap="square" lIns="0" tIns="0" rIns="0" bIns="0" rtlCol="0" anchor="ctr"/>
           <a:lstStyle/>
           <a:p>
-            <a:pPr indent="0" marL="0">
+            <a:pPr marL="0" indent="0">
               <a:lnSpc>
                 <a:spcPts val="5000"/>
               </a:lnSpc>
@@ -1467,7 +1245,7 @@
           <a:bodyPr wrap="square" lIns="0" tIns="0" rIns="0" bIns="0" rtlCol="0" anchor="ctr"/>
           <a:lstStyle/>
           <a:p>
-            <a:pPr indent="0" marL="0">
+            <a:pPr marL="0" indent="0">
               <a:buNone/>
             </a:pPr>
             <a:r>
@@ -1529,6 +1307,13 @@
           </a:solidFill>
           <a:ln/>
         </p:spPr>
+        <p:txBody>
+          <a:bodyPr/>
+          <a:lstStyle/>
+          <a:p>
+            <a:endParaRPr lang="en-ID"/>
+          </a:p>
+        </p:txBody>
       </p:sp>
       <p:sp>
         <p:nvSpPr>
@@ -1549,6 +1334,13 @@
           </a:solidFill>
           <a:ln/>
         </p:spPr>
+        <p:txBody>
+          <a:bodyPr/>
+          <a:lstStyle/>
+          <a:p>
+            <a:endParaRPr lang="en-ID"/>
+          </a:p>
+        </p:txBody>
       </p:sp>
       <p:sp>
         <p:nvSpPr>
@@ -1571,7 +1363,7 @@
           <a:bodyPr wrap="square" lIns="0" tIns="0" rIns="0" bIns="0" rtlCol="0" anchor="ctr"/>
           <a:lstStyle/>
           <a:p>
-            <a:pPr indent="0" marL="0">
+            <a:pPr marL="0" indent="0">
               <a:buNone/>
             </a:pPr>
             <a:r>
@@ -1585,9 +1377,6 @@
               </a:rPr>
               <a:t>belajar</a:t>
             </a:r>
-            <a:pPr indent="0" marL="0">
-              <a:buNone/>
-            </a:pPr>
             <a:r>
               <a:rPr lang="en-US" sz="2000" b="1" dirty="0">
                 <a:solidFill>
@@ -1624,7 +1413,7 @@
           <a:bodyPr wrap="square" lIns="0" tIns="0" rIns="0" bIns="0" rtlCol="0" anchor="ctr"/>
           <a:lstStyle/>
           <a:p>
-            <a:pPr algn="r" indent="0" marL="0">
+            <a:pPr marL="0" indent="0" algn="r">
               <a:buNone/>
             </a:pPr>
             <a:r>
@@ -1663,11 +1452,11 @@
           <a:bodyPr wrap="square" lIns="0" tIns="0" rIns="0" bIns="0" rtlCol="0" anchor="ctr"/>
           <a:lstStyle/>
           <a:p>
-            <a:pPr indent="0" marL="0">
-              <a:buNone/>
-            </a:pPr>
-            <a:r>
-              <a:rPr lang="en-US" sz="1250" b="1" spc="40" kern="0" dirty="0">
+            <a:pPr marL="0" indent="0">
+              <a:buNone/>
+            </a:pPr>
+            <a:r>
+              <a:rPr lang="en-US" sz="1250" b="1" kern="0" spc="40" dirty="0">
                 <a:solidFill>
                   <a:srgbClr val="4B36C7"/>
                 </a:solidFill>
@@ -1702,7 +1491,7 @@
           <a:bodyPr wrap="square" lIns="0" tIns="0" rIns="0" bIns="0" rtlCol="0" anchor="ctr"/>
           <a:lstStyle/>
           <a:p>
-            <a:pPr indent="0" marL="0">
+            <a:pPr marL="0" indent="0">
               <a:buNone/>
             </a:pPr>
             <a:r>
@@ -1746,6 +1535,13 @@
             <a:prstDash val="solid"/>
           </a:ln>
         </p:spPr>
+        <p:txBody>
+          <a:bodyPr/>
+          <a:lstStyle/>
+          <a:p>
+            <a:endParaRPr lang="en-ID"/>
+          </a:p>
+        </p:txBody>
       </p:sp>
       <p:sp>
         <p:nvSpPr>
@@ -1768,7 +1564,7 @@
           <a:bodyPr wrap="square" lIns="0" tIns="0" rIns="0" bIns="0" rtlCol="0" anchor="ctr"/>
           <a:lstStyle/>
           <a:p>
-            <a:pPr indent="0" marL="0">
+            <a:pPr marL="0" indent="0">
               <a:buNone/>
             </a:pPr>
             <a:r>
@@ -1807,7 +1603,7 @@
           <a:bodyPr wrap="square" lIns="0" tIns="0" rIns="0" bIns="0" rtlCol="0" anchor="ctr"/>
           <a:lstStyle/>
           <a:p>
-            <a:pPr indent="0" marL="0">
+            <a:pPr marL="0" indent="0">
               <a:lnSpc>
                 <a:spcPct val="120000"/>
               </a:lnSpc>
@@ -1854,6 +1650,13 @@
             <a:prstDash val="solid"/>
           </a:ln>
         </p:spPr>
+        <p:txBody>
+          <a:bodyPr/>
+          <a:lstStyle/>
+          <a:p>
+            <a:endParaRPr lang="en-ID"/>
+          </a:p>
+        </p:txBody>
       </p:sp>
       <p:sp>
         <p:nvSpPr>
@@ -1876,7 +1679,7 @@
           <a:bodyPr wrap="square" lIns="0" tIns="0" rIns="0" bIns="0" rtlCol="0" anchor="ctr"/>
           <a:lstStyle/>
           <a:p>
-            <a:pPr indent="0" marL="0">
+            <a:pPr marL="0" indent="0">
               <a:buNone/>
             </a:pPr>
             <a:r>
@@ -1915,7 +1718,7 @@
           <a:bodyPr wrap="square" lIns="0" tIns="0" rIns="0" bIns="0" rtlCol="0" anchor="ctr"/>
           <a:lstStyle/>
           <a:p>
-            <a:pPr indent="0" marL="0">
+            <a:pPr marL="0" indent="0">
               <a:lnSpc>
                 <a:spcPct val="120000"/>
               </a:lnSpc>
@@ -1962,6 +1765,13 @@
             <a:prstDash val="solid"/>
           </a:ln>
         </p:spPr>
+        <p:txBody>
+          <a:bodyPr/>
+          <a:lstStyle/>
+          <a:p>
+            <a:endParaRPr lang="en-ID"/>
+          </a:p>
+        </p:txBody>
       </p:sp>
       <p:sp>
         <p:nvSpPr>
@@ -1984,7 +1794,7 @@
           <a:bodyPr wrap="square" lIns="0" tIns="0" rIns="0" bIns="0" rtlCol="0" anchor="ctr"/>
           <a:lstStyle/>
           <a:p>
-            <a:pPr indent="0" marL="0">
+            <a:pPr marL="0" indent="0">
               <a:buNone/>
             </a:pPr>
             <a:r>
@@ -2023,7 +1833,7 @@
           <a:bodyPr wrap="square" lIns="0" tIns="0" rIns="0" bIns="0" rtlCol="0" anchor="ctr"/>
           <a:lstStyle/>
           <a:p>
-            <a:pPr indent="0" marL="0">
+            <a:pPr marL="0" indent="0">
               <a:lnSpc>
                 <a:spcPct val="120000"/>
               </a:lnSpc>
@@ -2070,6 +1880,13 @@
             <a:prstDash val="solid"/>
           </a:ln>
         </p:spPr>
+        <p:txBody>
+          <a:bodyPr/>
+          <a:lstStyle/>
+          <a:p>
+            <a:endParaRPr lang="en-ID"/>
+          </a:p>
+        </p:txBody>
       </p:sp>
       <p:sp>
         <p:nvSpPr>
@@ -2092,7 +1909,7 @@
           <a:bodyPr wrap="square" lIns="0" tIns="0" rIns="0" bIns="0" rtlCol="0" anchor="ctr"/>
           <a:lstStyle/>
           <a:p>
-            <a:pPr indent="0" marL="0">
+            <a:pPr marL="0" indent="0">
               <a:buNone/>
             </a:pPr>
             <a:r>
@@ -2131,7 +1948,7 @@
           <a:bodyPr wrap="square" lIns="0" tIns="0" rIns="0" bIns="0" rtlCol="0" anchor="ctr"/>
           <a:lstStyle/>
           <a:p>
-            <a:pPr indent="0" marL="0">
+            <a:pPr marL="0" indent="0">
               <a:lnSpc>
                 <a:spcPct val="120000"/>
               </a:lnSpc>
@@ -2173,7 +1990,7 @@
           <a:bodyPr wrap="square" lIns="0" tIns="0" rIns="0" bIns="0" rtlCol="0" anchor="ctr"/>
           <a:lstStyle/>
           <a:p>
-            <a:pPr indent="0" marL="0">
+            <a:pPr marL="0" indent="0">
               <a:buNone/>
             </a:pPr>
             <a:r>
@@ -2187,9 +2004,6 @@
               </a:rPr>
               <a:t>Penutup: </a:t>
             </a:r>
-            <a:pPr indent="0" marL="0">
-              <a:buNone/>
-            </a:pPr>
             <a:r>
               <a:rPr lang="en-US" sz="1250" b="1" dirty="0">
                 <a:solidFill>
@@ -2201,9 +2015,6 @@
               </a:rPr>
               <a:t>CTA yang jelas</a:t>
             </a:r>
-            <a:pPr indent="0" marL="0">
-              <a:buNone/>
-            </a:pPr>
             <a:r>
               <a:rPr lang="en-US" sz="1250" dirty="0">
                 <a:solidFill>
@@ -2240,11 +2051,11 @@
           <a:bodyPr wrap="square" lIns="0" tIns="0" rIns="0" bIns="0" rtlCol="0" anchor="ctr"/>
           <a:lstStyle/>
           <a:p>
-            <a:pPr indent="0" marL="0">
-              <a:buNone/>
-            </a:pPr>
-            <a:r>
-              <a:rPr lang="en-US" sz="1250" b="1" spc="40" kern="0" dirty="0">
+            <a:pPr marL="0" indent="0">
+              <a:buNone/>
+            </a:pPr>
+            <a:r>
+              <a:rPr lang="en-US" sz="1250" b="1" kern="0" spc="40" dirty="0">
                 <a:solidFill>
                   <a:srgbClr val="4B36C7"/>
                 </a:solidFill>
@@ -2284,6 +2095,13 @@
             <a:prstDash val="solid"/>
           </a:ln>
         </p:spPr>
+        <p:txBody>
+          <a:bodyPr/>
+          <a:lstStyle/>
+          <a:p>
+            <a:endParaRPr lang="en-ID"/>
+          </a:p>
+        </p:txBody>
       </p:sp>
       <p:sp>
         <p:nvSpPr>
@@ -2306,7 +2124,7 @@
           <a:bodyPr wrap="square" lIns="0" tIns="0" rIns="0" bIns="0" rtlCol="0" anchor="ctr"/>
           <a:lstStyle/>
           <a:p>
-            <a:pPr indent="0" marL="0">
+            <a:pPr marL="0" indent="0">
               <a:lnSpc>
                 <a:spcPct val="110000"/>
               </a:lnSpc>
@@ -2326,7 +2144,7 @@
             <a:endParaRPr lang="en-US" sz="1050" dirty="0"/>
           </a:p>
           <a:p>
-            <a:pPr indent="0" marL="0">
+            <a:pPr marL="0" indent="0">
               <a:lnSpc>
                 <a:spcPct val="110000"/>
               </a:lnSpc>
@@ -2373,6 +2191,13 @@
             <a:prstDash val="solid"/>
           </a:ln>
         </p:spPr>
+        <p:txBody>
+          <a:bodyPr/>
+          <a:lstStyle/>
+          <a:p>
+            <a:endParaRPr lang="en-ID"/>
+          </a:p>
+        </p:txBody>
       </p:sp>
       <p:sp>
         <p:nvSpPr>
@@ -2395,7 +2220,7 @@
           <a:bodyPr wrap="square" lIns="0" tIns="0" rIns="0" bIns="0" rtlCol="0" anchor="ctr"/>
           <a:lstStyle/>
           <a:p>
-            <a:pPr indent="0" marL="0">
+            <a:pPr marL="0" indent="0">
               <a:lnSpc>
                 <a:spcPct val="110000"/>
               </a:lnSpc>
@@ -2415,7 +2240,7 @@
             <a:endParaRPr lang="en-US" sz="1050" dirty="0"/>
           </a:p>
           <a:p>
-            <a:pPr indent="0" marL="0">
+            <a:pPr marL="0" indent="0">
               <a:lnSpc>
                 <a:spcPct val="110000"/>
               </a:lnSpc>
@@ -2462,6 +2287,13 @@
             <a:prstDash val="solid"/>
           </a:ln>
         </p:spPr>
+        <p:txBody>
+          <a:bodyPr/>
+          <a:lstStyle/>
+          <a:p>
+            <a:endParaRPr lang="en-ID"/>
+          </a:p>
+        </p:txBody>
       </p:sp>
       <p:sp>
         <p:nvSpPr>
@@ -2484,7 +2316,7 @@
           <a:bodyPr wrap="square" lIns="0" tIns="0" rIns="0" bIns="0" rtlCol="0" anchor="ctr"/>
           <a:lstStyle/>
           <a:p>
-            <a:pPr indent="0" marL="0">
+            <a:pPr marL="0" indent="0">
               <a:lnSpc>
                 <a:spcPct val="110000"/>
               </a:lnSpc>
@@ -2504,7 +2336,7 @@
             <a:endParaRPr lang="en-US" sz="1050" dirty="0"/>
           </a:p>
           <a:p>
-            <a:pPr indent="0" marL="0">
+            <a:pPr marL="0" indent="0">
               <a:lnSpc>
                 <a:spcPct val="110000"/>
               </a:lnSpc>
@@ -2551,6 +2383,13 @@
             <a:prstDash val="solid"/>
           </a:ln>
         </p:spPr>
+        <p:txBody>
+          <a:bodyPr/>
+          <a:lstStyle/>
+          <a:p>
+            <a:endParaRPr lang="en-ID"/>
+          </a:p>
+        </p:txBody>
       </p:sp>
       <p:sp>
         <p:nvSpPr>
@@ -2573,7 +2412,7 @@
           <a:bodyPr wrap="square" lIns="0" tIns="0" rIns="0" bIns="0" rtlCol="0" anchor="ctr"/>
           <a:lstStyle/>
           <a:p>
-            <a:pPr indent="0" marL="0">
+            <a:pPr marL="0" indent="0">
               <a:lnSpc>
                 <a:spcPct val="110000"/>
               </a:lnSpc>
@@ -2593,7 +2432,7 @@
             <a:endParaRPr lang="en-US" sz="1050" dirty="0"/>
           </a:p>
           <a:p>
-            <a:pPr indent="0" marL="0">
+            <a:pPr marL="0" indent="0">
               <a:lnSpc>
                 <a:spcPct val="110000"/>
               </a:lnSpc>
@@ -2640,6 +2479,13 @@
             <a:prstDash val="solid"/>
           </a:ln>
         </p:spPr>
+        <p:txBody>
+          <a:bodyPr/>
+          <a:lstStyle/>
+          <a:p>
+            <a:endParaRPr lang="en-ID"/>
+          </a:p>
+        </p:txBody>
       </p:sp>
       <p:sp>
         <p:nvSpPr>
@@ -2662,7 +2508,7 @@
           <a:bodyPr wrap="square" lIns="0" tIns="0" rIns="0" bIns="0" rtlCol="0" anchor="ctr"/>
           <a:lstStyle/>
           <a:p>
-            <a:pPr indent="0" marL="0">
+            <a:pPr marL="0" indent="0">
               <a:lnSpc>
                 <a:spcPct val="125000"/>
               </a:lnSpc>
@@ -2679,12 +2525,6 @@
               </a:rPr>
               <a:t>◆  YANG KAMU BUTUHKAN  </a:t>
             </a:r>
-            <a:pPr indent="0" marL="0">
-              <a:lnSpc>
-                <a:spcPct val="125000"/>
-              </a:lnSpc>
-              <a:buNone/>
-            </a:pPr>
             <a:r>
               <a:rPr lang="en-US" sz="1250" dirty="0">
                 <a:solidFill>
@@ -2744,6 +2584,13 @@
           </a:solidFill>
           <a:ln/>
         </p:spPr>
+        <p:txBody>
+          <a:bodyPr/>
+          <a:lstStyle/>
+          <a:p>
+            <a:endParaRPr lang="en-ID"/>
+          </a:p>
+        </p:txBody>
       </p:sp>
       <p:sp>
         <p:nvSpPr>
@@ -2764,6 +2611,13 @@
           </a:solidFill>
           <a:ln/>
         </p:spPr>
+        <p:txBody>
+          <a:bodyPr/>
+          <a:lstStyle/>
+          <a:p>
+            <a:endParaRPr lang="en-ID"/>
+          </a:p>
+        </p:txBody>
       </p:sp>
       <p:sp>
         <p:nvSpPr>
@@ -2786,7 +2640,7 @@
           <a:bodyPr wrap="square" lIns="0" tIns="0" rIns="0" bIns="0" rtlCol="0" anchor="ctr"/>
           <a:lstStyle/>
           <a:p>
-            <a:pPr indent="0" marL="0">
+            <a:pPr marL="0" indent="0">
               <a:buNone/>
             </a:pPr>
             <a:r>
@@ -2800,9 +2654,6 @@
               </a:rPr>
               <a:t>belajar</a:t>
             </a:r>
-            <a:pPr indent="0" marL="0">
-              <a:buNone/>
-            </a:pPr>
             <a:r>
               <a:rPr lang="en-US" sz="2000" b="1" dirty="0">
                 <a:solidFill>
@@ -2839,7 +2690,7 @@
           <a:bodyPr wrap="square" lIns="0" tIns="0" rIns="0" bIns="0" rtlCol="0" anchor="ctr"/>
           <a:lstStyle/>
           <a:p>
-            <a:pPr algn="r" indent="0" marL="0">
+            <a:pPr marL="0" indent="0" algn="r">
               <a:buNone/>
             </a:pPr>
             <a:r>
@@ -2878,11 +2729,11 @@
           <a:bodyPr wrap="square" lIns="0" tIns="0" rIns="0" bIns="0" rtlCol="0" anchor="ctr"/>
           <a:lstStyle/>
           <a:p>
-            <a:pPr indent="0" marL="0">
-              <a:buNone/>
-            </a:pPr>
-            <a:r>
-              <a:rPr lang="en-US" sz="1250" b="1" spc="40" kern="0" dirty="0">
+            <a:pPr marL="0" indent="0">
+              <a:buNone/>
+            </a:pPr>
+            <a:r>
+              <a:rPr lang="en-US" sz="1250" b="1" kern="0" spc="40" dirty="0">
                 <a:solidFill>
                   <a:srgbClr val="4B36C7"/>
                 </a:solidFill>
@@ -2917,7 +2768,7 @@
           <a:bodyPr wrap="square" lIns="0" tIns="0" rIns="0" bIns="0" rtlCol="0" anchor="ctr"/>
           <a:lstStyle/>
           <a:p>
-            <a:pPr indent="0" marL="0">
+            <a:pPr marL="0" indent="0">
               <a:buNone/>
             </a:pPr>
             <a:r>
@@ -2961,6 +2812,13 @@
             <a:prstDash val="solid"/>
           </a:ln>
         </p:spPr>
+        <p:txBody>
+          <a:bodyPr/>
+          <a:lstStyle/>
+          <a:p>
+            <a:endParaRPr lang="en-ID"/>
+          </a:p>
+        </p:txBody>
       </p:sp>
       <p:sp>
         <p:nvSpPr>
@@ -2983,7 +2841,7 @@
           <a:bodyPr wrap="square" lIns="0" tIns="0" rIns="0" bIns="0" rtlCol="0" anchor="ctr"/>
           <a:lstStyle/>
           <a:p>
-            <a:pPr indent="0" marL="0">
+            <a:pPr marL="0" indent="0">
               <a:buNone/>
             </a:pPr>
             <a:r>
@@ -3022,7 +2880,7 @@
           <a:bodyPr wrap="square" lIns="0" tIns="0" rIns="0" bIns="0" rtlCol="0" anchor="ctr"/>
           <a:lstStyle/>
           <a:p>
-            <a:pPr indent="0" marL="0">
+            <a:pPr marL="0" indent="0">
               <a:lnSpc>
                 <a:spcPct val="130000"/>
               </a:lnSpc>
@@ -3064,7 +2922,7 @@
           <a:bodyPr wrap="square" lIns="0" tIns="0" rIns="0" bIns="0" rtlCol="0" anchor="ctr"/>
           <a:lstStyle/>
           <a:p>
-            <a:pPr indent="0" marL="0">
+            <a:pPr marL="0" indent="0">
               <a:lnSpc>
                 <a:spcPct val="125000"/>
               </a:lnSpc>
@@ -3111,6 +2969,13 @@
             <a:prstDash val="solid"/>
           </a:ln>
         </p:spPr>
+        <p:txBody>
+          <a:bodyPr/>
+          <a:lstStyle/>
+          <a:p>
+            <a:endParaRPr lang="en-ID"/>
+          </a:p>
+        </p:txBody>
       </p:sp>
       <p:sp>
         <p:nvSpPr>
@@ -3133,7 +2998,7 @@
           <a:bodyPr wrap="square" lIns="0" tIns="0" rIns="0" bIns="0" rtlCol="0" anchor="ctr"/>
           <a:lstStyle/>
           <a:p>
-            <a:pPr indent="0" marL="0">
+            <a:pPr marL="0" indent="0">
               <a:buNone/>
             </a:pPr>
             <a:r>
@@ -3172,7 +3037,7 @@
           <a:bodyPr wrap="square" lIns="0" tIns="0" rIns="0" bIns="0" rtlCol="0" anchor="ctr"/>
           <a:lstStyle/>
           <a:p>
-            <a:pPr indent="0" marL="0">
+            <a:pPr marL="0" indent="0">
               <a:lnSpc>
                 <a:spcPct val="125000"/>
               </a:lnSpc>
@@ -3214,7 +3079,7 @@
           <a:bodyPr wrap="square" lIns="0" tIns="0" rIns="0" bIns="0" rtlCol="0" anchor="ctr"/>
           <a:lstStyle/>
           <a:p>
-            <a:pPr indent="0" marL="0">
+            <a:pPr marL="0" indent="0">
               <a:lnSpc>
                 <a:spcPct val="125000"/>
               </a:lnSpc>
@@ -3279,6 +3144,13 @@
           </a:solidFill>
           <a:ln/>
         </p:spPr>
+        <p:txBody>
+          <a:bodyPr/>
+          <a:lstStyle/>
+          <a:p>
+            <a:endParaRPr lang="en-ID"/>
+          </a:p>
+        </p:txBody>
       </p:sp>
       <p:sp>
         <p:nvSpPr>
@@ -3299,6 +3171,13 @@
           </a:solidFill>
           <a:ln/>
         </p:spPr>
+        <p:txBody>
+          <a:bodyPr/>
+          <a:lstStyle/>
+          <a:p>
+            <a:endParaRPr lang="en-ID"/>
+          </a:p>
+        </p:txBody>
       </p:sp>
       <p:sp>
         <p:nvSpPr>
@@ -3321,7 +3200,7 @@
           <a:bodyPr wrap="square" lIns="0" tIns="0" rIns="0" bIns="0" rtlCol="0" anchor="ctr"/>
           <a:lstStyle/>
           <a:p>
-            <a:pPr indent="0" marL="0">
+            <a:pPr marL="0" indent="0">
               <a:buNone/>
             </a:pPr>
             <a:r>
@@ -3335,9 +3214,6 @@
               </a:rPr>
               <a:t>belajar</a:t>
             </a:r>
-            <a:pPr indent="0" marL="0">
-              <a:buNone/>
-            </a:pPr>
             <a:r>
               <a:rPr lang="en-US" sz="2000" b="1" dirty="0">
                 <a:solidFill>
@@ -3374,7 +3250,7 @@
           <a:bodyPr wrap="square" lIns="0" tIns="0" rIns="0" bIns="0" rtlCol="0" anchor="ctr"/>
           <a:lstStyle/>
           <a:p>
-            <a:pPr algn="r" indent="0" marL="0">
+            <a:pPr marL="0" indent="0" algn="r">
               <a:buNone/>
             </a:pPr>
             <a:r>
@@ -3413,11 +3289,11 @@
           <a:bodyPr wrap="square" lIns="0" tIns="0" rIns="0" bIns="0" rtlCol="0" anchor="ctr"/>
           <a:lstStyle/>
           <a:p>
-            <a:pPr indent="0" marL="0">
-              <a:buNone/>
-            </a:pPr>
-            <a:r>
-              <a:rPr lang="en-US" sz="1250" b="1" spc="40" kern="0" dirty="0">
+            <a:pPr marL="0" indent="0">
+              <a:buNone/>
+            </a:pPr>
+            <a:r>
+              <a:rPr lang="en-US" sz="1250" b="1" kern="0" spc="40" dirty="0">
                 <a:solidFill>
                   <a:srgbClr val="4B36C7"/>
                 </a:solidFill>
@@ -3452,7 +3328,7 @@
           <a:bodyPr wrap="square" lIns="0" tIns="0" rIns="0" bIns="0" rtlCol="0" anchor="ctr"/>
           <a:lstStyle/>
           <a:p>
-            <a:pPr indent="0" marL="0">
+            <a:pPr marL="0" indent="0">
               <a:buNone/>
             </a:pPr>
             <a:r>
@@ -3489,6 +3365,13 @@
           </a:solidFill>
           <a:ln/>
         </p:spPr>
+        <p:txBody>
+          <a:bodyPr/>
+          <a:lstStyle/>
+          <a:p>
+            <a:endParaRPr lang="en-ID"/>
+          </a:p>
+        </p:txBody>
       </p:sp>
       <p:sp>
         <p:nvSpPr>
@@ -3511,7 +3394,7 @@
           <a:bodyPr wrap="square" lIns="0" tIns="0" rIns="0" bIns="0" rtlCol="0" anchor="ctr"/>
           <a:lstStyle/>
           <a:p>
-            <a:pPr algn="ctr" indent="0" marL="0">
+            <a:pPr marL="0" indent="0" algn="ctr">
               <a:buNone/>
             </a:pPr>
             <a:r>
@@ -3550,7 +3433,7 @@
           <a:bodyPr wrap="square" lIns="0" tIns="0" rIns="0" bIns="0" rtlCol="0" anchor="ctr"/>
           <a:lstStyle/>
           <a:p>
-            <a:pPr indent="0" marL="0">
+            <a:pPr marL="0" indent="0">
               <a:buNone/>
             </a:pPr>
             <a:r>
@@ -3564,9 +3447,6 @@
               </a:rPr>
               <a:t>Isi cm-data-produk.csv — </a:t>
             </a:r>
-            <a:pPr indent="0" marL="0">
-              <a:buNone/>
-            </a:pPr>
             <a:r>
               <a:rPr lang="en-US" sz="1300" dirty="0">
                 <a:solidFill>
@@ -3601,6 +3481,13 @@
           </a:solidFill>
           <a:ln/>
         </p:spPr>
+        <p:txBody>
+          <a:bodyPr/>
+          <a:lstStyle/>
+          <a:p>
+            <a:endParaRPr lang="en-ID"/>
+          </a:p>
+        </p:txBody>
       </p:sp>
       <p:sp>
         <p:nvSpPr>
@@ -3623,7 +3510,7 @@
           <a:bodyPr wrap="square" lIns="0" tIns="0" rIns="0" bIns="0" rtlCol="0" anchor="ctr"/>
           <a:lstStyle/>
           <a:p>
-            <a:pPr algn="ctr" indent="0" marL="0">
+            <a:pPr marL="0" indent="0" algn="ctr">
               <a:buNone/>
             </a:pPr>
             <a:r>
@@ -3662,7 +3549,7 @@
           <a:bodyPr wrap="square" lIns="0" tIns="0" rIns="0" bIns="0" rtlCol="0" anchor="ctr"/>
           <a:lstStyle/>
           <a:p>
-            <a:pPr indent="0" marL="0">
+            <a:pPr marL="0" indent="0">
               <a:buNone/>
             </a:pPr>
             <a:r>
@@ -3676,9 +3563,6 @@
               </a:rPr>
               <a:t>Upload ke Project Knowledge — </a:t>
             </a:r>
-            <a:pPr indent="0" marL="0">
-              <a:buNone/>
-            </a:pPr>
             <a:r>
               <a:rPr lang="en-US" sz="1300" dirty="0">
                 <a:solidFill>
@@ -3713,6 +3597,13 @@
           </a:solidFill>
           <a:ln/>
         </p:spPr>
+        <p:txBody>
+          <a:bodyPr/>
+          <a:lstStyle/>
+          <a:p>
+            <a:endParaRPr lang="en-ID"/>
+          </a:p>
+        </p:txBody>
       </p:sp>
       <p:sp>
         <p:nvSpPr>
@@ -3735,7 +3626,7 @@
           <a:bodyPr wrap="square" lIns="0" tIns="0" rIns="0" bIns="0" rtlCol="0" anchor="ctr"/>
           <a:lstStyle/>
           <a:p>
-            <a:pPr algn="ctr" indent="0" marL="0">
+            <a:pPr marL="0" indent="0" algn="ctr">
               <a:buNone/>
             </a:pPr>
             <a:r>
@@ -3774,7 +3665,7 @@
           <a:bodyPr wrap="square" lIns="0" tIns="0" rIns="0" bIns="0" rtlCol="0" anchor="ctr"/>
           <a:lstStyle/>
           <a:p>
-            <a:pPr indent="0" marL="0">
+            <a:pPr marL="0" indent="0">
               <a:buNone/>
             </a:pPr>
             <a:r>
@@ -3788,9 +3679,6 @@
               </a:rPr>
               <a:t>Generate Langsung — </a:t>
             </a:r>
-            <a:pPr indent="0" marL="0">
-              <a:buNone/>
-            </a:pPr>
             <a:r>
               <a:rPr lang="en-US" sz="1300" dirty="0">
                 <a:solidFill>
@@ -3825,6 +3713,13 @@
           </a:solidFill>
           <a:ln/>
         </p:spPr>
+        <p:txBody>
+          <a:bodyPr/>
+          <a:lstStyle/>
+          <a:p>
+            <a:endParaRPr lang="en-ID"/>
+          </a:p>
+        </p:txBody>
       </p:sp>
       <p:sp>
         <p:nvSpPr>
@@ -3847,7 +3742,7 @@
           <a:bodyPr wrap="square" lIns="0" tIns="0" rIns="0" bIns="0" rtlCol="0" anchor="ctr"/>
           <a:lstStyle/>
           <a:p>
-            <a:pPr algn="ctr" indent="0" marL="0">
+            <a:pPr marL="0" indent="0" algn="ctr">
               <a:buNone/>
             </a:pPr>
             <a:r>
@@ -3886,7 +3781,7 @@
           <a:bodyPr wrap="square" lIns="0" tIns="0" rIns="0" bIns="0" rtlCol="0" anchor="ctr"/>
           <a:lstStyle/>
           <a:p>
-            <a:pPr indent="0" marL="0">
+            <a:pPr marL="0" indent="0">
               <a:buNone/>
             </a:pPr>
             <a:r>
@@ -3900,9 +3795,6 @@
               </a:rPr>
               <a:t>Review Tiap Deskripsi — </a:t>
             </a:r>
-            <a:pPr indent="0" marL="0">
-              <a:buNone/>
-            </a:pPr>
             <a:r>
               <a:rPr lang="en-US" sz="1300" dirty="0">
                 <a:solidFill>
@@ -3937,6 +3829,13 @@
           </a:solidFill>
           <a:ln/>
         </p:spPr>
+        <p:txBody>
+          <a:bodyPr/>
+          <a:lstStyle/>
+          <a:p>
+            <a:endParaRPr lang="en-ID"/>
+          </a:p>
+        </p:txBody>
       </p:sp>
       <p:sp>
         <p:nvSpPr>
@@ -3959,7 +3858,7 @@
           <a:bodyPr wrap="square" lIns="0" tIns="0" rIns="0" bIns="0" rtlCol="0" anchor="ctr"/>
           <a:lstStyle/>
           <a:p>
-            <a:pPr algn="ctr" indent="0" marL="0">
+            <a:pPr marL="0" indent="0" algn="ctr">
               <a:buNone/>
             </a:pPr>
             <a:r>
@@ -3998,7 +3897,7 @@
           <a:bodyPr wrap="square" lIns="0" tIns="0" rIns="0" bIns="0" rtlCol="0" anchor="ctr"/>
           <a:lstStyle/>
           <a:p>
-            <a:pPr indent="0" marL="0">
+            <a:pPr marL="0" indent="0">
               <a:buNone/>
             </a:pPr>
             <a:r>
@@ -4012,9 +3911,6 @@
               </a:rPr>
               <a:t>Paste &amp; Pantau — </a:t>
             </a:r>
-            <a:pPr indent="0" marL="0">
-              <a:buNone/>
-            </a:pPr>
             <a:r>
               <a:rPr lang="en-US" sz="1300" dirty="0">
                 <a:solidFill>
@@ -4056,6 +3952,13 @@
             <a:prstDash val="solid"/>
           </a:ln>
         </p:spPr>
+        <p:txBody>
+          <a:bodyPr/>
+          <a:lstStyle/>
+          <a:p>
+            <a:endParaRPr lang="en-ID"/>
+          </a:p>
+        </p:txBody>
       </p:sp>
       <p:sp>
         <p:nvSpPr>
@@ -4078,7 +3981,7 @@
           <a:bodyPr wrap="square" lIns="0" tIns="0" rIns="0" bIns="0" rtlCol="0" anchor="ctr"/>
           <a:lstStyle/>
           <a:p>
-            <a:pPr indent="0" marL="0">
+            <a:pPr marL="0" indent="0">
               <a:lnSpc>
                 <a:spcPct val="120000"/>
               </a:lnSpc>
@@ -4095,12 +3998,6 @@
               </a:rPr>
               <a:t>◆  KENAPA SATU PROMPT SAJA CUKUP?  </a:t>
             </a:r>
-            <a:pPr indent="0" marL="0">
-              <a:lnSpc>
-                <a:spcPct val="120000"/>
-              </a:lnSpc>
-              <a:buNone/>
-            </a:pPr>
             <a:r>
               <a:rPr lang="en-US" sz="1250" dirty="0">
                 <a:solidFill>
@@ -4160,6 +4057,13 @@
           </a:solidFill>
           <a:ln/>
         </p:spPr>
+        <p:txBody>
+          <a:bodyPr/>
+          <a:lstStyle/>
+          <a:p>
+            <a:endParaRPr lang="en-ID"/>
+          </a:p>
+        </p:txBody>
       </p:sp>
       <p:sp>
         <p:nvSpPr>
@@ -4180,6 +4084,13 @@
           </a:solidFill>
           <a:ln/>
         </p:spPr>
+        <p:txBody>
+          <a:bodyPr/>
+          <a:lstStyle/>
+          <a:p>
+            <a:endParaRPr lang="en-ID"/>
+          </a:p>
+        </p:txBody>
       </p:sp>
       <p:sp>
         <p:nvSpPr>
@@ -4202,7 +4113,7 @@
           <a:bodyPr wrap="square" lIns="0" tIns="0" rIns="0" bIns="0" rtlCol="0" anchor="ctr"/>
           <a:lstStyle/>
           <a:p>
-            <a:pPr indent="0" marL="0">
+            <a:pPr marL="0" indent="0">
               <a:buNone/>
             </a:pPr>
             <a:r>
@@ -4216,9 +4127,6 @@
               </a:rPr>
               <a:t>belajar</a:t>
             </a:r>
-            <a:pPr indent="0" marL="0">
-              <a:buNone/>
-            </a:pPr>
             <a:r>
               <a:rPr lang="en-US" sz="2000" b="1" dirty="0">
                 <a:solidFill>
@@ -4255,7 +4163,7 @@
           <a:bodyPr wrap="square" lIns="0" tIns="0" rIns="0" bIns="0" rtlCol="0" anchor="ctr"/>
           <a:lstStyle/>
           <a:p>
-            <a:pPr algn="r" indent="0" marL="0">
+            <a:pPr marL="0" indent="0" algn="r">
               <a:buNone/>
             </a:pPr>
             <a:r>
@@ -4294,11 +4202,11 @@
           <a:bodyPr wrap="square" lIns="0" tIns="0" rIns="0" bIns="0" rtlCol="0" anchor="ctr"/>
           <a:lstStyle/>
           <a:p>
-            <a:pPr indent="0" marL="0">
-              <a:buNone/>
-            </a:pPr>
-            <a:r>
-              <a:rPr lang="en-US" sz="1250" b="1" spc="40" kern="0" dirty="0">
+            <a:pPr marL="0" indent="0">
+              <a:buNone/>
+            </a:pPr>
+            <a:r>
+              <a:rPr lang="en-US" sz="1250" b="1" kern="0" spc="40" dirty="0">
                 <a:solidFill>
                   <a:srgbClr val="4B36C7"/>
                 </a:solidFill>
@@ -4333,7 +4241,7 @@
           <a:bodyPr wrap="square" lIns="0" tIns="0" rIns="0" bIns="0" rtlCol="0" anchor="ctr"/>
           <a:lstStyle/>
           <a:p>
-            <a:pPr indent="0" marL="0">
+            <a:pPr marL="0" indent="0">
               <a:buNone/>
             </a:pPr>
             <a:r>
@@ -4377,6 +4285,13 @@
             <a:prstDash val="solid"/>
           </a:ln>
         </p:spPr>
+        <p:txBody>
+          <a:bodyPr/>
+          <a:lstStyle/>
+          <a:p>
+            <a:endParaRPr lang="en-ID"/>
+          </a:p>
+        </p:txBody>
       </p:sp>
       <p:sp>
         <p:nvSpPr>
@@ -4399,7 +4314,7 @@
           <a:bodyPr wrap="square" lIns="0" tIns="0" rIns="0" bIns="0" rtlCol="0" anchor="ctr"/>
           <a:lstStyle/>
           <a:p>
-            <a:pPr indent="0" marL="0">
+            <a:pPr marL="0" indent="0">
               <a:buNone/>
             </a:pPr>
             <a:r>
@@ -4438,7 +4353,7 @@
           <a:bodyPr wrap="square" lIns="0" tIns="0" rIns="0" bIns="0" rtlCol="0" anchor="ctr"/>
           <a:lstStyle/>
           <a:p>
-            <a:pPr indent="0" marL="0">
+            <a:pPr marL="0" indent="0">
               <a:lnSpc>
                 <a:spcPct val="125000"/>
               </a:lnSpc>
@@ -4485,6 +4400,13 @@
             <a:prstDash val="solid"/>
           </a:ln>
         </p:spPr>
+        <p:txBody>
+          <a:bodyPr/>
+          <a:lstStyle/>
+          <a:p>
+            <a:endParaRPr lang="en-ID"/>
+          </a:p>
+        </p:txBody>
       </p:sp>
       <p:sp>
         <p:nvSpPr>
@@ -4507,7 +4429,7 @@
           <a:bodyPr wrap="square" lIns="0" tIns="0" rIns="0" bIns="0" rtlCol="0" anchor="ctr"/>
           <a:lstStyle/>
           <a:p>
-            <a:pPr indent="0" marL="0">
+            <a:pPr marL="0" indent="0">
               <a:lnSpc>
                 <a:spcPct val="120000"/>
               </a:lnSpc>
@@ -4522,7 +4444,51 @@
                 <a:ea typeface="Helvetica" pitchFamily="34" charset="-122"/>
                 <a:cs typeface="Helvetica" pitchFamily="34" charset="-120"/>
               </a:rPr>
-              <a:t>[Project ini sudah punya positioning dan data produk] Buatkan deskripsi Tokopedia untuk tiap produk: hook 2 kalimat, keyword, benefit, spesifikasi, CTA. Maks 200 kata per produk.</a:t>
+              <a:t>“</a:t>
+            </a:r>
+            <a:r>
+              <a:rPr lang="en-US" sz="1050" i="1" dirty="0" err="1">
+                <a:solidFill>
+                  <a:srgbClr val="1A7A44"/>
+                </a:solidFill>
+                <a:latin typeface="Helvetica" pitchFamily="34" charset="0"/>
+                <a:ea typeface="Helvetica" pitchFamily="34" charset="-122"/>
+                <a:cs typeface="Helvetica" pitchFamily="34" charset="-120"/>
+              </a:rPr>
+              <a:t>Buatkan</a:t>
+            </a:r>
+            <a:r>
+              <a:rPr lang="en-US" sz="1050" i="1" dirty="0">
+                <a:solidFill>
+                  <a:srgbClr val="1A7A44"/>
+                </a:solidFill>
+                <a:latin typeface="Helvetica" pitchFamily="34" charset="0"/>
+                <a:ea typeface="Helvetica" pitchFamily="34" charset="-122"/>
+                <a:cs typeface="Helvetica" pitchFamily="34" charset="-120"/>
+              </a:rPr>
+              <a:t> deskripsi Tokopedia untuk tiap produk: hook 2 kalimat, keyword, benefit, spesifikasi, CTA. Maks 200 kata per </a:t>
+            </a:r>
+            <a:r>
+              <a:rPr lang="en-US" sz="1050" i="1" dirty="0" err="1">
+                <a:solidFill>
+                  <a:srgbClr val="1A7A44"/>
+                </a:solidFill>
+                <a:latin typeface="Helvetica" pitchFamily="34" charset="0"/>
+                <a:ea typeface="Helvetica" pitchFamily="34" charset="-122"/>
+                <a:cs typeface="Helvetica" pitchFamily="34" charset="-120"/>
+              </a:rPr>
+              <a:t>produk</a:t>
+            </a:r>
+            <a:r>
+              <a:rPr lang="en-US" sz="1050" i="1" dirty="0">
+                <a:solidFill>
+                  <a:srgbClr val="1A7A44"/>
+                </a:solidFill>
+                <a:latin typeface="Helvetica" pitchFamily="34" charset="0"/>
+                <a:ea typeface="Helvetica" pitchFamily="34" charset="-122"/>
+                <a:cs typeface="Helvetica" pitchFamily="34" charset="-120"/>
+              </a:rPr>
+              <a:t>”</a:t>
             </a:r>
             <a:endParaRPr lang="en-US" sz="1050" dirty="0"/>
           </a:p>
@@ -4549,6 +4515,13 @@
           </a:solidFill>
           <a:ln/>
         </p:spPr>
+        <p:txBody>
+          <a:bodyPr/>
+          <a:lstStyle/>
+          <a:p>
+            <a:endParaRPr lang="en-ID"/>
+          </a:p>
+        </p:txBody>
       </p:sp>
       <p:sp>
         <p:nvSpPr>
@@ -4571,7 +4544,7 @@
           <a:bodyPr wrap="square" lIns="0" tIns="0" rIns="0" bIns="0" rtlCol="0" anchor="ctr"/>
           <a:lstStyle/>
           <a:p>
-            <a:pPr indent="0" marL="0">
+            <a:pPr marL="0" indent="0">
               <a:buNone/>
             </a:pPr>
             <a:r>
@@ -4610,7 +4583,7 @@
           <a:bodyPr wrap="square" lIns="0" tIns="0" rIns="0" bIns="0" rtlCol="0" anchor="ctr"/>
           <a:lstStyle/>
           <a:p>
-            <a:pPr indent="0" marL="0">
+            <a:pPr marL="0" indent="0">
               <a:lnSpc>
                 <a:spcPct val="130000"/>
               </a:lnSpc>
@@ -4630,7 +4603,7 @@
             <a:endParaRPr lang="en-US" sz="1250" dirty="0"/>
           </a:p>
           <a:p>
-            <a:pPr indent="0" marL="0">
+            <a:pPr marL="0" indent="0">
               <a:lnSpc>
                 <a:spcPct val="130000"/>
               </a:lnSpc>
@@ -4952,4 +4925,319 @@
     </a:ext>
   </a:extLst>
 </a:theme>
+</file>
+
+<file path=ppt/theme/theme2.xml><?xml version="1.0" encoding="utf-8"?>
+<a:theme xmlns:a="http://schemas.openxmlformats.org/drawingml/2006/main" name="Office Theme">
+  <a:themeElements>
+    <a:clrScheme name="Office">
+      <a:dk1>
+        <a:sysClr val="windowText" lastClr="000000"/>
+      </a:dk1>
+      <a:lt1>
+        <a:sysClr val="window" lastClr="FFFFFF"/>
+      </a:lt1>
+      <a:dk2>
+        <a:srgbClr val="0E2841"/>
+      </a:dk2>
+      <a:lt2>
+        <a:srgbClr val="E8E8E8"/>
+      </a:lt2>
+      <a:accent1>
+        <a:srgbClr val="156082"/>
+      </a:accent1>
+      <a:accent2>
+        <a:srgbClr val="E97132"/>
+      </a:accent2>
+      <a:accent3>
+        <a:srgbClr val="196B24"/>
+      </a:accent3>
+      <a:accent4>
+        <a:srgbClr val="0F9ED5"/>
+      </a:accent4>
+      <a:accent5>
+        <a:srgbClr val="A02B93"/>
+      </a:accent5>
+      <a:accent6>
+        <a:srgbClr val="4EA72E"/>
+      </a:accent6>
+      <a:hlink>
+        <a:srgbClr val="467886"/>
+      </a:hlink>
+      <a:folHlink>
+        <a:srgbClr val="96607D"/>
+      </a:folHlink>
+    </a:clrScheme>
+    <a:fontScheme name="Office">
+      <a:majorFont>
+        <a:latin typeface="Aptos Display" panose="02110004020202020204"/>
+        <a:ea typeface=""/>
+        <a:cs typeface=""/>
+        <a:font script="Jpan" typeface="游ゴシック Light"/>
+        <a:font script="Hang" typeface="맑은 고딕"/>
+        <a:font script="Hans" typeface="等线 Light"/>
+        <a:font script="Hant" typeface="新細明體"/>
+        <a:font script="Arab" typeface="Times New Roman"/>
+        <a:font script="Hebr" typeface="Times New Roman"/>
+        <a:font script="Thai" typeface="Angsana New"/>
+        <a:font script="Ethi" typeface="Nyala"/>
+        <a:font script="Beng" typeface="Vrinda"/>
+        <a:font script="Gujr" typeface="Shruti"/>
+        <a:font script="Khmr" typeface="MoolBoran"/>
+        <a:font script="Knda" typeface="Tunga"/>
+        <a:font script="Guru" typeface="Raavi"/>
+        <a:font script="Cans" typeface="Euphemia"/>
+        <a:font script="Cher" typeface="Plantagenet Cherokee"/>
+        <a:font script="Yiii" typeface="Microsoft Yi Baiti"/>
+        <a:font script="Tibt" typeface="Microsoft Himalaya"/>
+        <a:font script="Thaa" typeface="MV Boli"/>
+        <a:font script="Deva" typeface="Mangal"/>
+        <a:font script="Telu" typeface="Gautami"/>
+        <a:font script="Taml" typeface="Latha"/>
+        <a:font script="Syrc" typeface="Estrangelo Edessa"/>
+        <a:font script="Orya" typeface="Kalinga"/>
+        <a:font script="Mlym" typeface="Kartika"/>
+        <a:font script="Laoo" typeface="DokChampa"/>
+        <a:font script="Sinh" typeface="Iskoola Pota"/>
+        <a:font script="Mong" typeface="Mongolian Baiti"/>
+        <a:font script="Viet" typeface="Times New Roman"/>
+        <a:font script="Uigh" typeface="Microsoft Uighur"/>
+        <a:font script="Geor" typeface="Sylfaen"/>
+        <a:font script="Armn" typeface="Arial"/>
+        <a:font script="Bugi" typeface="Leelawadee UI"/>
+        <a:font script="Bopo" typeface="Microsoft JhengHei"/>
+        <a:font script="Java" typeface="Javanese Text"/>
+        <a:font script="Lisu" typeface="Segoe UI"/>
+        <a:font script="Mymr" typeface="Myanmar Text"/>
+        <a:font script="Nkoo" typeface="Ebrima"/>
+        <a:font script="Olck" typeface="Nirmala UI"/>
+        <a:font script="Osma" typeface="Ebrima"/>
+        <a:font script="Phag" typeface="Phagspa"/>
+        <a:font script="Syrn" typeface="Estrangelo Edessa"/>
+        <a:font script="Syrj" typeface="Estrangelo Edessa"/>
+        <a:font script="Syre" typeface="Estrangelo Edessa"/>
+        <a:font script="Sora" typeface="Nirmala UI"/>
+        <a:font script="Tale" typeface="Microsoft Tai Le"/>
+        <a:font script="Talu" typeface="Microsoft New Tai Lue"/>
+        <a:font script="Tfng" typeface="Ebrima"/>
+      </a:majorFont>
+      <a:minorFont>
+        <a:latin typeface="Aptos" panose="02110004020202020204"/>
+        <a:ea typeface=""/>
+        <a:cs typeface=""/>
+        <a:font script="Jpan" typeface="游ゴシック"/>
+        <a:font script="Hang" typeface="맑은 고딕"/>
+        <a:font script="Hans" typeface="等线"/>
+        <a:font script="Hant" typeface="新細明體"/>
+        <a:font script="Arab" typeface="Arial"/>
+        <a:font script="Hebr" typeface="Arial"/>
+        <a:font script="Thai" typeface="Cordia New"/>
+        <a:font script="Ethi" typeface="Nyala"/>
+        <a:font script="Beng" typeface="Vrinda"/>
+        <a:font script="Gujr" typeface="Shruti"/>
+        <a:font script="Khmr" typeface="DaunPenh"/>
+        <a:font script="Knda" typeface="Tunga"/>
+        <a:font script="Guru" typeface="Raavi"/>
+        <a:font script="Cans" typeface="Euphemia"/>
+        <a:font script="Cher" typeface="Plantagenet Cherokee"/>
+        <a:font script="Yiii" typeface="Microsoft Yi Baiti"/>
+        <a:font script="Tibt" typeface="Microsoft Himalaya"/>
+        <a:font script="Thaa" typeface="MV Boli"/>
+        <a:font script="Deva" typeface="Mangal"/>
+        <a:font script="Telu" typeface="Gautami"/>
+        <a:font script="Taml" typeface="Latha"/>
+        <a:font script="Syrc" typeface="Estrangelo Edessa"/>
+        <a:font script="Orya" typeface="Kalinga"/>
+        <a:font script="Mlym" typeface="Kartika"/>
+        <a:font script="Laoo" typeface="DokChampa"/>
+        <a:font script="Sinh" typeface="Iskoola Pota"/>
+        <a:font script="Mong" typeface="Mongolian Baiti"/>
+        <a:font script="Viet" typeface="Arial"/>
+        <a:font script="Uigh" typeface="Microsoft Uighur"/>
+        <a:font script="Geor" typeface="Sylfaen"/>
+        <a:font script="Armn" typeface="Arial"/>
+        <a:font script="Bugi" typeface="Leelawadee UI"/>
+        <a:font script="Bopo" typeface="Microsoft JhengHei"/>
+        <a:font script="Java" typeface="Javanese Text"/>
+        <a:font script="Lisu" typeface="Segoe UI"/>
+        <a:font script="Mymr" typeface="Myanmar Text"/>
+        <a:font script="Nkoo" typeface="Ebrima"/>
+        <a:font script="Olck" typeface="Nirmala UI"/>
+        <a:font script="Osma" typeface="Ebrima"/>
+        <a:font script="Phag" typeface="Phagspa"/>
+        <a:font script="Syrn" typeface="Estrangelo Edessa"/>
+        <a:font script="Syrj" typeface="Estrangelo Edessa"/>
+        <a:font script="Syre" typeface="Estrangelo Edessa"/>
+        <a:font script="Sora" typeface="Nirmala UI"/>
+        <a:font script="Tale" typeface="Microsoft Tai Le"/>
+        <a:font script="Talu" typeface="Microsoft New Tai Lue"/>
+        <a:font script="Tfng" typeface="Ebrima"/>
+      </a:minorFont>
+    </a:fontScheme>
+    <a:fmtScheme name="Office">
+      <a:fillStyleLst>
+        <a:solidFill>
+          <a:schemeClr val="phClr"/>
+        </a:solidFill>
+        <a:gradFill rotWithShape="1">
+          <a:gsLst>
+            <a:gs pos="0">
+              <a:schemeClr val="phClr">
+                <a:lumMod val="110000"/>
+                <a:satMod val="105000"/>
+                <a:tint val="67000"/>
+              </a:schemeClr>
+            </a:gs>
+            <a:gs pos="50000">
+              <a:schemeClr val="phClr">
+                <a:lumMod val="105000"/>
+                <a:satMod val="103000"/>
+                <a:tint val="73000"/>
+              </a:schemeClr>
+            </a:gs>
+            <a:gs pos="100000">
+              <a:schemeClr val="phClr">
+                <a:lumMod val="105000"/>
+                <a:satMod val="109000"/>
+                <a:tint val="81000"/>
+              </a:schemeClr>
+            </a:gs>
+          </a:gsLst>
+          <a:lin ang="5400000" scaled="0"/>
+        </a:gradFill>
+        <a:gradFill rotWithShape="1">
+          <a:gsLst>
+            <a:gs pos="0">
+              <a:schemeClr val="phClr">
+                <a:satMod val="103000"/>
+                <a:lumMod val="102000"/>
+                <a:tint val="94000"/>
+              </a:schemeClr>
+            </a:gs>
+            <a:gs pos="50000">
+              <a:schemeClr val="phClr">
+                <a:satMod val="110000"/>
+                <a:lumMod val="100000"/>
+                <a:shade val="100000"/>
+              </a:schemeClr>
+            </a:gs>
+            <a:gs pos="100000">
+              <a:schemeClr val="phClr">
+                <a:lumMod val="99000"/>
+                <a:satMod val="120000"/>
+                <a:shade val="78000"/>
+              </a:schemeClr>
+            </a:gs>
+          </a:gsLst>
+          <a:lin ang="5400000" scaled="0"/>
+        </a:gradFill>
+      </a:fillStyleLst>
+      <a:lnStyleLst>
+        <a:ln w="12700" cap="flat" cmpd="sng" algn="ctr">
+          <a:solidFill>
+            <a:schemeClr val="phClr"/>
+          </a:solidFill>
+          <a:prstDash val="solid"/>
+          <a:miter lim="800000"/>
+        </a:ln>
+        <a:ln w="19050" cap="flat" cmpd="sng" algn="ctr">
+          <a:solidFill>
+            <a:schemeClr val="phClr"/>
+          </a:solidFill>
+          <a:prstDash val="solid"/>
+          <a:miter lim="800000"/>
+        </a:ln>
+        <a:ln w="25400" cap="flat" cmpd="sng" algn="ctr">
+          <a:solidFill>
+            <a:schemeClr val="phClr"/>
+          </a:solidFill>
+          <a:prstDash val="solid"/>
+          <a:miter lim="800000"/>
+        </a:ln>
+      </a:lnStyleLst>
+      <a:effectStyleLst>
+        <a:effectStyle>
+          <a:effectLst/>
+        </a:effectStyle>
+        <a:effectStyle>
+          <a:effectLst/>
+        </a:effectStyle>
+        <a:effectStyle>
+          <a:effectLst>
+            <a:outerShdw blurRad="57150" dist="19050" dir="5400000" algn="ctr" rotWithShape="0">
+              <a:srgbClr val="000000">
+                <a:alpha val="63000"/>
+              </a:srgbClr>
+            </a:outerShdw>
+          </a:effectLst>
+        </a:effectStyle>
+      </a:effectStyleLst>
+      <a:bgFillStyleLst>
+        <a:solidFill>
+          <a:schemeClr val="phClr"/>
+        </a:solidFill>
+        <a:solidFill>
+          <a:schemeClr val="phClr">
+            <a:tint val="95000"/>
+            <a:satMod val="170000"/>
+          </a:schemeClr>
+        </a:solidFill>
+        <a:gradFill rotWithShape="1">
+          <a:gsLst>
+            <a:gs pos="0">
+              <a:schemeClr val="phClr">
+                <a:tint val="93000"/>
+                <a:satMod val="150000"/>
+                <a:shade val="98000"/>
+                <a:lumMod val="102000"/>
+              </a:schemeClr>
+            </a:gs>
+            <a:gs pos="50000">
+              <a:schemeClr val="phClr">
+                <a:tint val="98000"/>
+                <a:satMod val="130000"/>
+                <a:shade val="90000"/>
+                <a:lumMod val="103000"/>
+              </a:schemeClr>
+            </a:gs>
+            <a:gs pos="100000">
+              <a:schemeClr val="phClr">
+                <a:shade val="63000"/>
+                <a:satMod val="120000"/>
+              </a:schemeClr>
+            </a:gs>
+          </a:gsLst>
+          <a:lin ang="5400000" scaled="0"/>
+        </a:gradFill>
+      </a:bgFillStyleLst>
+    </a:fmtScheme>
+  </a:themeElements>
+  <a:objectDefaults>
+    <a:lnDef>
+      <a:spPr/>
+      <a:bodyPr/>
+      <a:lstStyle/>
+      <a:style>
+        <a:lnRef idx="2">
+          <a:schemeClr val="accent1"/>
+        </a:lnRef>
+        <a:fillRef idx="0">
+          <a:schemeClr val="accent1"/>
+        </a:fillRef>
+        <a:effectRef idx="1">
+          <a:schemeClr val="accent1"/>
+        </a:effectRef>
+        <a:fontRef idx="minor">
+          <a:schemeClr val="tx1"/>
+        </a:fontRef>
+      </a:style>
+    </a:lnDef>
+  </a:objectDefaults>
+  <a:extraClrSchemeLst/>
+  <a:extLst>
+    <a:ext uri="{05A4C25C-085E-4340-85A3-A5531E510DB2}">
+      <thm15:themeFamily xmlns:thm15="http://schemas.microsoft.com/office/thememl/2012/main" name="Office Theme" id="{2E142A2C-CD16-42D6-873A-C26D2A0506FA}" vid="{1BDDFF52-6CD6-40A5-AB3C-68EB2F1E4D0A}"/>
+    </a:ext>
+  </a:extLst>
+</a:theme>
 </file>
</xml_diff>

<commit_message>
M02: natural-complexity restructure (HTML + PPTX)
- Cara Kerja trimmed from forced 5 steps to natural 4
- Struktur Deskripsi Produk: card grid -> sequential anatomy flow (order matters: hook->keyword->spec->benefit->CTA)
- Kesalahan Umum: now a distinct red warning panel instead of a purple card grid identical to the anatomy section
- Yang Kamu Butuhkan moved to slide 3 footer to make room
- Cover slide: dropped the '-- X menit' duration text
- PPTX rebuilt from scratch to match
</commit_message>
<xml_diff>
--- a/Content-Marketing/M02-Deskripsi-Produk/K3-M02-Deskripsi-Produk.pptx
+++ b/Content-Marketing/M02-Deskripsi-Produk/K3-M02-Deskripsi-Produk.pptx
@@ -4,9 +4,6 @@
   <p:sldMasterIdLst>
     <p:sldMasterId id="2147483648" r:id="rId1"/>
   </p:sldMasterIdLst>
-  <p:notesMasterIdLst>
-    <p:notesMasterId r:id="rId7"/>
-  </p:notesMasterIdLst>
   <p:sldIdLst>
     <p:sldId id="256" r:id="rId2"/>
     <p:sldId id="257" r:id="rId3"/>
@@ -14,8 +11,11 @@
     <p:sldId id="259" r:id="rId5"/>
     <p:sldId id="260" r:id="rId6"/>
   </p:sldIdLst>
-  <p:sldSz cx="12192000" cy="6858000"/>
-  <p:notesSz cx="6858000" cy="12192000"/>
+  <p:notesMasterIdLst>
+    <p:notesMasterId r:id="rId7"/>
+  </p:notesMasterIdLst>
+  <p:sldSz cx="12191695" cy="6858000"/>
+  <p:notesSz cx="6858000" cy="12191695"/>
   <p:defaultTextStyle>
     <a:lvl1pPr marL="0" algn="l" defTabSz="914400" rtl="0" eaLnBrk="1" latinLnBrk="0" hangingPunct="1">
       <a:defRPr sz="1800" kern="1200">
@@ -108,11 +108,6 @@
       </a:defRPr>
     </a:lvl9pPr>
   </p:defaultTextStyle>
-  <p:extLst>
-    <p:ext uri="{EFAFB233-063F-42B5-8137-9DF3F51BA10A}">
-      <p15:sldGuideLst xmlns:p15="http://schemas.microsoft.com/office/powerpoint/2012/main"/>
-    </p:ext>
-  </p:extLst>
 </p:presentation>
 </file>
 
@@ -138,10 +133,234 @@
           <a:chExt cx="0" cy="0"/>
         </a:xfrm>
       </p:grpSpPr>
+      <p:sp>
+        <p:nvSpPr>
+          <p:cNvPr id="2" name="Header Placeholder 1"/>
+          <p:cNvSpPr>
+            <a:spLocks noGrp="1"/>
+          </p:cNvSpPr>
+          <p:nvPr>
+            <p:ph type="hdr" sz="quarter"/>
+          </p:nvPr>
+        </p:nvSpPr>
+        <p:spPr>
+          <a:xfrm>
+            <a:off x="0" y="0"/>
+            <a:ext cx="2971800" cy="458788"/>
+          </a:xfrm>
+          <a:prstGeom prst="rect">
+            <a:avLst/>
+          </a:prstGeom>
+        </p:spPr>
+        <p:txBody>
+          <a:bodyPr vert="horz" lIns="91440" tIns="45720" rIns="91440" bIns="45720" rtlCol="0"/>
+          <a:lstStyle>
+            <a:lvl1pPr algn="l">
+              <a:defRPr sz="1200"/>
+            </a:lvl1pPr>
+          </a:lstStyle>
+          <a:p>
+            <a:endParaRPr lang="en-US"/>
+          </a:p>
+        </p:txBody>
+      </p:sp>
+      <p:sp>
+        <p:nvSpPr>
+          <p:cNvPr id="3" name="Date Placeholder 2"/>
+          <p:cNvSpPr>
+            <a:spLocks noGrp="1"/>
+          </p:cNvSpPr>
+          <p:nvPr>
+            <p:ph type="dt" idx="1"/>
+          </p:nvPr>
+        </p:nvSpPr>
+        <p:spPr>
+          <a:xfrm>
+            <a:off x="3884613" y="0"/>
+            <a:ext cx="2971800" cy="458788"/>
+          </a:xfrm>
+          <a:prstGeom prst="rect">
+            <a:avLst/>
+          </a:prstGeom>
+        </p:spPr>
+        <p:txBody>
+          <a:bodyPr vert="horz" lIns="91440" tIns="45720" rIns="91440" bIns="45720" rtlCol="0"/>
+          <a:lstStyle>
+            <a:lvl1pPr algn="r">
+              <a:defRPr sz="1200"/>
+            </a:lvl1pPr>
+          </a:lstStyle>
+          <a:p>
+            <a:fld id="{5282F153-3F37-0F45-9E97-73ACFA13230C}" type="datetimeFigureOut">
+              <a:rPr lang="en-US"/>
+              <a:t>7/23/19</a:t>
+            </a:fld>
+            <a:endParaRPr lang="en-US"/>
+          </a:p>
+        </p:txBody>
+      </p:sp>
+      <p:sp>
+        <p:nvSpPr>
+          <p:cNvPr id="4" name="Slide Image Placeholder 3"/>
+          <p:cNvSpPr>
+            <a:spLocks noGrp="1" noRot="1" noChangeAspect="1"/>
+          </p:cNvSpPr>
+          <p:nvPr>
+            <p:ph type="sldImg" idx="2"/>
+          </p:nvPr>
+        </p:nvSpPr>
+        <p:spPr>
+          <a:xfrm>
+            <a:off x="685800" y="1143000"/>
+            <a:ext cx="5486400" cy="3086100"/>
+          </a:xfrm>
+          <a:prstGeom prst="rect">
+            <a:avLst/>
+          </a:prstGeom>
+          <a:noFill/>
+          <a:ln w="12700">
+            <a:solidFill>
+              <a:prstClr val="black"/>
+            </a:solidFill>
+          </a:ln>
+        </p:spPr>
+        <p:txBody>
+          <a:bodyPr vert="horz" lIns="91440" tIns="45720" rIns="91440" bIns="45720" rtlCol="0" anchor="ctr"/>
+          <a:lstStyle/>
+          <a:p>
+            <a:endParaRPr lang="en-US"/>
+          </a:p>
+        </p:txBody>
+      </p:sp>
+      <p:sp>
+        <p:nvSpPr>
+          <p:cNvPr id="5" name="Notes Placeholder 4"/>
+          <p:cNvSpPr>
+            <a:spLocks noGrp="1"/>
+          </p:cNvSpPr>
+          <p:nvPr>
+            <p:ph type="body" sz="quarter" idx="3"/>
+          </p:nvPr>
+        </p:nvSpPr>
+        <p:spPr>
+          <a:xfrm>
+            <a:off x="685800" y="4400550"/>
+            <a:ext cx="5486400" cy="3600450"/>
+          </a:xfrm>
+          <a:prstGeom prst="rect">
+            <a:avLst/>
+          </a:prstGeom>
+        </p:spPr>
+        <p:txBody>
+          <a:bodyPr vert="horz" lIns="91440" tIns="45720" rIns="91440" bIns="45720" rtlCol="0"/>
+          <a:lstStyle/>
+          <a:p>
+            <a:pPr lvl="0"/>
+            <a:r>
+              <a:rPr lang="en-US"/>
+              <a:t>Click to edit Master text styles</a:t>
+            </a:r>
+          </a:p>
+          <a:p>
+            <a:pPr lvl="1"/>
+            <a:r>
+              <a:rPr lang="en-US"/>
+              <a:t>Second level</a:t>
+            </a:r>
+          </a:p>
+          <a:p>
+            <a:pPr lvl="2"/>
+            <a:r>
+              <a:rPr lang="en-US"/>
+              <a:t>Third level</a:t>
+            </a:r>
+          </a:p>
+          <a:p>
+            <a:pPr lvl="3"/>
+            <a:r>
+              <a:rPr lang="en-US"/>
+              <a:t>Fourth level</a:t>
+            </a:r>
+          </a:p>
+          <a:p>
+            <a:pPr lvl="4"/>
+            <a:r>
+              <a:rPr lang="en-US"/>
+              <a:t>Fifth level</a:t>
+            </a:r>
+          </a:p>
+        </p:txBody>
+      </p:sp>
+      <p:sp>
+        <p:nvSpPr>
+          <p:cNvPr id="6" name="Footer Placeholder 5"/>
+          <p:cNvSpPr>
+            <a:spLocks noGrp="1"/>
+          </p:cNvSpPr>
+          <p:nvPr>
+            <p:ph type="ftr" sz="quarter" idx="4"/>
+          </p:nvPr>
+        </p:nvSpPr>
+        <p:spPr>
+          <a:xfrm>
+            <a:off x="0" y="8685213"/>
+            <a:ext cx="2971800" cy="458787"/>
+          </a:xfrm>
+          <a:prstGeom prst="rect">
+            <a:avLst/>
+          </a:prstGeom>
+        </p:spPr>
+        <p:txBody>
+          <a:bodyPr vert="horz" lIns="91440" tIns="45720" rIns="91440" bIns="45720" rtlCol="0" anchor="b"/>
+          <a:lstStyle>
+            <a:lvl1pPr algn="l">
+              <a:defRPr sz="1200"/>
+            </a:lvl1pPr>
+          </a:lstStyle>
+          <a:p>
+            <a:endParaRPr lang="en-US"/>
+          </a:p>
+        </p:txBody>
+      </p:sp>
+      <p:sp>
+        <p:nvSpPr>
+          <p:cNvPr id="7" name="Slide Number Placeholder 6"/>
+          <p:cNvSpPr>
+            <a:spLocks noGrp="1"/>
+          </p:cNvSpPr>
+          <p:nvPr>
+            <p:ph type="sldNum" sz="quarter" idx="5"/>
+          </p:nvPr>
+        </p:nvSpPr>
+        <p:spPr>
+          <a:xfrm>
+            <a:off x="3884613" y="8685213"/>
+            <a:ext cx="2971800" cy="458787"/>
+          </a:xfrm>
+          <a:prstGeom prst="rect">
+            <a:avLst/>
+          </a:prstGeom>
+        </p:spPr>
+        <p:txBody>
+          <a:bodyPr vert="horz" lIns="91440" tIns="45720" rIns="91440" bIns="45720" rtlCol="0" anchor="b"/>
+          <a:lstStyle>
+            <a:lvl1pPr algn="r">
+              <a:defRPr sz="1200"/>
+            </a:lvl1pPr>
+          </a:lstStyle>
+          <a:p>
+            <a:fld id="{CE5E9CC1-C706-0F49-92D6-E571CC5EEA8F}" type="slidenum">
+              <a:rPr lang="en-US"/>
+              <a:t>‹#›</a:t>
+            </a:fld>
+            <a:endParaRPr lang="en-US"/>
+          </a:p>
+        </p:txBody>
+      </p:sp>
     </p:spTree>
     <p:extLst>
       <p:ext uri="{BB962C8B-B14F-4D97-AF65-F5344CB8AC3E}">
-        <p14:creationId xmlns:p14="http://schemas.microsoft.com/office/powerpoint/2010/main" val="1843419748"/>
+        <p14:creationId xmlns:p14="http://schemas.microsoft.com/office/powerpoint/2010/main" val="1024086991"/>
       </p:ext>
     </p:extLst>
   </p:cSld>
@@ -285,6 +504,10 @@
           <a:bodyPr/>
           <a:lstStyle/>
           <a:p>
+            <a:r>
+              <a:rPr lang="en-US" dirty="0"/>
+              <a:t/>
+            </a:r>
             <a:endParaRPr lang="en-US" dirty="0"/>
           </a:p>
         </p:txBody>
@@ -369,6 +592,10 @@
           <a:bodyPr/>
           <a:lstStyle/>
           <a:p>
+            <a:r>
+              <a:rPr lang="en-US" dirty="0"/>
+              <a:t/>
+            </a:r>
             <a:endParaRPr lang="en-US" dirty="0"/>
           </a:p>
         </p:txBody>
@@ -453,6 +680,10 @@
           <a:bodyPr/>
           <a:lstStyle/>
           <a:p>
+            <a:r>
+              <a:rPr lang="en-US" dirty="0"/>
+              <a:t/>
+            </a:r>
             <a:endParaRPr lang="en-US" dirty="0"/>
           </a:p>
         </p:txBody>
@@ -537,6 +768,10 @@
           <a:bodyPr/>
           <a:lstStyle/>
           <a:p>
+            <a:r>
+              <a:rPr lang="en-US" dirty="0"/>
+              <a:t/>
+            </a:r>
             <a:endParaRPr lang="en-US" dirty="0"/>
           </a:p>
         </p:txBody>
@@ -621,6 +856,10 @@
           <a:bodyPr/>
           <a:lstStyle/>
           <a:p>
+            <a:r>
+              <a:rPr lang="en-US" dirty="0"/>
+              <a:t/>
+            </a:r>
             <a:endParaRPr lang="en-US" dirty="0"/>
           </a:p>
         </p:txBody>
@@ -694,11 +933,6 @@
 <file path=ppt/slideMasters/slideMaster1.xml><?xml version="1.0" encoding="utf-8"?>
 <p:sldMaster xmlns:a="http://schemas.openxmlformats.org/drawingml/2006/main" xmlns:r="http://schemas.openxmlformats.org/officeDocument/2006/relationships" xmlns:p="http://schemas.openxmlformats.org/presentationml/2006/main">
   <p:cSld>
-    <p:bg>
-      <p:bgRef idx="1001">
-        <a:schemeClr val="bg1"/>
-      </p:bgRef>
-    </p:bg>
     <p:spTree>
       <p:nvGrpSpPr>
         <p:cNvPr id="1" name=""/>
@@ -981,7 +1215,6 @@
         <a:solidFill>
           <a:srgbClr val="0D1321"/>
         </a:solidFill>
-        <a:effectLst/>
       </p:bgPr>
     </p:bg>
     <p:spTree>
@@ -1017,13 +1250,6 @@
           </a:solidFill>
           <a:ln/>
         </p:spPr>
-        <p:txBody>
-          <a:bodyPr/>
-          <a:lstStyle/>
-          <a:p>
-            <a:endParaRPr lang="en-ID"/>
-          </a:p>
-        </p:txBody>
       </p:sp>
       <p:sp>
         <p:nvSpPr>
@@ -1046,7 +1272,7 @@
           <a:bodyPr wrap="square" lIns="0" tIns="0" rIns="0" bIns="0" rtlCol="0" anchor="ctr"/>
           <a:lstStyle/>
           <a:p>
-            <a:pPr marL="0" indent="0">
+            <a:pPr indent="0" marL="0">
               <a:buNone/>
             </a:pPr>
             <a:r>
@@ -1060,6 +1286,9 @@
               </a:rPr>
               <a:t>belajar</a:t>
             </a:r>
+            <a:pPr indent="0" marL="0">
+              <a:buNone/>
+            </a:pPr>
             <a:r>
               <a:rPr lang="en-US" sz="2000" b="1" dirty="0">
                 <a:solidFill>
@@ -1096,13 +1325,6 @@
           </a:solidFill>
           <a:ln/>
         </p:spPr>
-        <p:txBody>
-          <a:bodyPr/>
-          <a:lstStyle/>
-          <a:p>
-            <a:endParaRPr lang="en-ID"/>
-          </a:p>
-        </p:txBody>
       </p:sp>
       <p:sp>
         <p:nvSpPr>
@@ -1125,7 +1347,7 @@
           <a:bodyPr wrap="square" lIns="0" tIns="0" rIns="0" bIns="0" rtlCol="0" anchor="ctr"/>
           <a:lstStyle/>
           <a:p>
-            <a:pPr marL="0" indent="0" algn="ctr">
+            <a:pPr algn="ctr" indent="0" marL="0">
               <a:buNone/>
             </a:pPr>
             <a:r>
@@ -1164,11 +1386,11 @@
           <a:bodyPr wrap="square" lIns="0" tIns="0" rIns="0" bIns="0" rtlCol="0" anchor="ctr"/>
           <a:lstStyle/>
           <a:p>
-            <a:pPr marL="0" indent="0">
-              <a:buNone/>
-            </a:pPr>
-            <a:r>
-              <a:rPr lang="en-US" sz="1300" b="1" kern="0" spc="40" dirty="0">
+            <a:pPr indent="0" marL="0">
+              <a:buNone/>
+            </a:pPr>
+            <a:r>
+              <a:rPr lang="en-US" sz="1300" b="1" spc="40" kern="0" dirty="0">
                 <a:solidFill>
                   <a:srgbClr val="8B7CF6"/>
                 </a:solidFill>
@@ -1203,7 +1425,7 @@
           <a:bodyPr wrap="square" lIns="0" tIns="0" rIns="0" bIns="0" rtlCol="0" anchor="ctr"/>
           <a:lstStyle/>
           <a:p>
-            <a:pPr marL="0" indent="0">
+            <a:pPr indent="0" marL="0">
               <a:lnSpc>
                 <a:spcPts val="5000"/>
               </a:lnSpc>
@@ -1245,7 +1467,7 @@
           <a:bodyPr wrap="square" lIns="0" tIns="0" rIns="0" bIns="0" rtlCol="0" anchor="ctr"/>
           <a:lstStyle/>
           <a:p>
-            <a:pPr marL="0" indent="0">
+            <a:pPr indent="0" marL="0">
               <a:buNone/>
             </a:pPr>
             <a:r>
@@ -1257,7 +1479,7 @@
                 <a:ea typeface="Helvetica" pitchFamily="34" charset="-122"/>
                 <a:cs typeface="Helvetica" pitchFamily="34" charset="-120"/>
               </a:rPr>
-              <a:t>Listing yang SEO dan menjual, pakai positioning dari Modul 1 — 10 menit</a:t>
+              <a:t>Listing yang SEO dan menjual, pakai positioning dari Modul 1</a:t>
             </a:r>
             <a:endParaRPr lang="en-US" sz="1550" dirty="0"/>
           </a:p>
@@ -1307,13 +1529,6 @@
           </a:solidFill>
           <a:ln/>
         </p:spPr>
-        <p:txBody>
-          <a:bodyPr/>
-          <a:lstStyle/>
-          <a:p>
-            <a:endParaRPr lang="en-ID"/>
-          </a:p>
-        </p:txBody>
       </p:sp>
       <p:sp>
         <p:nvSpPr>
@@ -1334,13 +1549,6 @@
           </a:solidFill>
           <a:ln/>
         </p:spPr>
-        <p:txBody>
-          <a:bodyPr/>
-          <a:lstStyle/>
-          <a:p>
-            <a:endParaRPr lang="en-ID"/>
-          </a:p>
-        </p:txBody>
       </p:sp>
       <p:sp>
         <p:nvSpPr>
@@ -1363,7 +1571,7 @@
           <a:bodyPr wrap="square" lIns="0" tIns="0" rIns="0" bIns="0" rtlCol="0" anchor="ctr"/>
           <a:lstStyle/>
           <a:p>
-            <a:pPr marL="0" indent="0">
+            <a:pPr indent="0" marL="0">
               <a:buNone/>
             </a:pPr>
             <a:r>
@@ -1377,6 +1585,9 @@
               </a:rPr>
               <a:t>belajar</a:t>
             </a:r>
+            <a:pPr indent="0" marL="0">
+              <a:buNone/>
+            </a:pPr>
             <a:r>
               <a:rPr lang="en-US" sz="2000" b="1" dirty="0">
                 <a:solidFill>
@@ -1413,7 +1624,7 @@
           <a:bodyPr wrap="square" lIns="0" tIns="0" rIns="0" bIns="0" rtlCol="0" anchor="ctr"/>
           <a:lstStyle/>
           <a:p>
-            <a:pPr marL="0" indent="0" algn="r">
+            <a:pPr algn="r" indent="0" marL="0">
               <a:buNone/>
             </a:pPr>
             <a:r>
@@ -1452,11 +1663,11 @@
           <a:bodyPr wrap="square" lIns="0" tIns="0" rIns="0" bIns="0" rtlCol="0" anchor="ctr"/>
           <a:lstStyle/>
           <a:p>
-            <a:pPr marL="0" indent="0">
-              <a:buNone/>
-            </a:pPr>
-            <a:r>
-              <a:rPr lang="en-US" sz="1250" b="1" kern="0" spc="40" dirty="0">
+            <a:pPr indent="0" marL="0">
+              <a:buNone/>
+            </a:pPr>
+            <a:r>
+              <a:rPr lang="en-US" sz="1250" b="1" spc="40" kern="0" dirty="0">
                 <a:solidFill>
                   <a:srgbClr val="4B36C7"/>
                 </a:solidFill>
@@ -1464,7 +1675,7 @@
                 <a:ea typeface="Helvetica" pitchFamily="34" charset="-122"/>
                 <a:cs typeface="Helvetica" pitchFamily="34" charset="-120"/>
               </a:rPr>
-              <a:t>STRUKTUR DESKRIPSI PRODUK YANG MENJUAL</a:t>
+              <a:t>URUTAN YANG BENAR-BENAR DIBACA PEMBELI</a:t>
             </a:r>
             <a:endParaRPr lang="en-US" sz="1250" dirty="0"/>
           </a:p>
@@ -1491,7 +1702,7 @@
           <a:bodyPr wrap="square" lIns="0" tIns="0" rIns="0" bIns="0" rtlCol="0" anchor="ctr"/>
           <a:lstStyle/>
           <a:p>
-            <a:pPr marL="0" indent="0">
+            <a:pPr indent="0" marL="0">
               <a:buNone/>
             </a:pPr>
             <a:r>
@@ -1503,7 +1714,7 @@
                 <a:ea typeface="Helvetica" pitchFamily="34" charset="-122"/>
                 <a:cs typeface="Helvetica" pitchFamily="34" charset="-120"/>
               </a:rPr>
-              <a:t>Struktur Deskripsi Produk yang Menjual</a:t>
+              <a:t>Anatomi Deskripsi yang Menjual</a:t>
             </a:r>
             <a:endParaRPr lang="en-US" sz="2200" dirty="0"/>
           </a:p>
@@ -1511,233 +1722,208 @@
       </p:sp>
       <p:sp>
         <p:nvSpPr>
-          <p:cNvPr id="8" name="Shape 6"/>
-          <p:cNvSpPr/>
-          <p:nvPr/>
-        </p:nvSpPr>
-        <p:spPr>
-          <a:xfrm>
-            <a:off x="502920" y="2084832"/>
-            <a:ext cx="2487168" cy="1207008"/>
-          </a:xfrm>
-          <a:prstGeom prst="roundRect">
-            <a:avLst>
-              <a:gd name="adj" fmla="val 7576"/>
-            </a:avLst>
-          </a:prstGeom>
-          <a:solidFill>
-            <a:srgbClr val="F4F6FB"/>
-          </a:solidFill>
-          <a:ln w="12700">
+          <p:cNvPr id="8" name="Text 6"/>
+          <p:cNvSpPr/>
+          <p:nvPr/>
+        </p:nvSpPr>
+        <p:spPr>
+          <a:xfrm>
+            <a:off x="502920" y="2066544"/>
+            <a:ext cx="11064240" cy="292608"/>
+          </a:xfrm>
+          <a:prstGeom prst="rect">
+            <a:avLst/>
+          </a:prstGeom>
+          <a:noFill/>
+          <a:ln/>
+        </p:spPr>
+        <p:txBody>
+          <a:bodyPr wrap="square" lIns="0" tIns="0" rIns="0" bIns="0" rtlCol="0" anchor="ctr"/>
+          <a:lstStyle/>
+          <a:p>
+            <a:pPr indent="0" marL="0">
+              <a:buNone/>
+            </a:pPr>
+            <a:r>
+              <a:rPr lang="en-US" sz="1200" i="1" dirty="0">
+                <a:solidFill>
+                  <a:srgbClr val="6B7280"/>
+                </a:solidFill>
+                <a:latin typeface="Helvetica" pitchFamily="34" charset="0"/>
+                <a:ea typeface="Helvetica" pitchFamily="34" charset="-122"/>
+                <a:cs typeface="Helvetica" pitchFamily="34" charset="-120"/>
+              </a:rPr>
+              <a:t>Bukan daftar hal acak — ini urutan yang dibaca pembeli dari atas ke bawah, jadi susun deskripsimu mengikuti urutan ini:</a:t>
+            </a:r>
+            <a:endParaRPr lang="en-US" sz="1200" dirty="0"/>
+          </a:p>
+        </p:txBody>
+      </p:sp>
+      <p:sp>
+        <p:nvSpPr>
+          <p:cNvPr id="9" name="Shape 7"/>
+          <p:cNvSpPr/>
+          <p:nvPr/>
+        </p:nvSpPr>
+        <p:spPr>
+          <a:xfrm>
+            <a:off x="649224" y="2761488"/>
+            <a:ext cx="0" cy="164592"/>
+          </a:xfrm>
+          <a:prstGeom prst="line">
+            <a:avLst/>
+          </a:prstGeom>
+          <a:noFill/>
+          <a:ln w="19050">
             <a:solidFill>
               <a:srgbClr val="D6DCEB"/>
             </a:solidFill>
             <a:prstDash val="solid"/>
           </a:ln>
         </p:spPr>
-        <p:txBody>
-          <a:bodyPr/>
-          <a:lstStyle/>
-          <a:p>
-            <a:endParaRPr lang="en-ID"/>
-          </a:p>
-        </p:txBody>
-      </p:sp>
-      <p:sp>
-        <p:nvSpPr>
-          <p:cNvPr id="9" name="Text 7"/>
-          <p:cNvSpPr/>
-          <p:nvPr/>
-        </p:nvSpPr>
-        <p:spPr>
-          <a:xfrm>
-            <a:off x="667512" y="2231136"/>
-            <a:ext cx="2157984" cy="384048"/>
-          </a:xfrm>
-          <a:prstGeom prst="rect">
-            <a:avLst/>
-          </a:prstGeom>
-          <a:noFill/>
-          <a:ln/>
-        </p:spPr>
-        <p:txBody>
-          <a:bodyPr wrap="square" lIns="0" tIns="0" rIns="0" bIns="0" rtlCol="0" anchor="ctr"/>
-          <a:lstStyle/>
-          <a:p>
-            <a:pPr marL="0" indent="0">
-              <a:buNone/>
-            </a:pPr>
-            <a:r>
-              <a:rPr lang="en-US" sz="1200" b="1" dirty="0">
-                <a:solidFill>
-                  <a:srgbClr val="4B36C7"/>
-                </a:solidFill>
-                <a:latin typeface="Helvetica" pitchFamily="34" charset="0"/>
-                <a:ea typeface="Helvetica" pitchFamily="34" charset="-122"/>
-                <a:cs typeface="Helvetica" pitchFamily="34" charset="-120"/>
-              </a:rPr>
-              <a:t>HOOK (2 KALIMAT PERTAMA)</a:t>
-            </a:r>
-            <a:endParaRPr lang="en-US" sz="1200" dirty="0"/>
-          </a:p>
-        </p:txBody>
-      </p:sp>
-      <p:sp>
-        <p:nvSpPr>
-          <p:cNvPr id="10" name="Text 8"/>
-          <p:cNvSpPr/>
-          <p:nvPr/>
-        </p:nvSpPr>
-        <p:spPr>
-          <a:xfrm>
-            <a:off x="667512" y="2587752"/>
-            <a:ext cx="2157984" cy="566928"/>
-          </a:xfrm>
-          <a:prstGeom prst="rect">
-            <a:avLst/>
-          </a:prstGeom>
-          <a:noFill/>
-          <a:ln/>
-        </p:spPr>
-        <p:txBody>
-          <a:bodyPr wrap="square" lIns="0" tIns="0" rIns="0" bIns="0" rtlCol="0" anchor="ctr"/>
-          <a:lstStyle/>
-          <a:p>
-            <a:pPr marL="0" indent="0">
-              <a:lnSpc>
-                <a:spcPct val="120000"/>
-              </a:lnSpc>
-              <a:buNone/>
-            </a:pPr>
-            <a:r>
-              <a:rPr lang="en-US" sz="1100" dirty="0">
-                <a:solidFill>
-                  <a:srgbClr val="23283A"/>
-                </a:solidFill>
-                <a:latin typeface="Helvetica" pitchFamily="34" charset="0"/>
-                <a:ea typeface="Helvetica" pitchFamily="34" charset="-122"/>
-                <a:cs typeface="Helvetica" pitchFamily="34" charset="-120"/>
-              </a:rPr>
-              <a:t>Langsung ke benefit, bukan nama produk — pembeli scan, bukan baca</a:t>
-            </a:r>
-            <a:endParaRPr lang="en-US" sz="1100" dirty="0"/>
-          </a:p>
-        </p:txBody>
-      </p:sp>
-      <p:sp>
-        <p:nvSpPr>
-          <p:cNvPr id="11" name="Shape 9"/>
-          <p:cNvSpPr/>
-          <p:nvPr/>
-        </p:nvSpPr>
-        <p:spPr>
-          <a:xfrm>
-            <a:off x="3108960" y="2084832"/>
-            <a:ext cx="2487168" cy="1207008"/>
+      </p:sp>
+      <p:sp>
+        <p:nvSpPr>
+          <p:cNvPr id="10" name="Shape 8"/>
+          <p:cNvSpPr/>
+          <p:nvPr/>
+        </p:nvSpPr>
+        <p:spPr>
+          <a:xfrm>
+            <a:off x="502920" y="2468880"/>
+            <a:ext cx="292608" cy="292608"/>
           </a:xfrm>
           <a:prstGeom prst="roundRect">
             <a:avLst>
-              <a:gd name="adj" fmla="val 7576"/>
+              <a:gd name="adj" fmla="val 18750"/>
             </a:avLst>
           </a:prstGeom>
           <a:solidFill>
-            <a:srgbClr val="F4F6FB"/>
+            <a:srgbClr val="6849F6"/>
           </a:solidFill>
-          <a:ln w="12700">
+          <a:ln/>
+        </p:spPr>
+      </p:sp>
+      <p:sp>
+        <p:nvSpPr>
+          <p:cNvPr id="11" name="Text 9"/>
+          <p:cNvSpPr/>
+          <p:nvPr/>
+        </p:nvSpPr>
+        <p:spPr>
+          <a:xfrm>
+            <a:off x="502920" y="2468880"/>
+            <a:ext cx="292608" cy="292608"/>
+          </a:xfrm>
+          <a:prstGeom prst="rect">
+            <a:avLst/>
+          </a:prstGeom>
+          <a:noFill/>
+          <a:ln/>
+        </p:spPr>
+        <p:txBody>
+          <a:bodyPr wrap="square" lIns="0" tIns="0" rIns="0" bIns="0" rtlCol="0" anchor="ctr"/>
+          <a:lstStyle/>
+          <a:p>
+            <a:pPr algn="ctr" indent="0" marL="0">
+              <a:buNone/>
+            </a:pPr>
+            <a:r>
+              <a:rPr lang="en-US" sz="1200" b="1" dirty="0">
+                <a:solidFill>
+                  <a:srgbClr val="FFFFFF"/>
+                </a:solidFill>
+                <a:latin typeface="Helvetica" pitchFamily="34" charset="0"/>
+                <a:ea typeface="Helvetica" pitchFamily="34" charset="-122"/>
+                <a:cs typeface="Helvetica" pitchFamily="34" charset="-120"/>
+              </a:rPr>
+              <a:t>1</a:t>
+            </a:r>
+            <a:endParaRPr lang="en-US" sz="1200" dirty="0"/>
+          </a:p>
+        </p:txBody>
+      </p:sp>
+      <p:sp>
+        <p:nvSpPr>
+          <p:cNvPr id="12" name="Text 10"/>
+          <p:cNvSpPr/>
+          <p:nvPr/>
+        </p:nvSpPr>
+        <p:spPr>
+          <a:xfrm>
+            <a:off x="960120" y="2432304"/>
+            <a:ext cx="10195560" cy="420624"/>
+          </a:xfrm>
+          <a:prstGeom prst="rect">
+            <a:avLst/>
+          </a:prstGeom>
+          <a:noFill/>
+          <a:ln/>
+        </p:spPr>
+        <p:txBody>
+          <a:bodyPr wrap="square" lIns="0" tIns="0" rIns="0" bIns="0" rtlCol="0" anchor="ctr"/>
+          <a:lstStyle/>
+          <a:p>
+            <a:pPr indent="0" marL="0">
+              <a:lnSpc>
+                <a:spcPct val="115000"/>
+              </a:lnSpc>
+              <a:buNone/>
+            </a:pPr>
+            <a:r>
+              <a:rPr lang="en-US" sz="1200" b="1" dirty="0">
+                <a:solidFill>
+                  <a:srgbClr val="0D1321"/>
+                </a:solidFill>
+                <a:latin typeface="Helvetica" pitchFamily="34" charset="0"/>
+                <a:ea typeface="Helvetica" pitchFamily="34" charset="-122"/>
+                <a:cs typeface="Helvetica" pitchFamily="34" charset="-120"/>
+              </a:rPr>
+              <a:t>Hook (2 kalimat pertama)  —  </a:t>
+            </a:r>
+            <a:pPr indent="0" marL="0">
+              <a:lnSpc>
+                <a:spcPct val="115000"/>
+              </a:lnSpc>
+              <a:buNone/>
+            </a:pPr>
+            <a:r>
+              <a:rPr lang="en-US" sz="1200" dirty="0">
+                <a:solidFill>
+                  <a:srgbClr val="23283A"/>
+                </a:solidFill>
+                <a:latin typeface="Helvetica" pitchFamily="34" charset="0"/>
+                <a:ea typeface="Helvetica" pitchFamily="34" charset="-122"/>
+                <a:cs typeface="Helvetica" pitchFamily="34" charset="-120"/>
+              </a:rPr>
+              <a:t>Langsung ke benefit, bukan nama produk — pembeli scan, bukan baca</a:t>
+            </a:r>
+            <a:endParaRPr lang="en-US" sz="1200" dirty="0"/>
+          </a:p>
+        </p:txBody>
+      </p:sp>
+      <p:sp>
+        <p:nvSpPr>
+          <p:cNvPr id="13" name="Shape 11"/>
+          <p:cNvSpPr/>
+          <p:nvPr/>
+        </p:nvSpPr>
+        <p:spPr>
+          <a:xfrm>
+            <a:off x="649224" y="3218688"/>
+            <a:ext cx="0" cy="164592"/>
+          </a:xfrm>
+          <a:prstGeom prst="line">
+            <a:avLst/>
+          </a:prstGeom>
+          <a:noFill/>
+          <a:ln w="19050">
             <a:solidFill>
               <a:srgbClr val="D6DCEB"/>
             </a:solidFill>
             <a:prstDash val="solid"/>
           </a:ln>
         </p:spPr>
-        <p:txBody>
-          <a:bodyPr/>
-          <a:lstStyle/>
-          <a:p>
-            <a:endParaRPr lang="en-ID"/>
-          </a:p>
-        </p:txBody>
-      </p:sp>
-      <p:sp>
-        <p:nvSpPr>
-          <p:cNvPr id="12" name="Text 10"/>
-          <p:cNvSpPr/>
-          <p:nvPr/>
-        </p:nvSpPr>
-        <p:spPr>
-          <a:xfrm>
-            <a:off x="3273552" y="2231136"/>
-            <a:ext cx="2157984" cy="384048"/>
-          </a:xfrm>
-          <a:prstGeom prst="rect">
-            <a:avLst/>
-          </a:prstGeom>
-          <a:noFill/>
-          <a:ln/>
-        </p:spPr>
-        <p:txBody>
-          <a:bodyPr wrap="square" lIns="0" tIns="0" rIns="0" bIns="0" rtlCol="0" anchor="ctr"/>
-          <a:lstStyle/>
-          <a:p>
-            <a:pPr marL="0" indent="0">
-              <a:buNone/>
-            </a:pPr>
-            <a:r>
-              <a:rPr lang="en-US" sz="1200" b="1" dirty="0">
-                <a:solidFill>
-                  <a:srgbClr val="4B36C7"/>
-                </a:solidFill>
-                <a:latin typeface="Helvetica" pitchFamily="34" charset="0"/>
-                <a:ea typeface="Helvetica" pitchFamily="34" charset="-122"/>
-                <a:cs typeface="Helvetica" pitchFamily="34" charset="-120"/>
-              </a:rPr>
-              <a:t>KEYWORD PENCARIAN</a:t>
-            </a:r>
-            <a:endParaRPr lang="en-US" sz="1200" dirty="0"/>
-          </a:p>
-        </p:txBody>
-      </p:sp>
-      <p:sp>
-        <p:nvSpPr>
-          <p:cNvPr id="13" name="Text 11"/>
-          <p:cNvSpPr/>
-          <p:nvPr/>
-        </p:nvSpPr>
-        <p:spPr>
-          <a:xfrm>
-            <a:off x="3273552" y="2587752"/>
-            <a:ext cx="2157984" cy="566928"/>
-          </a:xfrm>
-          <a:prstGeom prst="rect">
-            <a:avLst/>
-          </a:prstGeom>
-          <a:noFill/>
-          <a:ln/>
-        </p:spPr>
-        <p:txBody>
-          <a:bodyPr wrap="square" lIns="0" tIns="0" rIns="0" bIns="0" rtlCol="0" anchor="ctr"/>
-          <a:lstStyle/>
-          <a:p>
-            <a:pPr marL="0" indent="0">
-              <a:lnSpc>
-                <a:spcPct val="120000"/>
-              </a:lnSpc>
-              <a:buNone/>
-            </a:pPr>
-            <a:r>
-              <a:rPr lang="en-US" sz="1100" dirty="0">
-                <a:solidFill>
-                  <a:srgbClr val="23283A"/>
-                </a:solidFill>
-                <a:latin typeface="Helvetica" pitchFamily="34" charset="0"/>
-                <a:ea typeface="Helvetica" pitchFamily="34" charset="-122"/>
-                <a:cs typeface="Helvetica" pitchFamily="34" charset="-120"/>
-              </a:rPr>
-              <a:t>Kata yang dipakai pembeli saat search, bukan istilah teknis internal</a:t>
-            </a:r>
-            <a:endParaRPr lang="en-US" sz="1100" dirty="0"/>
-          </a:p>
-        </p:txBody>
       </p:sp>
       <p:sp>
         <p:nvSpPr>
@@ -1747,327 +1933,283 @@
         </p:nvSpPr>
         <p:spPr>
           <a:xfrm>
-            <a:off x="5715000" y="2084832"/>
-            <a:ext cx="2487168" cy="1207008"/>
+            <a:off x="502920" y="2926080"/>
+            <a:ext cx="292608" cy="292608"/>
           </a:xfrm>
           <a:prstGeom prst="roundRect">
             <a:avLst>
-              <a:gd name="adj" fmla="val 7576"/>
+              <a:gd name="adj" fmla="val 18750"/>
             </a:avLst>
           </a:prstGeom>
           <a:solidFill>
-            <a:srgbClr val="F4F6FB"/>
+            <a:srgbClr val="6849F6"/>
           </a:solidFill>
-          <a:ln w="12700">
+          <a:ln/>
+        </p:spPr>
+      </p:sp>
+      <p:sp>
+        <p:nvSpPr>
+          <p:cNvPr id="15" name="Text 13"/>
+          <p:cNvSpPr/>
+          <p:nvPr/>
+        </p:nvSpPr>
+        <p:spPr>
+          <a:xfrm>
+            <a:off x="502920" y="2926080"/>
+            <a:ext cx="292608" cy="292608"/>
+          </a:xfrm>
+          <a:prstGeom prst="rect">
+            <a:avLst/>
+          </a:prstGeom>
+          <a:noFill/>
+          <a:ln/>
+        </p:spPr>
+        <p:txBody>
+          <a:bodyPr wrap="square" lIns="0" tIns="0" rIns="0" bIns="0" rtlCol="0" anchor="ctr"/>
+          <a:lstStyle/>
+          <a:p>
+            <a:pPr algn="ctr" indent="0" marL="0">
+              <a:buNone/>
+            </a:pPr>
+            <a:r>
+              <a:rPr lang="en-US" sz="1200" b="1" dirty="0">
+                <a:solidFill>
+                  <a:srgbClr val="FFFFFF"/>
+                </a:solidFill>
+                <a:latin typeface="Helvetica" pitchFamily="34" charset="0"/>
+                <a:ea typeface="Helvetica" pitchFamily="34" charset="-122"/>
+                <a:cs typeface="Helvetica" pitchFamily="34" charset="-120"/>
+              </a:rPr>
+              <a:t>2</a:t>
+            </a:r>
+            <a:endParaRPr lang="en-US" sz="1200" dirty="0"/>
+          </a:p>
+        </p:txBody>
+      </p:sp>
+      <p:sp>
+        <p:nvSpPr>
+          <p:cNvPr id="16" name="Text 14"/>
+          <p:cNvSpPr/>
+          <p:nvPr/>
+        </p:nvSpPr>
+        <p:spPr>
+          <a:xfrm>
+            <a:off x="960120" y="2889504"/>
+            <a:ext cx="10195560" cy="420624"/>
+          </a:xfrm>
+          <a:prstGeom prst="rect">
+            <a:avLst/>
+          </a:prstGeom>
+          <a:noFill/>
+          <a:ln/>
+        </p:spPr>
+        <p:txBody>
+          <a:bodyPr wrap="square" lIns="0" tIns="0" rIns="0" bIns="0" rtlCol="0" anchor="ctr"/>
+          <a:lstStyle/>
+          <a:p>
+            <a:pPr indent="0" marL="0">
+              <a:lnSpc>
+                <a:spcPct val="115000"/>
+              </a:lnSpc>
+              <a:buNone/>
+            </a:pPr>
+            <a:r>
+              <a:rPr lang="en-US" sz="1200" b="1" dirty="0">
+                <a:solidFill>
+                  <a:srgbClr val="0D1321"/>
+                </a:solidFill>
+                <a:latin typeface="Helvetica" pitchFamily="34" charset="0"/>
+                <a:ea typeface="Helvetica" pitchFamily="34" charset="-122"/>
+                <a:cs typeface="Helvetica" pitchFamily="34" charset="-120"/>
+              </a:rPr>
+              <a:t>Keyword Pencarian  —  </a:t>
+            </a:r>
+            <a:pPr indent="0" marL="0">
+              <a:lnSpc>
+                <a:spcPct val="115000"/>
+              </a:lnSpc>
+              <a:buNone/>
+            </a:pPr>
+            <a:r>
+              <a:rPr lang="en-US" sz="1200" dirty="0">
+                <a:solidFill>
+                  <a:srgbClr val="23283A"/>
+                </a:solidFill>
+                <a:latin typeface="Helvetica" pitchFamily="34" charset="0"/>
+                <a:ea typeface="Helvetica" pitchFamily="34" charset="-122"/>
+                <a:cs typeface="Helvetica" pitchFamily="34" charset="-120"/>
+              </a:rPr>
+              <a:t>Kata yang dipakai pembeli saat search, bukan istilah teknis internal</a:t>
+            </a:r>
+            <a:endParaRPr lang="en-US" sz="1200" dirty="0"/>
+          </a:p>
+        </p:txBody>
+      </p:sp>
+      <p:sp>
+        <p:nvSpPr>
+          <p:cNvPr id="17" name="Shape 15"/>
+          <p:cNvSpPr/>
+          <p:nvPr/>
+        </p:nvSpPr>
+        <p:spPr>
+          <a:xfrm>
+            <a:off x="649224" y="3675888"/>
+            <a:ext cx="0" cy="164592"/>
+          </a:xfrm>
+          <a:prstGeom prst="line">
+            <a:avLst/>
+          </a:prstGeom>
+          <a:noFill/>
+          <a:ln w="19050">
             <a:solidFill>
               <a:srgbClr val="D6DCEB"/>
             </a:solidFill>
             <a:prstDash val="solid"/>
           </a:ln>
         </p:spPr>
-        <p:txBody>
-          <a:bodyPr/>
-          <a:lstStyle/>
-          <a:p>
-            <a:endParaRPr lang="en-ID"/>
-          </a:p>
-        </p:txBody>
-      </p:sp>
-      <p:sp>
-        <p:nvSpPr>
-          <p:cNvPr id="15" name="Text 13"/>
-          <p:cNvSpPr/>
-          <p:nvPr/>
-        </p:nvSpPr>
-        <p:spPr>
-          <a:xfrm>
-            <a:off x="5879592" y="2231136"/>
-            <a:ext cx="2157984" cy="384048"/>
-          </a:xfrm>
-          <a:prstGeom prst="rect">
-            <a:avLst/>
-          </a:prstGeom>
-          <a:noFill/>
-          <a:ln/>
-        </p:spPr>
-        <p:txBody>
-          <a:bodyPr wrap="square" lIns="0" tIns="0" rIns="0" bIns="0" rtlCol="0" anchor="ctr"/>
-          <a:lstStyle/>
-          <a:p>
-            <a:pPr marL="0" indent="0">
-              <a:buNone/>
-            </a:pPr>
-            <a:r>
-              <a:rPr lang="en-US" sz="1200" b="1" dirty="0">
-                <a:solidFill>
-                  <a:srgbClr val="4B36C7"/>
-                </a:solidFill>
-                <a:latin typeface="Helvetica" pitchFamily="34" charset="0"/>
-                <a:ea typeface="Helvetica" pitchFamily="34" charset="-122"/>
-                <a:cs typeface="Helvetica" pitchFamily="34" charset="-120"/>
-              </a:rPr>
-              <a:t>SPESIFIKASI JELAS</a:t>
-            </a:r>
-            <a:endParaRPr lang="en-US" sz="1200" dirty="0"/>
-          </a:p>
-        </p:txBody>
-      </p:sp>
-      <p:sp>
-        <p:nvSpPr>
-          <p:cNvPr id="16" name="Text 14"/>
-          <p:cNvSpPr/>
-          <p:nvPr/>
-        </p:nvSpPr>
-        <p:spPr>
-          <a:xfrm>
-            <a:off x="5879592" y="2587752"/>
-            <a:ext cx="2157984" cy="566928"/>
-          </a:xfrm>
-          <a:prstGeom prst="rect">
-            <a:avLst/>
-          </a:prstGeom>
-          <a:noFill/>
-          <a:ln/>
-        </p:spPr>
-        <p:txBody>
-          <a:bodyPr wrap="square" lIns="0" tIns="0" rIns="0" bIns="0" rtlCol="0" anchor="ctr"/>
-          <a:lstStyle/>
-          <a:p>
-            <a:pPr marL="0" indent="0">
-              <a:lnSpc>
-                <a:spcPct val="120000"/>
-              </a:lnSpc>
-              <a:buNone/>
-            </a:pPr>
-            <a:r>
-              <a:rPr lang="en-US" sz="1100" dirty="0">
-                <a:solidFill>
-                  <a:srgbClr val="23283A"/>
-                </a:solidFill>
-                <a:latin typeface="Helvetica" pitchFamily="34" charset="0"/>
-                <a:ea typeface="Helvetica" pitchFamily="34" charset="-122"/>
-                <a:cs typeface="Helvetica" pitchFamily="34" charset="-120"/>
-              </a:rPr>
-              <a:t>Berat, ukuran, varian, cara simpan — kurangi pertanyaan pembeli</a:t>
-            </a:r>
-            <a:endParaRPr lang="en-US" sz="1100" dirty="0"/>
-          </a:p>
-        </p:txBody>
-      </p:sp>
-      <p:sp>
-        <p:nvSpPr>
-          <p:cNvPr id="17" name="Shape 15"/>
-          <p:cNvSpPr/>
-          <p:nvPr/>
-        </p:nvSpPr>
-        <p:spPr>
-          <a:xfrm>
-            <a:off x="8321040" y="2084832"/>
-            <a:ext cx="2487168" cy="1207008"/>
+      </p:sp>
+      <p:sp>
+        <p:nvSpPr>
+          <p:cNvPr id="18" name="Shape 16"/>
+          <p:cNvSpPr/>
+          <p:nvPr/>
+        </p:nvSpPr>
+        <p:spPr>
+          <a:xfrm>
+            <a:off x="502920" y="3383280"/>
+            <a:ext cx="292608" cy="292608"/>
           </a:xfrm>
           <a:prstGeom prst="roundRect">
             <a:avLst>
-              <a:gd name="adj" fmla="val 7576"/>
+              <a:gd name="adj" fmla="val 18750"/>
             </a:avLst>
           </a:prstGeom>
           <a:solidFill>
-            <a:srgbClr val="F4F6FB"/>
+            <a:srgbClr val="6849F6"/>
           </a:solidFill>
-          <a:ln w="12700">
+          <a:ln/>
+        </p:spPr>
+      </p:sp>
+      <p:sp>
+        <p:nvSpPr>
+          <p:cNvPr id="19" name="Text 17"/>
+          <p:cNvSpPr/>
+          <p:nvPr/>
+        </p:nvSpPr>
+        <p:spPr>
+          <a:xfrm>
+            <a:off x="502920" y="3383280"/>
+            <a:ext cx="292608" cy="292608"/>
+          </a:xfrm>
+          <a:prstGeom prst="rect">
+            <a:avLst/>
+          </a:prstGeom>
+          <a:noFill/>
+          <a:ln/>
+        </p:spPr>
+        <p:txBody>
+          <a:bodyPr wrap="square" lIns="0" tIns="0" rIns="0" bIns="0" rtlCol="0" anchor="ctr"/>
+          <a:lstStyle/>
+          <a:p>
+            <a:pPr algn="ctr" indent="0" marL="0">
+              <a:buNone/>
+            </a:pPr>
+            <a:r>
+              <a:rPr lang="en-US" sz="1200" b="1" dirty="0">
+                <a:solidFill>
+                  <a:srgbClr val="FFFFFF"/>
+                </a:solidFill>
+                <a:latin typeface="Helvetica" pitchFamily="34" charset="0"/>
+                <a:ea typeface="Helvetica" pitchFamily="34" charset="-122"/>
+                <a:cs typeface="Helvetica" pitchFamily="34" charset="-120"/>
+              </a:rPr>
+              <a:t>3</a:t>
+            </a:r>
+            <a:endParaRPr lang="en-US" sz="1200" dirty="0"/>
+          </a:p>
+        </p:txBody>
+      </p:sp>
+      <p:sp>
+        <p:nvSpPr>
+          <p:cNvPr id="20" name="Text 18"/>
+          <p:cNvSpPr/>
+          <p:nvPr/>
+        </p:nvSpPr>
+        <p:spPr>
+          <a:xfrm>
+            <a:off x="960120" y="3346704"/>
+            <a:ext cx="10195560" cy="420624"/>
+          </a:xfrm>
+          <a:prstGeom prst="rect">
+            <a:avLst/>
+          </a:prstGeom>
+          <a:noFill/>
+          <a:ln/>
+        </p:spPr>
+        <p:txBody>
+          <a:bodyPr wrap="square" lIns="0" tIns="0" rIns="0" bIns="0" rtlCol="0" anchor="ctr"/>
+          <a:lstStyle/>
+          <a:p>
+            <a:pPr indent="0" marL="0">
+              <a:lnSpc>
+                <a:spcPct val="115000"/>
+              </a:lnSpc>
+              <a:buNone/>
+            </a:pPr>
+            <a:r>
+              <a:rPr lang="en-US" sz="1200" b="1" dirty="0">
+                <a:solidFill>
+                  <a:srgbClr val="0D1321"/>
+                </a:solidFill>
+                <a:latin typeface="Helvetica" pitchFamily="34" charset="0"/>
+                <a:ea typeface="Helvetica" pitchFamily="34" charset="-122"/>
+                <a:cs typeface="Helvetica" pitchFamily="34" charset="-120"/>
+              </a:rPr>
+              <a:t>Spesifikasi Jelas  —  </a:t>
+            </a:r>
+            <a:pPr indent="0" marL="0">
+              <a:lnSpc>
+                <a:spcPct val="115000"/>
+              </a:lnSpc>
+              <a:buNone/>
+            </a:pPr>
+            <a:r>
+              <a:rPr lang="en-US" sz="1200" dirty="0">
+                <a:solidFill>
+                  <a:srgbClr val="23283A"/>
+                </a:solidFill>
+                <a:latin typeface="Helvetica" pitchFamily="34" charset="0"/>
+                <a:ea typeface="Helvetica" pitchFamily="34" charset="-122"/>
+                <a:cs typeface="Helvetica" pitchFamily="34" charset="-120"/>
+              </a:rPr>
+              <a:t>Berat, ukuran, varian, cara simpan — kurangi pertanyaan pembeli</a:t>
+            </a:r>
+            <a:endParaRPr lang="en-US" sz="1200" dirty="0"/>
+          </a:p>
+        </p:txBody>
+      </p:sp>
+      <p:sp>
+        <p:nvSpPr>
+          <p:cNvPr id="21" name="Shape 19"/>
+          <p:cNvSpPr/>
+          <p:nvPr/>
+        </p:nvSpPr>
+        <p:spPr>
+          <a:xfrm>
+            <a:off x="649224" y="4133088"/>
+            <a:ext cx="0" cy="164592"/>
+          </a:xfrm>
+          <a:prstGeom prst="line">
+            <a:avLst/>
+          </a:prstGeom>
+          <a:noFill/>
+          <a:ln w="19050">
             <a:solidFill>
               <a:srgbClr val="D6DCEB"/>
             </a:solidFill>
             <a:prstDash val="solid"/>
           </a:ln>
         </p:spPr>
-        <p:txBody>
-          <a:bodyPr/>
-          <a:lstStyle/>
-          <a:p>
-            <a:endParaRPr lang="en-ID"/>
-          </a:p>
-        </p:txBody>
-      </p:sp>
-      <p:sp>
-        <p:nvSpPr>
-          <p:cNvPr id="18" name="Text 16"/>
-          <p:cNvSpPr/>
-          <p:nvPr/>
-        </p:nvSpPr>
-        <p:spPr>
-          <a:xfrm>
-            <a:off x="8485632" y="2231136"/>
-            <a:ext cx="2157984" cy="384048"/>
-          </a:xfrm>
-          <a:prstGeom prst="rect">
-            <a:avLst/>
-          </a:prstGeom>
-          <a:noFill/>
-          <a:ln/>
-        </p:spPr>
-        <p:txBody>
-          <a:bodyPr wrap="square" lIns="0" tIns="0" rIns="0" bIns="0" rtlCol="0" anchor="ctr"/>
-          <a:lstStyle/>
-          <a:p>
-            <a:pPr marL="0" indent="0">
-              <a:buNone/>
-            </a:pPr>
-            <a:r>
-              <a:rPr lang="en-US" sz="1200" b="1" dirty="0">
-                <a:solidFill>
-                  <a:srgbClr val="4B36C7"/>
-                </a:solidFill>
-                <a:latin typeface="Helvetica" pitchFamily="34" charset="0"/>
-                <a:ea typeface="Helvetica" pitchFamily="34" charset="-122"/>
-                <a:cs typeface="Helvetica" pitchFamily="34" charset="-120"/>
-              </a:rPr>
-              <a:t>BENEFIT BUKAN FITUR</a:t>
-            </a:r>
-            <a:endParaRPr lang="en-US" sz="1200" dirty="0"/>
-          </a:p>
-        </p:txBody>
-      </p:sp>
-      <p:sp>
-        <p:nvSpPr>
-          <p:cNvPr id="19" name="Text 17"/>
-          <p:cNvSpPr/>
-          <p:nvPr/>
-        </p:nvSpPr>
-        <p:spPr>
-          <a:xfrm>
-            <a:off x="8485632" y="2587752"/>
-            <a:ext cx="2157984" cy="566928"/>
-          </a:xfrm>
-          <a:prstGeom prst="rect">
-            <a:avLst/>
-          </a:prstGeom>
-          <a:noFill/>
-          <a:ln/>
-        </p:spPr>
-        <p:txBody>
-          <a:bodyPr wrap="square" lIns="0" tIns="0" rIns="0" bIns="0" rtlCol="0" anchor="ctr"/>
-          <a:lstStyle/>
-          <a:p>
-            <a:pPr marL="0" indent="0">
-              <a:lnSpc>
-                <a:spcPct val="120000"/>
-              </a:lnSpc>
-              <a:buNone/>
-            </a:pPr>
-            <a:r>
-              <a:rPr lang="en-US" sz="1100" dirty="0">
-                <a:solidFill>
-                  <a:srgbClr val="23283A"/>
-                </a:solidFill>
-                <a:latin typeface="Helvetica" pitchFamily="34" charset="0"/>
-                <a:ea typeface="Helvetica" pitchFamily="34" charset="-122"/>
-                <a:cs typeface="Helvetica" pitchFamily="34" charset="-120"/>
-              </a:rPr>
-              <a:t>Bukan "350ml" tapi "cukup untuk diminum seharian tanpa isi ulang"</a:t>
-            </a:r>
-            <a:endParaRPr lang="en-US" sz="1100" dirty="0"/>
-          </a:p>
-        </p:txBody>
-      </p:sp>
-      <p:sp>
-        <p:nvSpPr>
-          <p:cNvPr id="20" name="Text 18"/>
-          <p:cNvSpPr/>
-          <p:nvPr/>
-        </p:nvSpPr>
-        <p:spPr>
-          <a:xfrm>
-            <a:off x="502920" y="3456432"/>
-            <a:ext cx="11064240" cy="320040"/>
-          </a:xfrm>
-          <a:prstGeom prst="rect">
-            <a:avLst/>
-          </a:prstGeom>
-          <a:noFill/>
-          <a:ln/>
-        </p:spPr>
-        <p:txBody>
-          <a:bodyPr wrap="square" lIns="0" tIns="0" rIns="0" bIns="0" rtlCol="0" anchor="ctr"/>
-          <a:lstStyle/>
-          <a:p>
-            <a:pPr marL="0" indent="0">
-              <a:buNone/>
-            </a:pPr>
-            <a:r>
-              <a:rPr lang="en-US" sz="1250" dirty="0">
-                <a:solidFill>
-                  <a:srgbClr val="6B7280"/>
-                </a:solidFill>
-                <a:latin typeface="Helvetica" pitchFamily="34" charset="0"/>
-                <a:ea typeface="Helvetica" pitchFamily="34" charset="-122"/>
-                <a:cs typeface="Helvetica" pitchFamily="34" charset="-120"/>
-              </a:rPr>
-              <a:t>Penutup: </a:t>
-            </a:r>
-            <a:r>
-              <a:rPr lang="en-US" sz="1250" b="1" dirty="0">
-                <a:solidFill>
-                  <a:srgbClr val="23283A"/>
-                </a:solidFill>
-                <a:latin typeface="Helvetica" pitchFamily="34" charset="0"/>
-                <a:ea typeface="Helvetica" pitchFamily="34" charset="-122"/>
-                <a:cs typeface="Helvetica" pitchFamily="34" charset="-120"/>
-              </a:rPr>
-              <a:t>CTA yang jelas</a:t>
-            </a:r>
-            <a:r>
-              <a:rPr lang="en-US" sz="1250" dirty="0">
-                <a:solidFill>
-                  <a:srgbClr val="6B7280"/>
-                </a:solidFill>
-                <a:latin typeface="Helvetica" pitchFamily="34" charset="0"/>
-                <a:ea typeface="Helvetica" pitchFamily="34" charset="-122"/>
-                <a:cs typeface="Helvetica" pitchFamily="34" charset="-120"/>
-              </a:rPr>
-              <a:t> — "Tambahkan ke keranjang sekarang" atau "Pesan sebelum stok habis."</a:t>
-            </a:r>
-            <a:endParaRPr lang="en-US" sz="1250" dirty="0"/>
-          </a:p>
-        </p:txBody>
-      </p:sp>
-      <p:sp>
-        <p:nvSpPr>
-          <p:cNvPr id="21" name="Text 19"/>
-          <p:cNvSpPr/>
-          <p:nvPr/>
-        </p:nvSpPr>
-        <p:spPr>
-          <a:xfrm>
-            <a:off x="502920" y="3950208"/>
-            <a:ext cx="11064240" cy="274320"/>
-          </a:xfrm>
-          <a:prstGeom prst="rect">
-            <a:avLst/>
-          </a:prstGeom>
-          <a:noFill/>
-          <a:ln/>
-        </p:spPr>
-        <p:txBody>
-          <a:bodyPr wrap="square" lIns="0" tIns="0" rIns="0" bIns="0" rtlCol="0" anchor="ctr"/>
-          <a:lstStyle/>
-          <a:p>
-            <a:pPr marL="0" indent="0">
-              <a:buNone/>
-            </a:pPr>
-            <a:r>
-              <a:rPr lang="en-US" sz="1250" b="1" kern="0" spc="40" dirty="0">
-                <a:solidFill>
-                  <a:srgbClr val="4B36C7"/>
-                </a:solidFill>
-                <a:latin typeface="Helvetica" pitchFamily="34" charset="0"/>
-                <a:ea typeface="Helvetica" pitchFamily="34" charset="-122"/>
-                <a:cs typeface="Helvetica" pitchFamily="34" charset="-120"/>
-              </a:rPr>
-              <a:t>KESALAHAN UMUM</a:t>
-            </a:r>
-            <a:endParaRPr lang="en-US" sz="1250" dirty="0"/>
-          </a:p>
-        </p:txBody>
       </p:sp>
       <p:sp>
         <p:nvSpPr>
@@ -2077,466 +2219,625 @@
         </p:nvSpPr>
         <p:spPr>
           <a:xfrm>
-            <a:off x="502920" y="4279392"/>
-            <a:ext cx="2487168" cy="566928"/>
+            <a:off x="502920" y="3840480"/>
+            <a:ext cx="292608" cy="292608"/>
           </a:xfrm>
           <a:prstGeom prst="roundRect">
             <a:avLst>
-              <a:gd name="adj" fmla="val 16129"/>
+              <a:gd name="adj" fmla="val 18750"/>
             </a:avLst>
           </a:prstGeom>
           <a:solidFill>
-            <a:srgbClr val="F3F0FF"/>
+            <a:srgbClr val="6849F6"/>
+          </a:solidFill>
+          <a:ln/>
+        </p:spPr>
+      </p:sp>
+      <p:sp>
+        <p:nvSpPr>
+          <p:cNvPr id="23" name="Text 21"/>
+          <p:cNvSpPr/>
+          <p:nvPr/>
+        </p:nvSpPr>
+        <p:spPr>
+          <a:xfrm>
+            <a:off x="502920" y="3840480"/>
+            <a:ext cx="292608" cy="292608"/>
+          </a:xfrm>
+          <a:prstGeom prst="rect">
+            <a:avLst/>
+          </a:prstGeom>
+          <a:noFill/>
+          <a:ln/>
+        </p:spPr>
+        <p:txBody>
+          <a:bodyPr wrap="square" lIns="0" tIns="0" rIns="0" bIns="0" rtlCol="0" anchor="ctr"/>
+          <a:lstStyle/>
+          <a:p>
+            <a:pPr algn="ctr" indent="0" marL="0">
+              <a:buNone/>
+            </a:pPr>
+            <a:r>
+              <a:rPr lang="en-US" sz="1200" b="1" dirty="0">
+                <a:solidFill>
+                  <a:srgbClr val="FFFFFF"/>
+                </a:solidFill>
+                <a:latin typeface="Helvetica" pitchFamily="34" charset="0"/>
+                <a:ea typeface="Helvetica" pitchFamily="34" charset="-122"/>
+                <a:cs typeface="Helvetica" pitchFamily="34" charset="-120"/>
+              </a:rPr>
+              <a:t>4</a:t>
+            </a:r>
+            <a:endParaRPr lang="en-US" sz="1200" dirty="0"/>
+          </a:p>
+        </p:txBody>
+      </p:sp>
+      <p:sp>
+        <p:nvSpPr>
+          <p:cNvPr id="24" name="Text 22"/>
+          <p:cNvSpPr/>
+          <p:nvPr/>
+        </p:nvSpPr>
+        <p:spPr>
+          <a:xfrm>
+            <a:off x="960120" y="3803904"/>
+            <a:ext cx="10195560" cy="420624"/>
+          </a:xfrm>
+          <a:prstGeom prst="rect">
+            <a:avLst/>
+          </a:prstGeom>
+          <a:noFill/>
+          <a:ln/>
+        </p:spPr>
+        <p:txBody>
+          <a:bodyPr wrap="square" lIns="0" tIns="0" rIns="0" bIns="0" rtlCol="0" anchor="ctr"/>
+          <a:lstStyle/>
+          <a:p>
+            <a:pPr indent="0" marL="0">
+              <a:lnSpc>
+                <a:spcPct val="115000"/>
+              </a:lnSpc>
+              <a:buNone/>
+            </a:pPr>
+            <a:r>
+              <a:rPr lang="en-US" sz="1200" b="1" dirty="0">
+                <a:solidFill>
+                  <a:srgbClr val="0D1321"/>
+                </a:solidFill>
+                <a:latin typeface="Helvetica" pitchFamily="34" charset="0"/>
+                <a:ea typeface="Helvetica" pitchFamily="34" charset="-122"/>
+                <a:cs typeface="Helvetica" pitchFamily="34" charset="-120"/>
+              </a:rPr>
+              <a:t>Benefit Bukan Fitur  —  </a:t>
+            </a:r>
+            <a:pPr indent="0" marL="0">
+              <a:lnSpc>
+                <a:spcPct val="115000"/>
+              </a:lnSpc>
+              <a:buNone/>
+            </a:pPr>
+            <a:r>
+              <a:rPr lang="en-US" sz="1200" dirty="0">
+                <a:solidFill>
+                  <a:srgbClr val="23283A"/>
+                </a:solidFill>
+                <a:latin typeface="Helvetica" pitchFamily="34" charset="0"/>
+                <a:ea typeface="Helvetica" pitchFamily="34" charset="-122"/>
+                <a:cs typeface="Helvetica" pitchFamily="34" charset="-120"/>
+              </a:rPr>
+              <a:t>Bukan "350ml" tapi "cukup untuk diminum seharian tanpa isi ulang"</a:t>
+            </a:r>
+            <a:endParaRPr lang="en-US" sz="1200" dirty="0"/>
+          </a:p>
+        </p:txBody>
+      </p:sp>
+      <p:sp>
+        <p:nvSpPr>
+          <p:cNvPr id="25" name="Shape 23"/>
+          <p:cNvSpPr/>
+          <p:nvPr/>
+        </p:nvSpPr>
+        <p:spPr>
+          <a:xfrm>
+            <a:off x="502920" y="4297680"/>
+            <a:ext cx="292608" cy="292608"/>
+          </a:xfrm>
+          <a:prstGeom prst="roundRect">
+            <a:avLst>
+              <a:gd name="adj" fmla="val 18750"/>
+            </a:avLst>
+          </a:prstGeom>
+          <a:solidFill>
+            <a:srgbClr val="6849F6"/>
+          </a:solidFill>
+          <a:ln/>
+        </p:spPr>
+      </p:sp>
+      <p:sp>
+        <p:nvSpPr>
+          <p:cNvPr id="26" name="Text 24"/>
+          <p:cNvSpPr/>
+          <p:nvPr/>
+        </p:nvSpPr>
+        <p:spPr>
+          <a:xfrm>
+            <a:off x="502920" y="4297680"/>
+            <a:ext cx="292608" cy="292608"/>
+          </a:xfrm>
+          <a:prstGeom prst="rect">
+            <a:avLst/>
+          </a:prstGeom>
+          <a:noFill/>
+          <a:ln/>
+        </p:spPr>
+        <p:txBody>
+          <a:bodyPr wrap="square" lIns="0" tIns="0" rIns="0" bIns="0" rtlCol="0" anchor="ctr"/>
+          <a:lstStyle/>
+          <a:p>
+            <a:pPr algn="ctr" indent="0" marL="0">
+              <a:buNone/>
+            </a:pPr>
+            <a:r>
+              <a:rPr lang="en-US" sz="1200" b="1" dirty="0">
+                <a:solidFill>
+                  <a:srgbClr val="FFFFFF"/>
+                </a:solidFill>
+                <a:latin typeface="Helvetica" pitchFamily="34" charset="0"/>
+                <a:ea typeface="Helvetica" pitchFamily="34" charset="-122"/>
+                <a:cs typeface="Helvetica" pitchFamily="34" charset="-120"/>
+              </a:rPr>
+              <a:t>5</a:t>
+            </a:r>
+            <a:endParaRPr lang="en-US" sz="1200" dirty="0"/>
+          </a:p>
+        </p:txBody>
+      </p:sp>
+      <p:sp>
+        <p:nvSpPr>
+          <p:cNvPr id="27" name="Text 25"/>
+          <p:cNvSpPr/>
+          <p:nvPr/>
+        </p:nvSpPr>
+        <p:spPr>
+          <a:xfrm>
+            <a:off x="960120" y="4261104"/>
+            <a:ext cx="10195560" cy="420624"/>
+          </a:xfrm>
+          <a:prstGeom prst="rect">
+            <a:avLst/>
+          </a:prstGeom>
+          <a:noFill/>
+          <a:ln/>
+        </p:spPr>
+        <p:txBody>
+          <a:bodyPr wrap="square" lIns="0" tIns="0" rIns="0" bIns="0" rtlCol="0" anchor="ctr"/>
+          <a:lstStyle/>
+          <a:p>
+            <a:pPr indent="0" marL="0">
+              <a:lnSpc>
+                <a:spcPct val="115000"/>
+              </a:lnSpc>
+              <a:buNone/>
+            </a:pPr>
+            <a:r>
+              <a:rPr lang="en-US" sz="1200" b="1" dirty="0">
+                <a:solidFill>
+                  <a:srgbClr val="0D1321"/>
+                </a:solidFill>
+                <a:latin typeface="Helvetica" pitchFamily="34" charset="0"/>
+                <a:ea typeface="Helvetica" pitchFamily="34" charset="-122"/>
+                <a:cs typeface="Helvetica" pitchFamily="34" charset="-120"/>
+              </a:rPr>
+              <a:t>CTA yang Jelas  —  </a:t>
+            </a:r>
+            <a:pPr indent="0" marL="0">
+              <a:lnSpc>
+                <a:spcPct val="115000"/>
+              </a:lnSpc>
+              <a:buNone/>
+            </a:pPr>
+            <a:r>
+              <a:rPr lang="en-US" sz="1200" dirty="0">
+                <a:solidFill>
+                  <a:srgbClr val="23283A"/>
+                </a:solidFill>
+                <a:latin typeface="Helvetica" pitchFamily="34" charset="0"/>
+                <a:ea typeface="Helvetica" pitchFamily="34" charset="-122"/>
+                <a:cs typeface="Helvetica" pitchFamily="34" charset="-120"/>
+              </a:rPr>
+              <a:t>"Tambahkan ke keranjang sekarang" atau "Pesan sebelum stok habis"</a:t>
+            </a:r>
+            <a:endParaRPr lang="en-US" sz="1200" dirty="0"/>
+          </a:p>
+        </p:txBody>
+      </p:sp>
+      <p:sp>
+        <p:nvSpPr>
+          <p:cNvPr id="28" name="Shape 26"/>
+          <p:cNvSpPr/>
+          <p:nvPr/>
+        </p:nvSpPr>
+        <p:spPr>
+          <a:xfrm>
+            <a:off x="502920" y="4937760"/>
+            <a:ext cx="11064240" cy="1691640"/>
+          </a:xfrm>
+          <a:prstGeom prst="roundRect">
+            <a:avLst>
+              <a:gd name="adj" fmla="val 5405"/>
+            </a:avLst>
+          </a:prstGeom>
+          <a:solidFill>
+            <a:srgbClr val="FFF6F6"/>
           </a:solidFill>
           <a:ln w="12700">
             <a:solidFill>
-              <a:srgbClr val="DCD3FB"/>
+              <a:srgbClr val="F3C6C6"/>
             </a:solidFill>
             <a:prstDash val="solid"/>
           </a:ln>
         </p:spPr>
-        <p:txBody>
-          <a:bodyPr/>
-          <a:lstStyle/>
-          <a:p>
-            <a:endParaRPr lang="en-ID"/>
-          </a:p>
-        </p:txBody>
-      </p:sp>
-      <p:sp>
-        <p:nvSpPr>
-          <p:cNvPr id="23" name="Text 21"/>
-          <p:cNvSpPr/>
-          <p:nvPr/>
-        </p:nvSpPr>
-        <p:spPr>
-          <a:xfrm>
-            <a:off x="640080" y="4279392"/>
-            <a:ext cx="2212848" cy="566928"/>
-          </a:xfrm>
-          <a:prstGeom prst="rect">
-            <a:avLst/>
-          </a:prstGeom>
-          <a:noFill/>
-          <a:ln/>
-        </p:spPr>
-        <p:txBody>
-          <a:bodyPr wrap="square" lIns="0" tIns="0" rIns="0" bIns="0" rtlCol="0" anchor="ctr"/>
-          <a:lstStyle/>
-          <a:p>
-            <a:pPr marL="0" indent="0">
+      </p:sp>
+      <p:sp>
+        <p:nvSpPr>
+          <p:cNvPr id="29" name="Text 27"/>
+          <p:cNvSpPr/>
+          <p:nvPr/>
+        </p:nvSpPr>
+        <p:spPr>
+          <a:xfrm>
+            <a:off x="713232" y="5084064"/>
+            <a:ext cx="10607040" cy="274320"/>
+          </a:xfrm>
+          <a:prstGeom prst="rect">
+            <a:avLst/>
+          </a:prstGeom>
+          <a:noFill/>
+          <a:ln/>
+        </p:spPr>
+        <p:txBody>
+          <a:bodyPr wrap="square" lIns="0" tIns="0" rIns="0" bIns="0" rtlCol="0" anchor="ctr"/>
+          <a:lstStyle/>
+          <a:p>
+            <a:pPr indent="0" marL="0">
+              <a:buNone/>
+            </a:pPr>
+            <a:r>
+              <a:rPr lang="en-US" sz="1250" b="1" spc="40" kern="0" dirty="0">
+                <a:solidFill>
+                  <a:srgbClr val="DC2626"/>
+                </a:solidFill>
+                <a:latin typeface="Helvetica" pitchFamily="34" charset="0"/>
+                <a:ea typeface="Helvetica" pitchFamily="34" charset="-122"/>
+                <a:cs typeface="Helvetica" pitchFamily="34" charset="-120"/>
+              </a:rPr>
+              <a:t>KESALAHAN UMUM</a:t>
+            </a:r>
+            <a:endParaRPr lang="en-US" sz="1250" dirty="0"/>
+          </a:p>
+        </p:txBody>
+      </p:sp>
+      <p:sp>
+        <p:nvSpPr>
+          <p:cNvPr id="30" name="Text 28"/>
+          <p:cNvSpPr/>
+          <p:nvPr/>
+        </p:nvSpPr>
+        <p:spPr>
+          <a:xfrm>
+            <a:off x="713232" y="5385816"/>
+            <a:ext cx="219456" cy="274320"/>
+          </a:xfrm>
+          <a:prstGeom prst="rect">
+            <a:avLst/>
+          </a:prstGeom>
+          <a:noFill/>
+          <a:ln/>
+        </p:spPr>
+        <p:txBody>
+          <a:bodyPr wrap="square" lIns="0" tIns="0" rIns="0" bIns="0" rtlCol="0" anchor="ctr"/>
+          <a:lstStyle/>
+          <a:p>
+            <a:pPr indent="0" marL="0">
+              <a:buNone/>
+            </a:pPr>
+            <a:r>
+              <a:rPr lang="en-US" sz="1300" b="1" dirty="0">
+                <a:solidFill>
+                  <a:srgbClr val="DC2626"/>
+                </a:solidFill>
+                <a:latin typeface="Helvetica" pitchFamily="34" charset="0"/>
+                <a:ea typeface="Helvetica" pitchFamily="34" charset="-122"/>
+                <a:cs typeface="Helvetica" pitchFamily="34" charset="-120"/>
+              </a:rPr>
+              <a:t>×</a:t>
+            </a:r>
+            <a:endParaRPr lang="en-US" sz="1300" dirty="0"/>
+          </a:p>
+        </p:txBody>
+      </p:sp>
+      <p:sp>
+        <p:nvSpPr>
+          <p:cNvPr id="31" name="Text 29"/>
+          <p:cNvSpPr/>
+          <p:nvPr/>
+        </p:nvSpPr>
+        <p:spPr>
+          <a:xfrm>
+            <a:off x="950976" y="5358384"/>
+            <a:ext cx="10378440" cy="329184"/>
+          </a:xfrm>
+          <a:prstGeom prst="rect">
+            <a:avLst/>
+          </a:prstGeom>
+          <a:noFill/>
+          <a:ln/>
+        </p:spPr>
+        <p:txBody>
+          <a:bodyPr wrap="square" lIns="0" tIns="0" rIns="0" bIns="0" rtlCol="0" anchor="ctr"/>
+          <a:lstStyle/>
+          <a:p>
+            <a:pPr indent="0" marL="0">
               <a:lnSpc>
-                <a:spcPct val="110000"/>
+                <a:spcPct val="115000"/>
               </a:lnSpc>
               <a:buNone/>
             </a:pPr>
             <a:r>
-              <a:rPr lang="en-US" sz="1050" b="1" dirty="0">
-                <a:solidFill>
-                  <a:srgbClr val="4B36C7"/>
-                </a:solidFill>
-                <a:latin typeface="Helvetica" pitchFamily="34" charset="0"/>
-                <a:ea typeface="Helvetica" pitchFamily="34" charset="-122"/>
-                <a:cs typeface="Helvetica" pitchFamily="34" charset="-120"/>
-              </a:rPr>
-              <a:t>Deskripsi salinan</a:t>
-            </a:r>
-            <a:endParaRPr lang="en-US" sz="1050" dirty="0"/>
-          </a:p>
-          <a:p>
-            <a:pPr marL="0" indent="0">
+              <a:rPr lang="en-US" sz="1100" dirty="0">
+                <a:solidFill>
+                  <a:srgbClr val="7A3B3B"/>
+                </a:solidFill>
+                <a:latin typeface="Helvetica" pitchFamily="34" charset="0"/>
+                <a:ea typeface="Helvetica" pitchFamily="34" charset="-122"/>
+                <a:cs typeface="Helvetica" pitchFamily="34" charset="-120"/>
+              </a:rPr>
+              <a:t>Deskripsi salinan dari supplier — sama persis dengan ratusan toko lain, tidak bisa ranking</a:t>
+            </a:r>
+            <a:endParaRPr lang="en-US" sz="1100" dirty="0"/>
+          </a:p>
+        </p:txBody>
+      </p:sp>
+      <p:sp>
+        <p:nvSpPr>
+          <p:cNvPr id="32" name="Text 30"/>
+          <p:cNvSpPr/>
+          <p:nvPr/>
+        </p:nvSpPr>
+        <p:spPr>
+          <a:xfrm>
+            <a:off x="713232" y="5682996"/>
+            <a:ext cx="219456" cy="274320"/>
+          </a:xfrm>
+          <a:prstGeom prst="rect">
+            <a:avLst/>
+          </a:prstGeom>
+          <a:noFill/>
+          <a:ln/>
+        </p:spPr>
+        <p:txBody>
+          <a:bodyPr wrap="square" lIns="0" tIns="0" rIns="0" bIns="0" rtlCol="0" anchor="ctr"/>
+          <a:lstStyle/>
+          <a:p>
+            <a:pPr indent="0" marL="0">
+              <a:buNone/>
+            </a:pPr>
+            <a:r>
+              <a:rPr lang="en-US" sz="1300" b="1" dirty="0">
+                <a:solidFill>
+                  <a:srgbClr val="DC2626"/>
+                </a:solidFill>
+                <a:latin typeface="Helvetica" pitchFamily="34" charset="0"/>
+                <a:ea typeface="Helvetica" pitchFamily="34" charset="-122"/>
+                <a:cs typeface="Helvetica" pitchFamily="34" charset="-120"/>
+              </a:rPr>
+              <a:t>×</a:t>
+            </a:r>
+            <a:endParaRPr lang="en-US" sz="1300" dirty="0"/>
+          </a:p>
+        </p:txBody>
+      </p:sp>
+      <p:sp>
+        <p:nvSpPr>
+          <p:cNvPr id="33" name="Text 31"/>
+          <p:cNvSpPr/>
+          <p:nvPr/>
+        </p:nvSpPr>
+        <p:spPr>
+          <a:xfrm>
+            <a:off x="950976" y="5655564"/>
+            <a:ext cx="10378440" cy="329184"/>
+          </a:xfrm>
+          <a:prstGeom prst="rect">
+            <a:avLst/>
+          </a:prstGeom>
+          <a:noFill/>
+          <a:ln/>
+        </p:spPr>
+        <p:txBody>
+          <a:bodyPr wrap="square" lIns="0" tIns="0" rIns="0" bIns="0" rtlCol="0" anchor="ctr"/>
+          <a:lstStyle/>
+          <a:p>
+            <a:pPr indent="0" marL="0">
               <a:lnSpc>
-                <a:spcPct val="110000"/>
+                <a:spcPct val="115000"/>
               </a:lnSpc>
               <a:buNone/>
             </a:pPr>
             <a:r>
-              <a:rPr lang="en-US" sz="1050" b="1" dirty="0">
-                <a:solidFill>
-                  <a:srgbClr val="4B36C7"/>
-                </a:solidFill>
-                <a:latin typeface="Helvetica" pitchFamily="34" charset="0"/>
-                <a:ea typeface="Helvetica" pitchFamily="34" charset="-122"/>
-                <a:cs typeface="Helvetica" pitchFamily="34" charset="-120"/>
-              </a:rPr>
-              <a:t>dari supplier</a:t>
-            </a:r>
-            <a:endParaRPr lang="en-US" sz="1050" dirty="0"/>
-          </a:p>
-        </p:txBody>
-      </p:sp>
-      <p:sp>
-        <p:nvSpPr>
-          <p:cNvPr id="24" name="Shape 22"/>
-          <p:cNvSpPr/>
-          <p:nvPr/>
-        </p:nvSpPr>
-        <p:spPr>
-          <a:xfrm>
-            <a:off x="3108960" y="4279392"/>
-            <a:ext cx="2487168" cy="566928"/>
-          </a:xfrm>
-          <a:prstGeom prst="roundRect">
-            <a:avLst>
-              <a:gd name="adj" fmla="val 16129"/>
-            </a:avLst>
-          </a:prstGeom>
-          <a:solidFill>
-            <a:srgbClr val="F3F0FF"/>
-          </a:solidFill>
-          <a:ln w="12700">
-            <a:solidFill>
-              <a:srgbClr val="DCD3FB"/>
-            </a:solidFill>
-            <a:prstDash val="solid"/>
-          </a:ln>
-        </p:spPr>
-        <p:txBody>
-          <a:bodyPr/>
-          <a:lstStyle/>
-          <a:p>
-            <a:endParaRPr lang="en-ID"/>
-          </a:p>
-        </p:txBody>
-      </p:sp>
-      <p:sp>
-        <p:nvSpPr>
-          <p:cNvPr id="25" name="Text 23"/>
-          <p:cNvSpPr/>
-          <p:nvPr/>
-        </p:nvSpPr>
-        <p:spPr>
-          <a:xfrm>
-            <a:off x="3246120" y="4279392"/>
-            <a:ext cx="2212848" cy="566928"/>
-          </a:xfrm>
-          <a:prstGeom prst="rect">
-            <a:avLst/>
-          </a:prstGeom>
-          <a:noFill/>
-          <a:ln/>
-        </p:spPr>
-        <p:txBody>
-          <a:bodyPr wrap="square" lIns="0" tIns="0" rIns="0" bIns="0" rtlCol="0" anchor="ctr"/>
-          <a:lstStyle/>
-          <a:p>
-            <a:pPr marL="0" indent="0">
+              <a:rPr lang="en-US" sz="1100" dirty="0">
+                <a:solidFill>
+                  <a:srgbClr val="7A3B3B"/>
+                </a:solidFill>
+                <a:latin typeface="Helvetica" pitchFamily="34" charset="0"/>
+                <a:ea typeface="Helvetica" pitchFamily="34" charset="-122"/>
+                <a:cs typeface="Helvetica" pitchFamily="34" charset="-120"/>
+              </a:rPr>
+              <a:t>Terlalu fokus fitur teknis — pembeli peduli manfaat, bukan bahan apa</a:t>
+            </a:r>
+            <a:endParaRPr lang="en-US" sz="1100" dirty="0"/>
+          </a:p>
+        </p:txBody>
+      </p:sp>
+      <p:sp>
+        <p:nvSpPr>
+          <p:cNvPr id="34" name="Text 32"/>
+          <p:cNvSpPr/>
+          <p:nvPr/>
+        </p:nvSpPr>
+        <p:spPr>
+          <a:xfrm>
+            <a:off x="713232" y="5980176"/>
+            <a:ext cx="219456" cy="274320"/>
+          </a:xfrm>
+          <a:prstGeom prst="rect">
+            <a:avLst/>
+          </a:prstGeom>
+          <a:noFill/>
+          <a:ln/>
+        </p:spPr>
+        <p:txBody>
+          <a:bodyPr wrap="square" lIns="0" tIns="0" rIns="0" bIns="0" rtlCol="0" anchor="ctr"/>
+          <a:lstStyle/>
+          <a:p>
+            <a:pPr indent="0" marL="0">
+              <a:buNone/>
+            </a:pPr>
+            <a:r>
+              <a:rPr lang="en-US" sz="1300" b="1" dirty="0">
+                <a:solidFill>
+                  <a:srgbClr val="DC2626"/>
+                </a:solidFill>
+                <a:latin typeface="Helvetica" pitchFamily="34" charset="0"/>
+                <a:ea typeface="Helvetica" pitchFamily="34" charset="-122"/>
+                <a:cs typeface="Helvetica" pitchFamily="34" charset="-120"/>
+              </a:rPr>
+              <a:t>×</a:t>
+            </a:r>
+            <a:endParaRPr lang="en-US" sz="1300" dirty="0"/>
+          </a:p>
+        </p:txBody>
+      </p:sp>
+      <p:sp>
+        <p:nvSpPr>
+          <p:cNvPr id="35" name="Text 33"/>
+          <p:cNvSpPr/>
+          <p:nvPr/>
+        </p:nvSpPr>
+        <p:spPr>
+          <a:xfrm>
+            <a:off x="950976" y="5952744"/>
+            <a:ext cx="10378440" cy="329184"/>
+          </a:xfrm>
+          <a:prstGeom prst="rect">
+            <a:avLst/>
+          </a:prstGeom>
+          <a:noFill/>
+          <a:ln/>
+        </p:spPr>
+        <p:txBody>
+          <a:bodyPr wrap="square" lIns="0" tIns="0" rIns="0" bIns="0" rtlCol="0" anchor="ctr"/>
+          <a:lstStyle/>
+          <a:p>
+            <a:pPr indent="0" marL="0">
               <a:lnSpc>
-                <a:spcPct val="110000"/>
+                <a:spcPct val="115000"/>
               </a:lnSpc>
               <a:buNone/>
             </a:pPr>
             <a:r>
-              <a:rPr lang="en-US" sz="1050" b="1" dirty="0">
-                <a:solidFill>
-                  <a:srgbClr val="4B36C7"/>
-                </a:solidFill>
-                <a:latin typeface="Helvetica" pitchFamily="34" charset="0"/>
-                <a:ea typeface="Helvetica" pitchFamily="34" charset="-122"/>
-                <a:cs typeface="Helvetica" pitchFamily="34" charset="-120"/>
-              </a:rPr>
-              <a:t>Terlalu fokus</a:t>
-            </a:r>
-            <a:endParaRPr lang="en-US" sz="1050" dirty="0"/>
-          </a:p>
-          <a:p>
-            <a:pPr marL="0" indent="0">
+              <a:rPr lang="en-US" sz="1100" dirty="0">
+                <a:solidFill>
+                  <a:srgbClr val="7A3B3B"/>
+                </a:solidFill>
+                <a:latin typeface="Helvetica" pitchFamily="34" charset="0"/>
+                <a:ea typeface="Helvetica" pitchFamily="34" charset="-122"/>
+                <a:cs typeface="Helvetica" pitchFamily="34" charset="-120"/>
+              </a:rPr>
+              <a:t>Tidak ada keyword — deskripsi bagus tapi tidak ketemu di search</a:t>
+            </a:r>
+            <a:endParaRPr lang="en-US" sz="1100" dirty="0"/>
+          </a:p>
+        </p:txBody>
+      </p:sp>
+      <p:sp>
+        <p:nvSpPr>
+          <p:cNvPr id="36" name="Text 34"/>
+          <p:cNvSpPr/>
+          <p:nvPr/>
+        </p:nvSpPr>
+        <p:spPr>
+          <a:xfrm>
+            <a:off x="713232" y="6277356"/>
+            <a:ext cx="219456" cy="274320"/>
+          </a:xfrm>
+          <a:prstGeom prst="rect">
+            <a:avLst/>
+          </a:prstGeom>
+          <a:noFill/>
+          <a:ln/>
+        </p:spPr>
+        <p:txBody>
+          <a:bodyPr wrap="square" lIns="0" tIns="0" rIns="0" bIns="0" rtlCol="0" anchor="ctr"/>
+          <a:lstStyle/>
+          <a:p>
+            <a:pPr indent="0" marL="0">
+              <a:buNone/>
+            </a:pPr>
+            <a:r>
+              <a:rPr lang="en-US" sz="1300" b="1" dirty="0">
+                <a:solidFill>
+                  <a:srgbClr val="DC2626"/>
+                </a:solidFill>
+                <a:latin typeface="Helvetica" pitchFamily="34" charset="0"/>
+                <a:ea typeface="Helvetica" pitchFamily="34" charset="-122"/>
+                <a:cs typeface="Helvetica" pitchFamily="34" charset="-120"/>
+              </a:rPr>
+              <a:t>×</a:t>
+            </a:r>
+            <a:endParaRPr lang="en-US" sz="1300" dirty="0"/>
+          </a:p>
+        </p:txBody>
+      </p:sp>
+      <p:sp>
+        <p:nvSpPr>
+          <p:cNvPr id="37" name="Text 35"/>
+          <p:cNvSpPr/>
+          <p:nvPr/>
+        </p:nvSpPr>
+        <p:spPr>
+          <a:xfrm>
+            <a:off x="950976" y="6249924"/>
+            <a:ext cx="10378440" cy="329184"/>
+          </a:xfrm>
+          <a:prstGeom prst="rect">
+            <a:avLst/>
+          </a:prstGeom>
+          <a:noFill/>
+          <a:ln/>
+        </p:spPr>
+        <p:txBody>
+          <a:bodyPr wrap="square" lIns="0" tIns="0" rIns="0" bIns="0" rtlCol="0" anchor="ctr"/>
+          <a:lstStyle/>
+          <a:p>
+            <a:pPr indent="0" marL="0">
               <a:lnSpc>
-                <a:spcPct val="110000"/>
+                <a:spcPct val="115000"/>
               </a:lnSpc>
               <a:buNone/>
             </a:pPr>
             <a:r>
-              <a:rPr lang="en-US" sz="1050" b="1" dirty="0">
-                <a:solidFill>
-                  <a:srgbClr val="4B36C7"/>
-                </a:solidFill>
-                <a:latin typeface="Helvetica" pitchFamily="34" charset="0"/>
-                <a:ea typeface="Helvetica" pitchFamily="34" charset="-122"/>
-                <a:cs typeface="Helvetica" pitchFamily="34" charset="-120"/>
-              </a:rPr>
-              <a:t>fitur teknis</a:t>
-            </a:r>
-            <a:endParaRPr lang="en-US" sz="1050" dirty="0"/>
-          </a:p>
-        </p:txBody>
-      </p:sp>
-      <p:sp>
-        <p:nvSpPr>
-          <p:cNvPr id="26" name="Shape 24"/>
-          <p:cNvSpPr/>
-          <p:nvPr/>
-        </p:nvSpPr>
-        <p:spPr>
-          <a:xfrm>
-            <a:off x="5715000" y="4279392"/>
-            <a:ext cx="2487168" cy="566928"/>
-          </a:xfrm>
-          <a:prstGeom prst="roundRect">
-            <a:avLst>
-              <a:gd name="adj" fmla="val 16129"/>
-            </a:avLst>
-          </a:prstGeom>
-          <a:solidFill>
-            <a:srgbClr val="F3F0FF"/>
-          </a:solidFill>
-          <a:ln w="12700">
-            <a:solidFill>
-              <a:srgbClr val="DCD3FB"/>
-            </a:solidFill>
-            <a:prstDash val="solid"/>
-          </a:ln>
-        </p:spPr>
-        <p:txBody>
-          <a:bodyPr/>
-          <a:lstStyle/>
-          <a:p>
-            <a:endParaRPr lang="en-ID"/>
-          </a:p>
-        </p:txBody>
-      </p:sp>
-      <p:sp>
-        <p:nvSpPr>
-          <p:cNvPr id="27" name="Text 25"/>
-          <p:cNvSpPr/>
-          <p:nvPr/>
-        </p:nvSpPr>
-        <p:spPr>
-          <a:xfrm>
-            <a:off x="5852160" y="4279392"/>
-            <a:ext cx="2212848" cy="566928"/>
-          </a:xfrm>
-          <a:prstGeom prst="rect">
-            <a:avLst/>
-          </a:prstGeom>
-          <a:noFill/>
-          <a:ln/>
-        </p:spPr>
-        <p:txBody>
-          <a:bodyPr wrap="square" lIns="0" tIns="0" rIns="0" bIns="0" rtlCol="0" anchor="ctr"/>
-          <a:lstStyle/>
-          <a:p>
-            <a:pPr marL="0" indent="0">
-              <a:lnSpc>
-                <a:spcPct val="110000"/>
-              </a:lnSpc>
-              <a:buNone/>
-            </a:pPr>
-            <a:r>
-              <a:rPr lang="en-US" sz="1050" b="1" dirty="0">
-                <a:solidFill>
-                  <a:srgbClr val="4B36C7"/>
-                </a:solidFill>
-                <a:latin typeface="Helvetica" pitchFamily="34" charset="0"/>
-                <a:ea typeface="Helvetica" pitchFamily="34" charset="-122"/>
-                <a:cs typeface="Helvetica" pitchFamily="34" charset="-120"/>
-              </a:rPr>
-              <a:t>Tidak ada</a:t>
-            </a:r>
-            <a:endParaRPr lang="en-US" sz="1050" dirty="0"/>
-          </a:p>
-          <a:p>
-            <a:pPr marL="0" indent="0">
-              <a:lnSpc>
-                <a:spcPct val="110000"/>
-              </a:lnSpc>
-              <a:buNone/>
-            </a:pPr>
-            <a:r>
-              <a:rPr lang="en-US" sz="1050" b="1" dirty="0">
-                <a:solidFill>
-                  <a:srgbClr val="4B36C7"/>
-                </a:solidFill>
-                <a:latin typeface="Helvetica" pitchFamily="34" charset="0"/>
-                <a:ea typeface="Helvetica" pitchFamily="34" charset="-122"/>
-                <a:cs typeface="Helvetica" pitchFamily="34" charset="-120"/>
-              </a:rPr>
-              <a:t>keyword</a:t>
-            </a:r>
-            <a:endParaRPr lang="en-US" sz="1050" dirty="0"/>
-          </a:p>
-        </p:txBody>
-      </p:sp>
-      <p:sp>
-        <p:nvSpPr>
-          <p:cNvPr id="28" name="Shape 26"/>
-          <p:cNvSpPr/>
-          <p:nvPr/>
-        </p:nvSpPr>
-        <p:spPr>
-          <a:xfrm>
-            <a:off x="8321040" y="4279392"/>
-            <a:ext cx="2487168" cy="566928"/>
-          </a:xfrm>
-          <a:prstGeom prst="roundRect">
-            <a:avLst>
-              <a:gd name="adj" fmla="val 16129"/>
-            </a:avLst>
-          </a:prstGeom>
-          <a:solidFill>
-            <a:srgbClr val="F3F0FF"/>
-          </a:solidFill>
-          <a:ln w="12700">
-            <a:solidFill>
-              <a:srgbClr val="DCD3FB"/>
-            </a:solidFill>
-            <a:prstDash val="solid"/>
-          </a:ln>
-        </p:spPr>
-        <p:txBody>
-          <a:bodyPr/>
-          <a:lstStyle/>
-          <a:p>
-            <a:endParaRPr lang="en-ID"/>
-          </a:p>
-        </p:txBody>
-      </p:sp>
-      <p:sp>
-        <p:nvSpPr>
-          <p:cNvPr id="29" name="Text 27"/>
-          <p:cNvSpPr/>
-          <p:nvPr/>
-        </p:nvSpPr>
-        <p:spPr>
-          <a:xfrm>
-            <a:off x="8458200" y="4279392"/>
-            <a:ext cx="2212848" cy="566928"/>
-          </a:xfrm>
-          <a:prstGeom prst="rect">
-            <a:avLst/>
-          </a:prstGeom>
-          <a:noFill/>
-          <a:ln/>
-        </p:spPr>
-        <p:txBody>
-          <a:bodyPr wrap="square" lIns="0" tIns="0" rIns="0" bIns="0" rtlCol="0" anchor="ctr"/>
-          <a:lstStyle/>
-          <a:p>
-            <a:pPr marL="0" indent="0">
-              <a:lnSpc>
-                <a:spcPct val="110000"/>
-              </a:lnSpc>
-              <a:buNone/>
-            </a:pPr>
-            <a:r>
-              <a:rPr lang="en-US" sz="1050" b="1" dirty="0">
-                <a:solidFill>
-                  <a:srgbClr val="4B36C7"/>
-                </a:solidFill>
-                <a:latin typeface="Helvetica" pitchFamily="34" charset="0"/>
-                <a:ea typeface="Helvetica" pitchFamily="34" charset="-122"/>
-                <a:cs typeface="Helvetica" pitchFamily="34" charset="-120"/>
-              </a:rPr>
-              <a:t>Panjang tanpa</a:t>
-            </a:r>
-            <a:endParaRPr lang="en-US" sz="1050" dirty="0"/>
-          </a:p>
-          <a:p>
-            <a:pPr marL="0" indent="0">
-              <a:lnSpc>
-                <a:spcPct val="110000"/>
-              </a:lnSpc>
-              <a:buNone/>
-            </a:pPr>
-            <a:r>
-              <a:rPr lang="en-US" sz="1050" b="1" dirty="0">
-                <a:solidFill>
-                  <a:srgbClr val="4B36C7"/>
-                </a:solidFill>
-                <a:latin typeface="Helvetica" pitchFamily="34" charset="0"/>
-                <a:ea typeface="Helvetica" pitchFamily="34" charset="-122"/>
-                <a:cs typeface="Helvetica" pitchFamily="34" charset="-120"/>
-              </a:rPr>
-              <a:t>struktur</a:t>
-            </a:r>
-            <a:endParaRPr lang="en-US" sz="1050" dirty="0"/>
-          </a:p>
-        </p:txBody>
-      </p:sp>
-      <p:sp>
-        <p:nvSpPr>
-          <p:cNvPr id="30" name="Shape 28"/>
-          <p:cNvSpPr/>
-          <p:nvPr/>
-        </p:nvSpPr>
-        <p:spPr>
-          <a:xfrm>
-            <a:off x="502920" y="5029200"/>
-            <a:ext cx="11064240" cy="1234440"/>
-          </a:xfrm>
-          <a:prstGeom prst="roundRect">
-            <a:avLst>
-              <a:gd name="adj" fmla="val 7407"/>
-            </a:avLst>
-          </a:prstGeom>
-          <a:solidFill>
-            <a:srgbClr val="F3F0FF"/>
-          </a:solidFill>
-          <a:ln w="12700">
-            <a:solidFill>
-              <a:srgbClr val="DCD3FB"/>
-            </a:solidFill>
-            <a:prstDash val="solid"/>
-          </a:ln>
-        </p:spPr>
-        <p:txBody>
-          <a:bodyPr/>
-          <a:lstStyle/>
-          <a:p>
-            <a:endParaRPr lang="en-ID"/>
-          </a:p>
-        </p:txBody>
-      </p:sp>
-      <p:sp>
-        <p:nvSpPr>
-          <p:cNvPr id="31" name="Text 29"/>
-          <p:cNvSpPr/>
-          <p:nvPr/>
-        </p:nvSpPr>
-        <p:spPr>
-          <a:xfrm>
-            <a:off x="713232" y="5029200"/>
-            <a:ext cx="10643616" cy="1234440"/>
-          </a:xfrm>
-          <a:prstGeom prst="rect">
-            <a:avLst/>
-          </a:prstGeom>
-          <a:noFill/>
-          <a:ln/>
-        </p:spPr>
-        <p:txBody>
-          <a:bodyPr wrap="square" lIns="0" tIns="0" rIns="0" bIns="0" rtlCol="0" anchor="ctr"/>
-          <a:lstStyle/>
-          <a:p>
-            <a:pPr marL="0" indent="0">
-              <a:lnSpc>
-                <a:spcPct val="125000"/>
-              </a:lnSpc>
-              <a:buNone/>
-            </a:pPr>
-            <a:r>
-              <a:rPr lang="en-US" sz="1250" b="1" dirty="0">
-                <a:solidFill>
-                  <a:srgbClr val="4B36C7"/>
-                </a:solidFill>
-                <a:latin typeface="Helvetica" pitchFamily="34" charset="0"/>
-                <a:ea typeface="Helvetica" pitchFamily="34" charset="-122"/>
-                <a:cs typeface="Helvetica" pitchFamily="34" charset="-120"/>
-              </a:rPr>
-              <a:t>◆  YANG KAMU BUTUHKAN  </a:t>
-            </a:r>
-            <a:r>
-              <a:rPr lang="en-US" sz="1250" dirty="0">
-                <a:solidFill>
-                  <a:srgbClr val="23283A"/>
-                </a:solidFill>
-                <a:latin typeface="Helvetica" pitchFamily="34" charset="0"/>
-                <a:ea typeface="Helvetica" pitchFamily="34" charset="-122"/>
-                <a:cs typeface="Helvetica" pitchFamily="34" charset="-120"/>
-              </a:rPr>
-              <a:t>file cm-data-produk.csv (isi minimal 5 produk) dan akun Tokopedia/Shopee aktif. Upload CSV-nya ke Project Knowledge — otomatis dipakai lagi di Modul 3-5, dan positioning dari Modul 1 pun sudah tersedia otomatis.</a:t>
-            </a:r>
-            <a:endParaRPr lang="en-US" sz="1250" dirty="0"/>
+              <a:rPr lang="en-US" sz="1100" dirty="0">
+                <a:solidFill>
+                  <a:srgbClr val="7A3B3B"/>
+                </a:solidFill>
+                <a:latin typeface="Helvetica" pitchFamily="34" charset="0"/>
+                <a:ea typeface="Helvetica" pitchFamily="34" charset="-122"/>
+                <a:cs typeface="Helvetica" pitchFamily="34" charset="-120"/>
+              </a:rPr>
+              <a:t>Panjang tanpa struktur — pembeli marketplace scan dalam 5 detik</a:t>
+            </a:r>
+            <a:endParaRPr lang="en-US" sz="1100" dirty="0"/>
           </a:p>
         </p:txBody>
       </p:sp>
@@ -2584,13 +2885,6 @@
           </a:solidFill>
           <a:ln/>
         </p:spPr>
-        <p:txBody>
-          <a:bodyPr/>
-          <a:lstStyle/>
-          <a:p>
-            <a:endParaRPr lang="en-ID"/>
-          </a:p>
-        </p:txBody>
       </p:sp>
       <p:sp>
         <p:nvSpPr>
@@ -2611,13 +2905,6 @@
           </a:solidFill>
           <a:ln/>
         </p:spPr>
-        <p:txBody>
-          <a:bodyPr/>
-          <a:lstStyle/>
-          <a:p>
-            <a:endParaRPr lang="en-ID"/>
-          </a:p>
-        </p:txBody>
       </p:sp>
       <p:sp>
         <p:nvSpPr>
@@ -2640,7 +2927,7 @@
           <a:bodyPr wrap="square" lIns="0" tIns="0" rIns="0" bIns="0" rtlCol="0" anchor="ctr"/>
           <a:lstStyle/>
           <a:p>
-            <a:pPr marL="0" indent="0">
+            <a:pPr indent="0" marL="0">
               <a:buNone/>
             </a:pPr>
             <a:r>
@@ -2654,6 +2941,9 @@
               </a:rPr>
               <a:t>belajar</a:t>
             </a:r>
+            <a:pPr indent="0" marL="0">
+              <a:buNone/>
+            </a:pPr>
             <a:r>
               <a:rPr lang="en-US" sz="2000" b="1" dirty="0">
                 <a:solidFill>
@@ -2690,7 +2980,7 @@
           <a:bodyPr wrap="square" lIns="0" tIns="0" rIns="0" bIns="0" rtlCol="0" anchor="ctr"/>
           <a:lstStyle/>
           <a:p>
-            <a:pPr marL="0" indent="0" algn="r">
+            <a:pPr algn="r" indent="0" marL="0">
               <a:buNone/>
             </a:pPr>
             <a:r>
@@ -2729,11 +3019,11 @@
           <a:bodyPr wrap="square" lIns="0" tIns="0" rIns="0" bIns="0" rtlCol="0" anchor="ctr"/>
           <a:lstStyle/>
           <a:p>
-            <a:pPr marL="0" indent="0">
-              <a:buNone/>
-            </a:pPr>
-            <a:r>
-              <a:rPr lang="en-US" sz="1250" b="1" kern="0" spc="40" dirty="0">
+            <a:pPr indent="0" marL="0">
+              <a:buNone/>
+            </a:pPr>
+            <a:r>
+              <a:rPr lang="en-US" sz="1250" b="1" spc="40" kern="0" dirty="0">
                 <a:solidFill>
                   <a:srgbClr val="4B36C7"/>
                 </a:solidFill>
@@ -2768,7 +3058,7 @@
           <a:bodyPr wrap="square" lIns="0" tIns="0" rIns="0" bIns="0" rtlCol="0" anchor="ctr"/>
           <a:lstStyle/>
           <a:p>
-            <a:pPr marL="0" indent="0">
+            <a:pPr indent="0" marL="0">
               <a:buNone/>
             </a:pPr>
             <a:r>
@@ -2794,12 +3084,12 @@
         </p:nvSpPr>
         <p:spPr>
           <a:xfrm>
-            <a:off x="502920" y="2148840"/>
-            <a:ext cx="5166360" cy="1783080"/>
+            <a:off x="502920" y="2121408"/>
+            <a:ext cx="5166360" cy="1691640"/>
           </a:xfrm>
           <a:prstGeom prst="roundRect">
             <a:avLst>
-              <a:gd name="adj" fmla="val 6154"/>
+              <a:gd name="adj" fmla="val 6486"/>
             </a:avLst>
           </a:prstGeom>
           <a:solidFill>
@@ -2812,13 +3102,6 @@
             <a:prstDash val="solid"/>
           </a:ln>
         </p:spPr>
-        <p:txBody>
-          <a:bodyPr/>
-          <a:lstStyle/>
-          <a:p>
-            <a:endParaRPr lang="en-ID"/>
-          </a:p>
-        </p:txBody>
       </p:sp>
       <p:sp>
         <p:nvSpPr>
@@ -2828,7 +3111,7 @@
         </p:nvSpPr>
         <p:spPr>
           <a:xfrm>
-            <a:off x="704088" y="2350008"/>
+            <a:off x="704088" y="2322576"/>
             <a:ext cx="4764024" cy="274320"/>
           </a:xfrm>
           <a:prstGeom prst="rect">
@@ -2841,7 +3124,7 @@
           <a:bodyPr wrap="square" lIns="0" tIns="0" rIns="0" bIns="0" rtlCol="0" anchor="ctr"/>
           <a:lstStyle/>
           <a:p>
-            <a:pPr marL="0" indent="0">
+            <a:pPr indent="0" marL="0">
               <a:buNone/>
             </a:pPr>
             <a:r>
@@ -2867,7 +3150,7 @@
         </p:nvSpPr>
         <p:spPr>
           <a:xfrm>
-            <a:off x="704088" y="2715768"/>
+            <a:off x="704088" y="2688336"/>
             <a:ext cx="4764024" cy="365760"/>
           </a:xfrm>
           <a:prstGeom prst="rect">
@@ -2880,7 +3163,7 @@
           <a:bodyPr wrap="square" lIns="0" tIns="0" rIns="0" bIns="0" rtlCol="0" anchor="ctr"/>
           <a:lstStyle/>
           <a:p>
-            <a:pPr marL="0" indent="0">
+            <a:pPr indent="0" marL="0">
               <a:lnSpc>
                 <a:spcPct val="130000"/>
               </a:lnSpc>
@@ -2909,7 +3192,7 @@
         </p:nvSpPr>
         <p:spPr>
           <a:xfrm>
-            <a:off x="704088" y="3246120"/>
+            <a:off x="704088" y="3172968"/>
             <a:ext cx="4764024" cy="457200"/>
           </a:xfrm>
           <a:prstGeom prst="rect">
@@ -2922,7 +3205,7 @@
           <a:bodyPr wrap="square" lIns="0" tIns="0" rIns="0" bIns="0" rtlCol="0" anchor="ctr"/>
           <a:lstStyle/>
           <a:p>
-            <a:pPr marL="0" indent="0">
+            <a:pPr indent="0" marL="0">
               <a:lnSpc>
                 <a:spcPct val="125000"/>
               </a:lnSpc>
@@ -2951,12 +3234,12 @@
         </p:nvSpPr>
         <p:spPr>
           <a:xfrm>
-            <a:off x="6172200" y="2148840"/>
-            <a:ext cx="5166360" cy="2560320"/>
+            <a:off x="6172200" y="2121408"/>
+            <a:ext cx="5166360" cy="2331720"/>
           </a:xfrm>
           <a:prstGeom prst="roundRect">
             <a:avLst>
-              <a:gd name="adj" fmla="val 4286"/>
+              <a:gd name="adj" fmla="val 4706"/>
             </a:avLst>
           </a:prstGeom>
           <a:solidFill>
@@ -2969,13 +3252,6 @@
             <a:prstDash val="solid"/>
           </a:ln>
         </p:spPr>
-        <p:txBody>
-          <a:bodyPr/>
-          <a:lstStyle/>
-          <a:p>
-            <a:endParaRPr lang="en-ID"/>
-          </a:p>
-        </p:txBody>
       </p:sp>
       <p:sp>
         <p:nvSpPr>
@@ -2985,7 +3261,7 @@
         </p:nvSpPr>
         <p:spPr>
           <a:xfrm>
-            <a:off x="6373368" y="2350008"/>
+            <a:off x="6373368" y="2322576"/>
             <a:ext cx="4764024" cy="274320"/>
           </a:xfrm>
           <a:prstGeom prst="rect">
@@ -2998,7 +3274,7 @@
           <a:bodyPr wrap="square" lIns="0" tIns="0" rIns="0" bIns="0" rtlCol="0" anchor="ctr"/>
           <a:lstStyle/>
           <a:p>
-            <a:pPr marL="0" indent="0">
+            <a:pPr indent="0" marL="0">
               <a:buNone/>
             </a:pPr>
             <a:r>
@@ -3024,7 +3300,7 @@
         </p:nvSpPr>
         <p:spPr>
           <a:xfrm>
-            <a:off x="6373368" y="2697480"/>
+            <a:off x="6373368" y="2670048"/>
             <a:ext cx="4764024" cy="1188720"/>
           </a:xfrm>
           <a:prstGeom prst="rect">
@@ -3037,7 +3313,7 @@
           <a:bodyPr wrap="square" lIns="0" tIns="0" rIns="0" bIns="0" rtlCol="0" anchor="ctr"/>
           <a:lstStyle/>
           <a:p>
-            <a:pPr marL="0" indent="0">
+            <a:pPr indent="0" marL="0">
               <a:lnSpc>
                 <a:spcPct val="125000"/>
               </a:lnSpc>
@@ -3066,20 +3342,20 @@
         </p:nvSpPr>
         <p:spPr>
           <a:xfrm>
-            <a:off x="6373368" y="4023360"/>
-            <a:ext cx="4764024" cy="457200"/>
-          </a:xfrm>
-          <a:prstGeom prst="rect">
-            <a:avLst/>
-          </a:prstGeom>
-          <a:noFill/>
-          <a:ln/>
-        </p:spPr>
-        <p:txBody>
-          <a:bodyPr wrap="square" lIns="0" tIns="0" rIns="0" bIns="0" rtlCol="0" anchor="ctr"/>
-          <a:lstStyle/>
-          <a:p>
-            <a:pPr marL="0" indent="0">
+            <a:off x="6373368" y="3904488"/>
+            <a:ext cx="4764024" cy="502920"/>
+          </a:xfrm>
+          <a:prstGeom prst="rect">
+            <a:avLst/>
+          </a:prstGeom>
+          <a:noFill/>
+          <a:ln/>
+        </p:spPr>
+        <p:txBody>
+          <a:bodyPr wrap="square" lIns="0" tIns="0" rIns="0" bIns="0" rtlCol="0" anchor="ctr"/>
+          <a:lstStyle/>
+          <a:p>
+            <a:pPr indent="0" marL="0">
               <a:lnSpc>
                 <a:spcPct val="125000"/>
               </a:lnSpc>
@@ -3097,6 +3373,92 @@
               <a:t>Kenapa berhasil: Project sudah tahu positioning dan semua data produk — tidak perlu ditulis ulang, siap paste.</a:t>
             </a:r>
             <a:endParaRPr lang="en-US" sz="1150" dirty="0"/>
+          </a:p>
+        </p:txBody>
+      </p:sp>
+      <p:sp>
+        <p:nvSpPr>
+          <p:cNvPr id="16" name="Shape 14"/>
+          <p:cNvSpPr/>
+          <p:nvPr/>
+        </p:nvSpPr>
+        <p:spPr>
+          <a:xfrm>
+            <a:off x="502920" y="4636008"/>
+            <a:ext cx="11064240" cy="1051560"/>
+          </a:xfrm>
+          <a:prstGeom prst="roundRect">
+            <a:avLst>
+              <a:gd name="adj" fmla="val 8696"/>
+            </a:avLst>
+          </a:prstGeom>
+          <a:solidFill>
+            <a:srgbClr val="F3F0FF"/>
+          </a:solidFill>
+          <a:ln w="12700">
+            <a:solidFill>
+              <a:srgbClr val="DCD3FB"/>
+            </a:solidFill>
+            <a:prstDash val="solid"/>
+          </a:ln>
+        </p:spPr>
+      </p:sp>
+      <p:sp>
+        <p:nvSpPr>
+          <p:cNvPr id="17" name="Text 15"/>
+          <p:cNvSpPr/>
+          <p:nvPr/>
+        </p:nvSpPr>
+        <p:spPr>
+          <a:xfrm>
+            <a:off x="713232" y="4636008"/>
+            <a:ext cx="10643616" cy="1051560"/>
+          </a:xfrm>
+          <a:prstGeom prst="rect">
+            <a:avLst/>
+          </a:prstGeom>
+          <a:noFill/>
+          <a:ln/>
+        </p:spPr>
+        <p:txBody>
+          <a:bodyPr wrap="square" lIns="0" tIns="0" rIns="0" bIns="0" rtlCol="0" anchor="ctr"/>
+          <a:lstStyle/>
+          <a:p>
+            <a:pPr indent="0" marL="0">
+              <a:lnSpc>
+                <a:spcPct val="125000"/>
+              </a:lnSpc>
+              <a:buNone/>
+            </a:pPr>
+            <a:r>
+              <a:rPr lang="en-US" sz="1200" b="1" dirty="0">
+                <a:solidFill>
+                  <a:srgbClr val="4B36C7"/>
+                </a:solidFill>
+                <a:latin typeface="Helvetica" pitchFamily="34" charset="0"/>
+                <a:ea typeface="Helvetica" pitchFamily="34" charset="-122"/>
+                <a:cs typeface="Helvetica" pitchFamily="34" charset="-120"/>
+              </a:rPr>
+              <a:t>◆  YANG KAMU BUTUHKAN  </a:t>
+            </a:r>
+            <a:pPr indent="0" marL="0">
+              <a:lnSpc>
+                <a:spcPct val="125000"/>
+              </a:lnSpc>
+              <a:buNone/>
+            </a:pPr>
+            <a:r>
+              <a:rPr lang="en-US" sz="1200" dirty="0">
+                <a:solidFill>
+                  <a:srgbClr val="23283A"/>
+                </a:solidFill>
+                <a:latin typeface="Helvetica" pitchFamily="34" charset="0"/>
+                <a:ea typeface="Helvetica" pitchFamily="34" charset="-122"/>
+                <a:cs typeface="Helvetica" pitchFamily="34" charset="-120"/>
+              </a:rPr>
+              <a:t>file cm-data-produk.csv (isi minimal 5 produk) dan akun Tokopedia/Shopee aktif. Upload CSV-nya ke Project Knowledge — otomatis dipakai lagi di Modul 3-5, dan positioning dari Modul 1 pun sudah tersedia otomatis.</a:t>
+            </a:r>
+            <a:endParaRPr lang="en-US" sz="1200" dirty="0"/>
           </a:p>
         </p:txBody>
       </p:sp>
@@ -3144,13 +3506,6 @@
           </a:solidFill>
           <a:ln/>
         </p:spPr>
-        <p:txBody>
-          <a:bodyPr/>
-          <a:lstStyle/>
-          <a:p>
-            <a:endParaRPr lang="en-ID"/>
-          </a:p>
-        </p:txBody>
       </p:sp>
       <p:sp>
         <p:nvSpPr>
@@ -3171,13 +3526,6 @@
           </a:solidFill>
           <a:ln/>
         </p:spPr>
-        <p:txBody>
-          <a:bodyPr/>
-          <a:lstStyle/>
-          <a:p>
-            <a:endParaRPr lang="en-ID"/>
-          </a:p>
-        </p:txBody>
       </p:sp>
       <p:sp>
         <p:nvSpPr>
@@ -3200,7 +3548,7 @@
           <a:bodyPr wrap="square" lIns="0" tIns="0" rIns="0" bIns="0" rtlCol="0" anchor="ctr"/>
           <a:lstStyle/>
           <a:p>
-            <a:pPr marL="0" indent="0">
+            <a:pPr indent="0" marL="0">
               <a:buNone/>
             </a:pPr>
             <a:r>
@@ -3214,6 +3562,9 @@
               </a:rPr>
               <a:t>belajar</a:t>
             </a:r>
+            <a:pPr indent="0" marL="0">
+              <a:buNone/>
+            </a:pPr>
             <a:r>
               <a:rPr lang="en-US" sz="2000" b="1" dirty="0">
                 <a:solidFill>
@@ -3250,7 +3601,7 @@
           <a:bodyPr wrap="square" lIns="0" tIns="0" rIns="0" bIns="0" rtlCol="0" anchor="ctr"/>
           <a:lstStyle/>
           <a:p>
-            <a:pPr marL="0" indent="0" algn="r">
+            <a:pPr algn="r" indent="0" marL="0">
               <a:buNone/>
             </a:pPr>
             <a:r>
@@ -3289,11 +3640,11 @@
           <a:bodyPr wrap="square" lIns="0" tIns="0" rIns="0" bIns="0" rtlCol="0" anchor="ctr"/>
           <a:lstStyle/>
           <a:p>
-            <a:pPr marL="0" indent="0">
-              <a:buNone/>
-            </a:pPr>
-            <a:r>
-              <a:rPr lang="en-US" sz="1250" b="1" kern="0" spc="40" dirty="0">
+            <a:pPr indent="0" marL="0">
+              <a:buNone/>
+            </a:pPr>
+            <a:r>
+              <a:rPr lang="en-US" sz="1250" b="1" spc="40" kern="0" dirty="0">
                 <a:solidFill>
                   <a:srgbClr val="4B36C7"/>
                 </a:solidFill>
@@ -3328,7 +3679,7 @@
           <a:bodyPr wrap="square" lIns="0" tIns="0" rIns="0" bIns="0" rtlCol="0" anchor="ctr"/>
           <a:lstStyle/>
           <a:p>
-            <a:pPr marL="0" indent="0">
+            <a:pPr indent="0" marL="0">
               <a:buNone/>
             </a:pPr>
             <a:r>
@@ -3340,7 +3691,7 @@
                 <a:ea typeface="Helvetica" pitchFamily="34" charset="-122"/>
                 <a:cs typeface="Helvetica" pitchFamily="34" charset="-120"/>
               </a:rPr>
-              <a:t>Cara Kerja: 5 Langkah</a:t>
+              <a:t>Cara Kerja</a:t>
             </a:r>
             <a:endParaRPr lang="en-US" sz="2200" dirty="0"/>
           </a:p>
@@ -3354,7 +3705,7 @@
         </p:nvSpPr>
         <p:spPr>
           <a:xfrm>
-            <a:off x="548640" y="2121408"/>
+            <a:off x="548640" y="2194560"/>
             <a:ext cx="329184" cy="329184"/>
           </a:xfrm>
           <a:prstGeom prst="ellipse">
@@ -3365,13 +3716,6 @@
           </a:solidFill>
           <a:ln/>
         </p:spPr>
-        <p:txBody>
-          <a:bodyPr/>
-          <a:lstStyle/>
-          <a:p>
-            <a:endParaRPr lang="en-ID"/>
-          </a:p>
-        </p:txBody>
       </p:sp>
       <p:sp>
         <p:nvSpPr>
@@ -3381,7 +3725,7 @@
         </p:nvSpPr>
         <p:spPr>
           <a:xfrm>
-            <a:off x="548640" y="2121408"/>
+            <a:off x="548640" y="2194560"/>
             <a:ext cx="329184" cy="329184"/>
           </a:xfrm>
           <a:prstGeom prst="rect">
@@ -3394,7 +3738,7 @@
           <a:bodyPr wrap="square" lIns="0" tIns="0" rIns="0" bIns="0" rtlCol="0" anchor="ctr"/>
           <a:lstStyle/>
           <a:p>
-            <a:pPr marL="0" indent="0" algn="ctr">
+            <a:pPr algn="ctr" indent="0" marL="0">
               <a:buNone/>
             </a:pPr>
             <a:r>
@@ -3420,20 +3764,23 @@
         </p:nvSpPr>
         <p:spPr>
           <a:xfrm>
-            <a:off x="1024128" y="2093976"/>
-            <a:ext cx="10607040" cy="457200"/>
-          </a:xfrm>
-          <a:prstGeom prst="rect">
-            <a:avLst/>
-          </a:prstGeom>
-          <a:noFill/>
-          <a:ln/>
-        </p:spPr>
-        <p:txBody>
-          <a:bodyPr wrap="square" lIns="0" tIns="0" rIns="0" bIns="0" rtlCol="0" anchor="ctr"/>
-          <a:lstStyle/>
-          <a:p>
-            <a:pPr marL="0" indent="0">
+            <a:off x="1024128" y="2148840"/>
+            <a:ext cx="10607040" cy="548640"/>
+          </a:xfrm>
+          <a:prstGeom prst="rect">
+            <a:avLst/>
+          </a:prstGeom>
+          <a:noFill/>
+          <a:ln/>
+        </p:spPr>
+        <p:txBody>
+          <a:bodyPr wrap="square" lIns="0" tIns="0" rIns="0" bIns="0" rtlCol="0" anchor="ctr"/>
+          <a:lstStyle/>
+          <a:p>
+            <a:pPr indent="0" marL="0">
+              <a:lnSpc>
+                <a:spcPct val="120000"/>
+              </a:lnSpc>
               <a:buNone/>
             </a:pPr>
             <a:r>
@@ -3445,8 +3792,14 @@
                 <a:ea typeface="Helvetica" pitchFamily="34" charset="-122"/>
                 <a:cs typeface="Helvetica" pitchFamily="34" charset="-120"/>
               </a:rPr>
-              <a:t>Isi cm-data-produk.csv — </a:t>
-            </a:r>
+              <a:t>Isi &amp; Upload — </a:t>
+            </a:r>
+            <a:pPr indent="0" marL="0">
+              <a:lnSpc>
+                <a:spcPct val="120000"/>
+              </a:lnSpc>
+              <a:buNone/>
+            </a:pPr>
             <a:r>
               <a:rPr lang="en-US" sz="1300" dirty="0">
                 <a:solidFill>
@@ -3456,7 +3809,7 @@
                 <a:ea typeface="Helvetica" pitchFamily="34" charset="-122"/>
                 <a:cs typeface="Helvetica" pitchFamily="34" charset="-120"/>
               </a:rPr>
-              <a:t>kolom terpenting: Keunggulan 1-3 dan Keyword Pencarian</a:t>
+              <a:t>isi cm-data-produk.csv, lalu upload ke Project Knowledge (bukan cuma chat) supaya dipakai lagi di Modul 3-5</a:t>
             </a:r>
             <a:endParaRPr lang="en-US" sz="1300" dirty="0"/>
           </a:p>
@@ -3470,7 +3823,7 @@
         </p:nvSpPr>
         <p:spPr>
           <a:xfrm>
-            <a:off x="548640" y="2651760"/>
+            <a:off x="548640" y="2816352"/>
             <a:ext cx="329184" cy="329184"/>
           </a:xfrm>
           <a:prstGeom prst="ellipse">
@@ -3481,13 +3834,6 @@
           </a:solidFill>
           <a:ln/>
         </p:spPr>
-        <p:txBody>
-          <a:bodyPr/>
-          <a:lstStyle/>
-          <a:p>
-            <a:endParaRPr lang="en-ID"/>
-          </a:p>
-        </p:txBody>
       </p:sp>
       <p:sp>
         <p:nvSpPr>
@@ -3497,7 +3843,7 @@
         </p:nvSpPr>
         <p:spPr>
           <a:xfrm>
-            <a:off x="548640" y="2651760"/>
+            <a:off x="548640" y="2816352"/>
             <a:ext cx="329184" cy="329184"/>
           </a:xfrm>
           <a:prstGeom prst="rect">
@@ -3510,7 +3856,7 @@
           <a:bodyPr wrap="square" lIns="0" tIns="0" rIns="0" bIns="0" rtlCol="0" anchor="ctr"/>
           <a:lstStyle/>
           <a:p>
-            <a:pPr marL="0" indent="0" algn="ctr">
+            <a:pPr algn="ctr" indent="0" marL="0">
               <a:buNone/>
             </a:pPr>
             <a:r>
@@ -3536,20 +3882,23 @@
         </p:nvSpPr>
         <p:spPr>
           <a:xfrm>
-            <a:off x="1024128" y="2624328"/>
-            <a:ext cx="10607040" cy="457200"/>
-          </a:xfrm>
-          <a:prstGeom prst="rect">
-            <a:avLst/>
-          </a:prstGeom>
-          <a:noFill/>
-          <a:ln/>
-        </p:spPr>
-        <p:txBody>
-          <a:bodyPr wrap="square" lIns="0" tIns="0" rIns="0" bIns="0" rtlCol="0" anchor="ctr"/>
-          <a:lstStyle/>
-          <a:p>
-            <a:pPr marL="0" indent="0">
+            <a:off x="1024128" y="2770632"/>
+            <a:ext cx="10607040" cy="548640"/>
+          </a:xfrm>
+          <a:prstGeom prst="rect">
+            <a:avLst/>
+          </a:prstGeom>
+          <a:noFill/>
+          <a:ln/>
+        </p:spPr>
+        <p:txBody>
+          <a:bodyPr wrap="square" lIns="0" tIns="0" rIns="0" bIns="0" rtlCol="0" anchor="ctr"/>
+          <a:lstStyle/>
+          <a:p>
+            <a:pPr indent="0" marL="0">
+              <a:lnSpc>
+                <a:spcPct val="120000"/>
+              </a:lnSpc>
               <a:buNone/>
             </a:pPr>
             <a:r>
@@ -3561,8 +3910,14 @@
                 <a:ea typeface="Helvetica" pitchFamily="34" charset="-122"/>
                 <a:cs typeface="Helvetica" pitchFamily="34" charset="-120"/>
               </a:rPr>
-              <a:t>Upload ke Project Knowledge — </a:t>
-            </a:r>
+              <a:t>Generate Langsung — </a:t>
+            </a:r>
+            <a:pPr indent="0" marL="0">
+              <a:lnSpc>
+                <a:spcPct val="120000"/>
+              </a:lnSpc>
+              <a:buNone/>
+            </a:pPr>
             <a:r>
               <a:rPr lang="en-US" sz="1300" dirty="0">
                 <a:solidFill>
@@ -3572,7 +3927,7 @@
                 <a:ea typeface="Helvetica" pitchFamily="34" charset="-122"/>
                 <a:cs typeface="Helvetica" pitchFamily="34" charset="-120"/>
               </a:rPr>
-              <a:t>bukan cuma chat, supaya dipakai lagi di Modul 3-5</a:t>
+              <a:t>positioning &amp; data produk otomatis dari Project, tinggal instruksi format maks 200 kata/produk</a:t>
             </a:r>
             <a:endParaRPr lang="en-US" sz="1300" dirty="0"/>
           </a:p>
@@ -3586,7 +3941,7 @@
         </p:nvSpPr>
         <p:spPr>
           <a:xfrm>
-            <a:off x="548640" y="3182112"/>
+            <a:off x="548640" y="3438144"/>
             <a:ext cx="329184" cy="329184"/>
           </a:xfrm>
           <a:prstGeom prst="ellipse">
@@ -3597,13 +3952,6 @@
           </a:solidFill>
           <a:ln/>
         </p:spPr>
-        <p:txBody>
-          <a:bodyPr/>
-          <a:lstStyle/>
-          <a:p>
-            <a:endParaRPr lang="en-ID"/>
-          </a:p>
-        </p:txBody>
       </p:sp>
       <p:sp>
         <p:nvSpPr>
@@ -3613,7 +3961,7 @@
         </p:nvSpPr>
         <p:spPr>
           <a:xfrm>
-            <a:off x="548640" y="3182112"/>
+            <a:off x="548640" y="3438144"/>
             <a:ext cx="329184" cy="329184"/>
           </a:xfrm>
           <a:prstGeom prst="rect">
@@ -3626,7 +3974,7 @@
           <a:bodyPr wrap="square" lIns="0" tIns="0" rIns="0" bIns="0" rtlCol="0" anchor="ctr"/>
           <a:lstStyle/>
           <a:p>
-            <a:pPr marL="0" indent="0" algn="ctr">
+            <a:pPr algn="ctr" indent="0" marL="0">
               <a:buNone/>
             </a:pPr>
             <a:r>
@@ -3652,20 +4000,23 @@
         </p:nvSpPr>
         <p:spPr>
           <a:xfrm>
-            <a:off x="1024128" y="3154680"/>
-            <a:ext cx="10607040" cy="457200"/>
-          </a:xfrm>
-          <a:prstGeom prst="rect">
-            <a:avLst/>
-          </a:prstGeom>
-          <a:noFill/>
-          <a:ln/>
-        </p:spPr>
-        <p:txBody>
-          <a:bodyPr wrap="square" lIns="0" tIns="0" rIns="0" bIns="0" rtlCol="0" anchor="ctr"/>
-          <a:lstStyle/>
-          <a:p>
-            <a:pPr marL="0" indent="0">
+            <a:off x="1024128" y="3392424"/>
+            <a:ext cx="10607040" cy="548640"/>
+          </a:xfrm>
+          <a:prstGeom prst="rect">
+            <a:avLst/>
+          </a:prstGeom>
+          <a:noFill/>
+          <a:ln/>
+        </p:spPr>
+        <p:txBody>
+          <a:bodyPr wrap="square" lIns="0" tIns="0" rIns="0" bIns="0" rtlCol="0" anchor="ctr"/>
+          <a:lstStyle/>
+          <a:p>
+            <a:pPr indent="0" marL="0">
+              <a:lnSpc>
+                <a:spcPct val="120000"/>
+              </a:lnSpc>
               <a:buNone/>
             </a:pPr>
             <a:r>
@@ -3677,8 +4028,14 @@
                 <a:ea typeface="Helvetica" pitchFamily="34" charset="-122"/>
                 <a:cs typeface="Helvetica" pitchFamily="34" charset="-120"/>
               </a:rPr>
-              <a:t>Generate Langsung — </a:t>
-            </a:r>
+              <a:t>Review Tiap Deskripsi — </a:t>
+            </a:r>
+            <a:pPr indent="0" marL="0">
+              <a:lnSpc>
+                <a:spcPct val="120000"/>
+              </a:lnSpc>
+              <a:buNone/>
+            </a:pPr>
             <a:r>
               <a:rPr lang="en-US" sz="1300" dirty="0">
                 <a:solidFill>
@@ -3688,7 +4045,7 @@
                 <a:ea typeface="Helvetica" pitchFamily="34" charset="-122"/>
                 <a:cs typeface="Helvetica" pitchFamily="34" charset="-120"/>
               </a:rPr>
-              <a:t>positioning &amp; data produk otomatis dari Project, tinggal instruksi format maks 200 kata/produk</a:t>
+              <a:t>pastikan keyword terasa natural, tidak dipaksakan</a:t>
             </a:r>
             <a:endParaRPr lang="en-US" sz="1300" dirty="0"/>
           </a:p>
@@ -3702,7 +4059,7 @@
         </p:nvSpPr>
         <p:spPr>
           <a:xfrm>
-            <a:off x="548640" y="3712464"/>
+            <a:off x="548640" y="4059936"/>
             <a:ext cx="329184" cy="329184"/>
           </a:xfrm>
           <a:prstGeom prst="ellipse">
@@ -3713,13 +4070,6 @@
           </a:solidFill>
           <a:ln/>
         </p:spPr>
-        <p:txBody>
-          <a:bodyPr/>
-          <a:lstStyle/>
-          <a:p>
-            <a:endParaRPr lang="en-ID"/>
-          </a:p>
-        </p:txBody>
       </p:sp>
       <p:sp>
         <p:nvSpPr>
@@ -3729,7 +4079,7 @@
         </p:nvSpPr>
         <p:spPr>
           <a:xfrm>
-            <a:off x="548640" y="3712464"/>
+            <a:off x="548640" y="4059936"/>
             <a:ext cx="329184" cy="329184"/>
           </a:xfrm>
           <a:prstGeom prst="rect">
@@ -3742,7 +4092,7 @@
           <a:bodyPr wrap="square" lIns="0" tIns="0" rIns="0" bIns="0" rtlCol="0" anchor="ctr"/>
           <a:lstStyle/>
           <a:p>
-            <a:pPr marL="0" indent="0" algn="ctr">
+            <a:pPr algn="ctr" indent="0" marL="0">
               <a:buNone/>
             </a:pPr>
             <a:r>
@@ -3768,20 +4118,23 @@
         </p:nvSpPr>
         <p:spPr>
           <a:xfrm>
-            <a:off x="1024128" y="3685032"/>
-            <a:ext cx="10607040" cy="457200"/>
-          </a:xfrm>
-          <a:prstGeom prst="rect">
-            <a:avLst/>
-          </a:prstGeom>
-          <a:noFill/>
-          <a:ln/>
-        </p:spPr>
-        <p:txBody>
-          <a:bodyPr wrap="square" lIns="0" tIns="0" rIns="0" bIns="0" rtlCol="0" anchor="ctr"/>
-          <a:lstStyle/>
-          <a:p>
-            <a:pPr marL="0" indent="0">
+            <a:off x="1024128" y="4014216"/>
+            <a:ext cx="10607040" cy="548640"/>
+          </a:xfrm>
+          <a:prstGeom prst="rect">
+            <a:avLst/>
+          </a:prstGeom>
+          <a:noFill/>
+          <a:ln/>
+        </p:spPr>
+        <p:txBody>
+          <a:bodyPr wrap="square" lIns="0" tIns="0" rIns="0" bIns="0" rtlCol="0" anchor="ctr"/>
+          <a:lstStyle/>
+          <a:p>
+            <a:pPr indent="0" marL="0">
+              <a:lnSpc>
+                <a:spcPct val="120000"/>
+              </a:lnSpc>
               <a:buNone/>
             </a:pPr>
             <a:r>
@@ -3793,8 +4146,14 @@
                 <a:ea typeface="Helvetica" pitchFamily="34" charset="-122"/>
                 <a:cs typeface="Helvetica" pitchFamily="34" charset="-120"/>
               </a:rPr>
-              <a:t>Review Tiap Deskripsi — </a:t>
-            </a:r>
+              <a:t>Paste &amp; Pantau — </a:t>
+            </a:r>
+            <a:pPr indent="0" marL="0">
+              <a:lnSpc>
+                <a:spcPct val="120000"/>
+              </a:lnSpc>
+              <a:buNone/>
+            </a:pPr>
             <a:r>
               <a:rPr lang="en-US" sz="1300" dirty="0">
                 <a:solidFill>
@@ -3804,7 +4163,7 @@
                 <a:ea typeface="Helvetica" pitchFamily="34" charset="-122"/>
                 <a:cs typeface="Helvetica" pitchFamily="34" charset="-120"/>
               </a:rPr>
-              <a:t>pastikan keyword terasa natural, tidak dipaksakan</a:t>
+              <a:t>ke Tokopedia/Shopee, catat posisi ranking setelah 7 hari</a:t>
             </a:r>
             <a:endParaRPr lang="en-US" sz="1300" dirty="0"/>
           </a:p>
@@ -3818,123 +4177,7 @@
         </p:nvSpPr>
         <p:spPr>
           <a:xfrm>
-            <a:off x="548640" y="4242816"/>
-            <a:ext cx="329184" cy="329184"/>
-          </a:xfrm>
-          <a:prstGeom prst="ellipse">
-            <a:avLst/>
-          </a:prstGeom>
-          <a:solidFill>
-            <a:srgbClr val="6849F6"/>
-          </a:solidFill>
-          <a:ln/>
-        </p:spPr>
-        <p:txBody>
-          <a:bodyPr/>
-          <a:lstStyle/>
-          <a:p>
-            <a:endParaRPr lang="en-ID"/>
-          </a:p>
-        </p:txBody>
-      </p:sp>
-      <p:sp>
-        <p:nvSpPr>
-          <p:cNvPr id="21" name="Text 19"/>
-          <p:cNvSpPr/>
-          <p:nvPr/>
-        </p:nvSpPr>
-        <p:spPr>
-          <a:xfrm>
-            <a:off x="548640" y="4242816"/>
-            <a:ext cx="329184" cy="329184"/>
-          </a:xfrm>
-          <a:prstGeom prst="rect">
-            <a:avLst/>
-          </a:prstGeom>
-          <a:noFill/>
-          <a:ln/>
-        </p:spPr>
-        <p:txBody>
-          <a:bodyPr wrap="square" lIns="0" tIns="0" rIns="0" bIns="0" rtlCol="0" anchor="ctr"/>
-          <a:lstStyle/>
-          <a:p>
-            <a:pPr marL="0" indent="0" algn="ctr">
-              <a:buNone/>
-            </a:pPr>
-            <a:r>
-              <a:rPr lang="en-US" sz="1300" b="1" dirty="0">
-                <a:solidFill>
-                  <a:srgbClr val="FFFFFF"/>
-                </a:solidFill>
-                <a:latin typeface="Helvetica" pitchFamily="34" charset="0"/>
-                <a:ea typeface="Helvetica" pitchFamily="34" charset="-122"/>
-                <a:cs typeface="Helvetica" pitchFamily="34" charset="-120"/>
-              </a:rPr>
-              <a:t>5</a:t>
-            </a:r>
-            <a:endParaRPr lang="en-US" sz="1300" dirty="0"/>
-          </a:p>
-        </p:txBody>
-      </p:sp>
-      <p:sp>
-        <p:nvSpPr>
-          <p:cNvPr id="22" name="Text 20"/>
-          <p:cNvSpPr/>
-          <p:nvPr/>
-        </p:nvSpPr>
-        <p:spPr>
-          <a:xfrm>
-            <a:off x="1024128" y="4215384"/>
-            <a:ext cx="10607040" cy="457200"/>
-          </a:xfrm>
-          <a:prstGeom prst="rect">
-            <a:avLst/>
-          </a:prstGeom>
-          <a:noFill/>
-          <a:ln/>
-        </p:spPr>
-        <p:txBody>
-          <a:bodyPr wrap="square" lIns="0" tIns="0" rIns="0" bIns="0" rtlCol="0" anchor="ctr"/>
-          <a:lstStyle/>
-          <a:p>
-            <a:pPr marL="0" indent="0">
-              <a:buNone/>
-            </a:pPr>
-            <a:r>
-              <a:rPr lang="en-US" sz="1300" b="1" dirty="0">
-                <a:solidFill>
-                  <a:srgbClr val="0D1321"/>
-                </a:solidFill>
-                <a:latin typeface="Helvetica" pitchFamily="34" charset="0"/>
-                <a:ea typeface="Helvetica" pitchFamily="34" charset="-122"/>
-                <a:cs typeface="Helvetica" pitchFamily="34" charset="-120"/>
-              </a:rPr>
-              <a:t>Paste &amp; Pantau — </a:t>
-            </a:r>
-            <a:r>
-              <a:rPr lang="en-US" sz="1300" dirty="0">
-                <a:solidFill>
-                  <a:srgbClr val="23283A"/>
-                </a:solidFill>
-                <a:latin typeface="Helvetica" pitchFamily="34" charset="0"/>
-                <a:ea typeface="Helvetica" pitchFamily="34" charset="-122"/>
-                <a:cs typeface="Helvetica" pitchFamily="34" charset="-120"/>
-              </a:rPr>
-              <a:t>ke Tokopedia/Shopee, catat posisi ranking setelah 7 hari</a:t>
-            </a:r>
-            <a:endParaRPr lang="en-US" sz="1300" dirty="0"/>
-          </a:p>
-        </p:txBody>
-      </p:sp>
-      <p:sp>
-        <p:nvSpPr>
-          <p:cNvPr id="23" name="Shape 21"/>
-          <p:cNvSpPr/>
-          <p:nvPr/>
-        </p:nvSpPr>
-        <p:spPr>
-          <a:xfrm>
-            <a:off x="502920" y="4937760"/>
+            <a:off x="502920" y="4818888"/>
             <a:ext cx="11064240" cy="960120"/>
           </a:xfrm>
           <a:prstGeom prst="roundRect">
@@ -3952,23 +4195,16 @@
             <a:prstDash val="solid"/>
           </a:ln>
         </p:spPr>
-        <p:txBody>
-          <a:bodyPr/>
-          <a:lstStyle/>
-          <a:p>
-            <a:endParaRPr lang="en-ID"/>
-          </a:p>
-        </p:txBody>
-      </p:sp>
-      <p:sp>
-        <p:nvSpPr>
-          <p:cNvPr id="24" name="Text 22"/>
-          <p:cNvSpPr/>
-          <p:nvPr/>
-        </p:nvSpPr>
-        <p:spPr>
-          <a:xfrm>
-            <a:off x="713232" y="4937760"/>
+      </p:sp>
+      <p:sp>
+        <p:nvSpPr>
+          <p:cNvPr id="21" name="Text 19"/>
+          <p:cNvSpPr/>
+          <p:nvPr/>
+        </p:nvSpPr>
+        <p:spPr>
+          <a:xfrm>
+            <a:off x="713232" y="4818888"/>
             <a:ext cx="10643616" cy="960120"/>
           </a:xfrm>
           <a:prstGeom prst="rect">
@@ -3981,7 +4217,7 @@
           <a:bodyPr wrap="square" lIns="0" tIns="0" rIns="0" bIns="0" rtlCol="0" anchor="ctr"/>
           <a:lstStyle/>
           <a:p>
-            <a:pPr marL="0" indent="0">
+            <a:pPr indent="0" marL="0">
               <a:lnSpc>
                 <a:spcPct val="120000"/>
               </a:lnSpc>
@@ -3998,6 +4234,12 @@
               </a:rPr>
               <a:t>◆  KENAPA SATU PROMPT SAJA CUKUP?  </a:t>
             </a:r>
+            <a:pPr indent="0" marL="0">
+              <a:lnSpc>
+                <a:spcPct val="120000"/>
+              </a:lnSpc>
+              <a:buNone/>
+            </a:pPr>
             <a:r>
               <a:rPr lang="en-US" sz="1250" dirty="0">
                 <a:solidFill>
@@ -4057,13 +4299,6 @@
           </a:solidFill>
           <a:ln/>
         </p:spPr>
-        <p:txBody>
-          <a:bodyPr/>
-          <a:lstStyle/>
-          <a:p>
-            <a:endParaRPr lang="en-ID"/>
-          </a:p>
-        </p:txBody>
       </p:sp>
       <p:sp>
         <p:nvSpPr>
@@ -4084,13 +4319,6 @@
           </a:solidFill>
           <a:ln/>
         </p:spPr>
-        <p:txBody>
-          <a:bodyPr/>
-          <a:lstStyle/>
-          <a:p>
-            <a:endParaRPr lang="en-ID"/>
-          </a:p>
-        </p:txBody>
       </p:sp>
       <p:sp>
         <p:nvSpPr>
@@ -4113,7 +4341,7 @@
           <a:bodyPr wrap="square" lIns="0" tIns="0" rIns="0" bIns="0" rtlCol="0" anchor="ctr"/>
           <a:lstStyle/>
           <a:p>
-            <a:pPr marL="0" indent="0">
+            <a:pPr indent="0" marL="0">
               <a:buNone/>
             </a:pPr>
             <a:r>
@@ -4127,6 +4355,9 @@
               </a:rPr>
               <a:t>belajar</a:t>
             </a:r>
+            <a:pPr indent="0" marL="0">
+              <a:buNone/>
+            </a:pPr>
             <a:r>
               <a:rPr lang="en-US" sz="2000" b="1" dirty="0">
                 <a:solidFill>
@@ -4163,7 +4394,7 @@
           <a:bodyPr wrap="square" lIns="0" tIns="0" rIns="0" bIns="0" rtlCol="0" anchor="ctr"/>
           <a:lstStyle/>
           <a:p>
-            <a:pPr marL="0" indent="0" algn="r">
+            <a:pPr algn="r" indent="0" marL="0">
               <a:buNone/>
             </a:pPr>
             <a:r>
@@ -4202,11 +4433,11 @@
           <a:bodyPr wrap="square" lIns="0" tIns="0" rIns="0" bIns="0" rtlCol="0" anchor="ctr"/>
           <a:lstStyle/>
           <a:p>
-            <a:pPr marL="0" indent="0">
-              <a:buNone/>
-            </a:pPr>
-            <a:r>
-              <a:rPr lang="en-US" sz="1250" b="1" kern="0" spc="40" dirty="0">
+            <a:pPr indent="0" marL="0">
+              <a:buNone/>
+            </a:pPr>
+            <a:r>
+              <a:rPr lang="en-US" sz="1250" b="1" spc="40" kern="0" dirty="0">
                 <a:solidFill>
                   <a:srgbClr val="4B36C7"/>
                 </a:solidFill>
@@ -4241,7 +4472,7 @@
           <a:bodyPr wrap="square" lIns="0" tIns="0" rIns="0" bIns="0" rtlCol="0" anchor="ctr"/>
           <a:lstStyle/>
           <a:p>
-            <a:pPr marL="0" indent="0">
+            <a:pPr indent="0" marL="0">
               <a:buNone/>
             </a:pPr>
             <a:r>
@@ -4285,13 +4516,6 @@
             <a:prstDash val="solid"/>
           </a:ln>
         </p:spPr>
-        <p:txBody>
-          <a:bodyPr/>
-          <a:lstStyle/>
-          <a:p>
-            <a:endParaRPr lang="en-ID"/>
-          </a:p>
-        </p:txBody>
       </p:sp>
       <p:sp>
         <p:nvSpPr>
@@ -4314,7 +4538,7 @@
           <a:bodyPr wrap="square" lIns="0" tIns="0" rIns="0" bIns="0" rtlCol="0" anchor="ctr"/>
           <a:lstStyle/>
           <a:p>
-            <a:pPr marL="0" indent="0">
+            <a:pPr indent="0" marL="0">
               <a:buNone/>
             </a:pPr>
             <a:r>
@@ -4353,7 +4577,7 @@
           <a:bodyPr wrap="square" lIns="0" tIns="0" rIns="0" bIns="0" rtlCol="0" anchor="ctr"/>
           <a:lstStyle/>
           <a:p>
-            <a:pPr marL="0" indent="0">
+            <a:pPr indent="0" marL="0">
               <a:lnSpc>
                 <a:spcPct val="125000"/>
               </a:lnSpc>
@@ -4400,13 +4624,6 @@
             <a:prstDash val="solid"/>
           </a:ln>
         </p:spPr>
-        <p:txBody>
-          <a:bodyPr/>
-          <a:lstStyle/>
-          <a:p>
-            <a:endParaRPr lang="en-ID"/>
-          </a:p>
-        </p:txBody>
       </p:sp>
       <p:sp>
         <p:nvSpPr>
@@ -4429,7 +4646,7 @@
           <a:bodyPr wrap="square" lIns="0" tIns="0" rIns="0" bIns="0" rtlCol="0" anchor="ctr"/>
           <a:lstStyle/>
           <a:p>
-            <a:pPr marL="0" indent="0">
+            <a:pPr indent="0" marL="0">
               <a:lnSpc>
                 <a:spcPct val="120000"/>
               </a:lnSpc>
@@ -4444,51 +4661,7 @@
                 <a:ea typeface="Helvetica" pitchFamily="34" charset="-122"/>
                 <a:cs typeface="Helvetica" pitchFamily="34" charset="-120"/>
               </a:rPr>
-              <a:t>“</a:t>
-            </a:r>
-            <a:r>
-              <a:rPr lang="en-US" sz="1050" i="1" dirty="0" err="1">
-                <a:solidFill>
-                  <a:srgbClr val="1A7A44"/>
-                </a:solidFill>
-                <a:latin typeface="Helvetica" pitchFamily="34" charset="0"/>
-                <a:ea typeface="Helvetica" pitchFamily="34" charset="-122"/>
-                <a:cs typeface="Helvetica" pitchFamily="34" charset="-120"/>
-              </a:rPr>
-              <a:t>Buatkan</a:t>
-            </a:r>
-            <a:r>
-              <a:rPr lang="en-US" sz="1050" i="1" dirty="0">
-                <a:solidFill>
-                  <a:srgbClr val="1A7A44"/>
-                </a:solidFill>
-                <a:latin typeface="Helvetica" pitchFamily="34" charset="0"/>
-                <a:ea typeface="Helvetica" pitchFamily="34" charset="-122"/>
-                <a:cs typeface="Helvetica" pitchFamily="34" charset="-120"/>
-              </a:rPr>
-              <a:t> deskripsi Tokopedia untuk tiap produk: hook 2 kalimat, keyword, benefit, spesifikasi, CTA. Maks 200 kata per </a:t>
-            </a:r>
-            <a:r>
-              <a:rPr lang="en-US" sz="1050" i="1" dirty="0" err="1">
-                <a:solidFill>
-                  <a:srgbClr val="1A7A44"/>
-                </a:solidFill>
-                <a:latin typeface="Helvetica" pitchFamily="34" charset="0"/>
-                <a:ea typeface="Helvetica" pitchFamily="34" charset="-122"/>
-                <a:cs typeface="Helvetica" pitchFamily="34" charset="-120"/>
-              </a:rPr>
-              <a:t>produk</a:t>
-            </a:r>
-            <a:r>
-              <a:rPr lang="en-US" sz="1050" i="1" dirty="0">
-                <a:solidFill>
-                  <a:srgbClr val="1A7A44"/>
-                </a:solidFill>
-                <a:latin typeface="Helvetica" pitchFamily="34" charset="0"/>
-                <a:ea typeface="Helvetica" pitchFamily="34" charset="-122"/>
-                <a:cs typeface="Helvetica" pitchFamily="34" charset="-120"/>
-              </a:rPr>
-              <a:t>”</a:t>
+              <a:t>Buatkan deskripsi Tokopedia untuk tiap produk: hook 2 kalimat, keyword, benefit, spesifikasi, CTA. Maks 200 kata per produk.</a:t>
             </a:r>
             <a:endParaRPr lang="en-US" sz="1050" dirty="0"/>
           </a:p>
@@ -4515,13 +4688,6 @@
           </a:solidFill>
           <a:ln/>
         </p:spPr>
-        <p:txBody>
-          <a:bodyPr/>
-          <a:lstStyle/>
-          <a:p>
-            <a:endParaRPr lang="en-ID"/>
-          </a:p>
-        </p:txBody>
       </p:sp>
       <p:sp>
         <p:nvSpPr>
@@ -4544,7 +4710,7 @@
           <a:bodyPr wrap="square" lIns="0" tIns="0" rIns="0" bIns="0" rtlCol="0" anchor="ctr"/>
           <a:lstStyle/>
           <a:p>
-            <a:pPr marL="0" indent="0">
+            <a:pPr indent="0" marL="0">
               <a:buNone/>
             </a:pPr>
             <a:r>
@@ -4583,7 +4749,7 @@
           <a:bodyPr wrap="square" lIns="0" tIns="0" rIns="0" bIns="0" rtlCol="0" anchor="ctr"/>
           <a:lstStyle/>
           <a:p>
-            <a:pPr marL="0" indent="0">
+            <a:pPr indent="0" marL="0">
               <a:lnSpc>
                 <a:spcPct val="130000"/>
               </a:lnSpc>
@@ -4603,7 +4769,7 @@
             <a:endParaRPr lang="en-US" sz="1250" dirty="0"/>
           </a:p>
           <a:p>
-            <a:pPr marL="0" indent="0">
+            <a:pPr indent="0" marL="0">
               <a:lnSpc>
                 <a:spcPct val="130000"/>
               </a:lnSpc>
@@ -4925,319 +5091,4 @@
     </a:ext>
   </a:extLst>
 </a:theme>
-</file>
-
-<file path=ppt/theme/theme2.xml><?xml version="1.0" encoding="utf-8"?>
-<a:theme xmlns:a="http://schemas.openxmlformats.org/drawingml/2006/main" name="Office Theme">
-  <a:themeElements>
-    <a:clrScheme name="Office">
-      <a:dk1>
-        <a:sysClr val="windowText" lastClr="000000"/>
-      </a:dk1>
-      <a:lt1>
-        <a:sysClr val="window" lastClr="FFFFFF"/>
-      </a:lt1>
-      <a:dk2>
-        <a:srgbClr val="0E2841"/>
-      </a:dk2>
-      <a:lt2>
-        <a:srgbClr val="E8E8E8"/>
-      </a:lt2>
-      <a:accent1>
-        <a:srgbClr val="156082"/>
-      </a:accent1>
-      <a:accent2>
-        <a:srgbClr val="E97132"/>
-      </a:accent2>
-      <a:accent3>
-        <a:srgbClr val="196B24"/>
-      </a:accent3>
-      <a:accent4>
-        <a:srgbClr val="0F9ED5"/>
-      </a:accent4>
-      <a:accent5>
-        <a:srgbClr val="A02B93"/>
-      </a:accent5>
-      <a:accent6>
-        <a:srgbClr val="4EA72E"/>
-      </a:accent6>
-      <a:hlink>
-        <a:srgbClr val="467886"/>
-      </a:hlink>
-      <a:folHlink>
-        <a:srgbClr val="96607D"/>
-      </a:folHlink>
-    </a:clrScheme>
-    <a:fontScheme name="Office">
-      <a:majorFont>
-        <a:latin typeface="Aptos Display" panose="02110004020202020204"/>
-        <a:ea typeface=""/>
-        <a:cs typeface=""/>
-        <a:font script="Jpan" typeface="游ゴシック Light"/>
-        <a:font script="Hang" typeface="맑은 고딕"/>
-        <a:font script="Hans" typeface="等线 Light"/>
-        <a:font script="Hant" typeface="新細明體"/>
-        <a:font script="Arab" typeface="Times New Roman"/>
-        <a:font script="Hebr" typeface="Times New Roman"/>
-        <a:font script="Thai" typeface="Angsana New"/>
-        <a:font script="Ethi" typeface="Nyala"/>
-        <a:font script="Beng" typeface="Vrinda"/>
-        <a:font script="Gujr" typeface="Shruti"/>
-        <a:font script="Khmr" typeface="MoolBoran"/>
-        <a:font script="Knda" typeface="Tunga"/>
-        <a:font script="Guru" typeface="Raavi"/>
-        <a:font script="Cans" typeface="Euphemia"/>
-        <a:font script="Cher" typeface="Plantagenet Cherokee"/>
-        <a:font script="Yiii" typeface="Microsoft Yi Baiti"/>
-        <a:font script="Tibt" typeface="Microsoft Himalaya"/>
-        <a:font script="Thaa" typeface="MV Boli"/>
-        <a:font script="Deva" typeface="Mangal"/>
-        <a:font script="Telu" typeface="Gautami"/>
-        <a:font script="Taml" typeface="Latha"/>
-        <a:font script="Syrc" typeface="Estrangelo Edessa"/>
-        <a:font script="Orya" typeface="Kalinga"/>
-        <a:font script="Mlym" typeface="Kartika"/>
-        <a:font script="Laoo" typeface="DokChampa"/>
-        <a:font script="Sinh" typeface="Iskoola Pota"/>
-        <a:font script="Mong" typeface="Mongolian Baiti"/>
-        <a:font script="Viet" typeface="Times New Roman"/>
-        <a:font script="Uigh" typeface="Microsoft Uighur"/>
-        <a:font script="Geor" typeface="Sylfaen"/>
-        <a:font script="Armn" typeface="Arial"/>
-        <a:font script="Bugi" typeface="Leelawadee UI"/>
-        <a:font script="Bopo" typeface="Microsoft JhengHei"/>
-        <a:font script="Java" typeface="Javanese Text"/>
-        <a:font script="Lisu" typeface="Segoe UI"/>
-        <a:font script="Mymr" typeface="Myanmar Text"/>
-        <a:font script="Nkoo" typeface="Ebrima"/>
-        <a:font script="Olck" typeface="Nirmala UI"/>
-        <a:font script="Osma" typeface="Ebrima"/>
-        <a:font script="Phag" typeface="Phagspa"/>
-        <a:font script="Syrn" typeface="Estrangelo Edessa"/>
-        <a:font script="Syrj" typeface="Estrangelo Edessa"/>
-        <a:font script="Syre" typeface="Estrangelo Edessa"/>
-        <a:font script="Sora" typeface="Nirmala UI"/>
-        <a:font script="Tale" typeface="Microsoft Tai Le"/>
-        <a:font script="Talu" typeface="Microsoft New Tai Lue"/>
-        <a:font script="Tfng" typeface="Ebrima"/>
-      </a:majorFont>
-      <a:minorFont>
-        <a:latin typeface="Aptos" panose="02110004020202020204"/>
-        <a:ea typeface=""/>
-        <a:cs typeface=""/>
-        <a:font script="Jpan" typeface="游ゴシック"/>
-        <a:font script="Hang" typeface="맑은 고딕"/>
-        <a:font script="Hans" typeface="等线"/>
-        <a:font script="Hant" typeface="新細明體"/>
-        <a:font script="Arab" typeface="Arial"/>
-        <a:font script="Hebr" typeface="Arial"/>
-        <a:font script="Thai" typeface="Cordia New"/>
-        <a:font script="Ethi" typeface="Nyala"/>
-        <a:font script="Beng" typeface="Vrinda"/>
-        <a:font script="Gujr" typeface="Shruti"/>
-        <a:font script="Khmr" typeface="DaunPenh"/>
-        <a:font script="Knda" typeface="Tunga"/>
-        <a:font script="Guru" typeface="Raavi"/>
-        <a:font script="Cans" typeface="Euphemia"/>
-        <a:font script="Cher" typeface="Plantagenet Cherokee"/>
-        <a:font script="Yiii" typeface="Microsoft Yi Baiti"/>
-        <a:font script="Tibt" typeface="Microsoft Himalaya"/>
-        <a:font script="Thaa" typeface="MV Boli"/>
-        <a:font script="Deva" typeface="Mangal"/>
-        <a:font script="Telu" typeface="Gautami"/>
-        <a:font script="Taml" typeface="Latha"/>
-        <a:font script="Syrc" typeface="Estrangelo Edessa"/>
-        <a:font script="Orya" typeface="Kalinga"/>
-        <a:font script="Mlym" typeface="Kartika"/>
-        <a:font script="Laoo" typeface="DokChampa"/>
-        <a:font script="Sinh" typeface="Iskoola Pota"/>
-        <a:font script="Mong" typeface="Mongolian Baiti"/>
-        <a:font script="Viet" typeface="Arial"/>
-        <a:font script="Uigh" typeface="Microsoft Uighur"/>
-        <a:font script="Geor" typeface="Sylfaen"/>
-        <a:font script="Armn" typeface="Arial"/>
-        <a:font script="Bugi" typeface="Leelawadee UI"/>
-        <a:font script="Bopo" typeface="Microsoft JhengHei"/>
-        <a:font script="Java" typeface="Javanese Text"/>
-        <a:font script="Lisu" typeface="Segoe UI"/>
-        <a:font script="Mymr" typeface="Myanmar Text"/>
-        <a:font script="Nkoo" typeface="Ebrima"/>
-        <a:font script="Olck" typeface="Nirmala UI"/>
-        <a:font script="Osma" typeface="Ebrima"/>
-        <a:font script="Phag" typeface="Phagspa"/>
-        <a:font script="Syrn" typeface="Estrangelo Edessa"/>
-        <a:font script="Syrj" typeface="Estrangelo Edessa"/>
-        <a:font script="Syre" typeface="Estrangelo Edessa"/>
-        <a:font script="Sora" typeface="Nirmala UI"/>
-        <a:font script="Tale" typeface="Microsoft Tai Le"/>
-        <a:font script="Talu" typeface="Microsoft New Tai Lue"/>
-        <a:font script="Tfng" typeface="Ebrima"/>
-      </a:minorFont>
-    </a:fontScheme>
-    <a:fmtScheme name="Office">
-      <a:fillStyleLst>
-        <a:solidFill>
-          <a:schemeClr val="phClr"/>
-        </a:solidFill>
-        <a:gradFill rotWithShape="1">
-          <a:gsLst>
-            <a:gs pos="0">
-              <a:schemeClr val="phClr">
-                <a:lumMod val="110000"/>
-                <a:satMod val="105000"/>
-                <a:tint val="67000"/>
-              </a:schemeClr>
-            </a:gs>
-            <a:gs pos="50000">
-              <a:schemeClr val="phClr">
-                <a:lumMod val="105000"/>
-                <a:satMod val="103000"/>
-                <a:tint val="73000"/>
-              </a:schemeClr>
-            </a:gs>
-            <a:gs pos="100000">
-              <a:schemeClr val="phClr">
-                <a:lumMod val="105000"/>
-                <a:satMod val="109000"/>
-                <a:tint val="81000"/>
-              </a:schemeClr>
-            </a:gs>
-          </a:gsLst>
-          <a:lin ang="5400000" scaled="0"/>
-        </a:gradFill>
-        <a:gradFill rotWithShape="1">
-          <a:gsLst>
-            <a:gs pos="0">
-              <a:schemeClr val="phClr">
-                <a:satMod val="103000"/>
-                <a:lumMod val="102000"/>
-                <a:tint val="94000"/>
-              </a:schemeClr>
-            </a:gs>
-            <a:gs pos="50000">
-              <a:schemeClr val="phClr">
-                <a:satMod val="110000"/>
-                <a:lumMod val="100000"/>
-                <a:shade val="100000"/>
-              </a:schemeClr>
-            </a:gs>
-            <a:gs pos="100000">
-              <a:schemeClr val="phClr">
-                <a:lumMod val="99000"/>
-                <a:satMod val="120000"/>
-                <a:shade val="78000"/>
-              </a:schemeClr>
-            </a:gs>
-          </a:gsLst>
-          <a:lin ang="5400000" scaled="0"/>
-        </a:gradFill>
-      </a:fillStyleLst>
-      <a:lnStyleLst>
-        <a:ln w="12700" cap="flat" cmpd="sng" algn="ctr">
-          <a:solidFill>
-            <a:schemeClr val="phClr"/>
-          </a:solidFill>
-          <a:prstDash val="solid"/>
-          <a:miter lim="800000"/>
-        </a:ln>
-        <a:ln w="19050" cap="flat" cmpd="sng" algn="ctr">
-          <a:solidFill>
-            <a:schemeClr val="phClr"/>
-          </a:solidFill>
-          <a:prstDash val="solid"/>
-          <a:miter lim="800000"/>
-        </a:ln>
-        <a:ln w="25400" cap="flat" cmpd="sng" algn="ctr">
-          <a:solidFill>
-            <a:schemeClr val="phClr"/>
-          </a:solidFill>
-          <a:prstDash val="solid"/>
-          <a:miter lim="800000"/>
-        </a:ln>
-      </a:lnStyleLst>
-      <a:effectStyleLst>
-        <a:effectStyle>
-          <a:effectLst/>
-        </a:effectStyle>
-        <a:effectStyle>
-          <a:effectLst/>
-        </a:effectStyle>
-        <a:effectStyle>
-          <a:effectLst>
-            <a:outerShdw blurRad="57150" dist="19050" dir="5400000" algn="ctr" rotWithShape="0">
-              <a:srgbClr val="000000">
-                <a:alpha val="63000"/>
-              </a:srgbClr>
-            </a:outerShdw>
-          </a:effectLst>
-        </a:effectStyle>
-      </a:effectStyleLst>
-      <a:bgFillStyleLst>
-        <a:solidFill>
-          <a:schemeClr val="phClr"/>
-        </a:solidFill>
-        <a:solidFill>
-          <a:schemeClr val="phClr">
-            <a:tint val="95000"/>
-            <a:satMod val="170000"/>
-          </a:schemeClr>
-        </a:solidFill>
-        <a:gradFill rotWithShape="1">
-          <a:gsLst>
-            <a:gs pos="0">
-              <a:schemeClr val="phClr">
-                <a:tint val="93000"/>
-                <a:satMod val="150000"/>
-                <a:shade val="98000"/>
-                <a:lumMod val="102000"/>
-              </a:schemeClr>
-            </a:gs>
-            <a:gs pos="50000">
-              <a:schemeClr val="phClr">
-                <a:tint val="98000"/>
-                <a:satMod val="130000"/>
-                <a:shade val="90000"/>
-                <a:lumMod val="103000"/>
-              </a:schemeClr>
-            </a:gs>
-            <a:gs pos="100000">
-              <a:schemeClr val="phClr">
-                <a:shade val="63000"/>
-                <a:satMod val="120000"/>
-              </a:schemeClr>
-            </a:gs>
-          </a:gsLst>
-          <a:lin ang="5400000" scaled="0"/>
-        </a:gradFill>
-      </a:bgFillStyleLst>
-    </a:fmtScheme>
-  </a:themeElements>
-  <a:objectDefaults>
-    <a:lnDef>
-      <a:spPr/>
-      <a:bodyPr/>
-      <a:lstStyle/>
-      <a:style>
-        <a:lnRef idx="2">
-          <a:schemeClr val="accent1"/>
-        </a:lnRef>
-        <a:fillRef idx="0">
-          <a:schemeClr val="accent1"/>
-        </a:fillRef>
-        <a:effectRef idx="1">
-          <a:schemeClr val="accent1"/>
-        </a:effectRef>
-        <a:fontRef idx="minor">
-          <a:schemeClr val="tx1"/>
-        </a:fontRef>
-      </a:style>
-    </a:lnDef>
-  </a:objectDefaults>
-  <a:extraClrSchemeLst/>
-  <a:extLst>
-    <a:ext uri="{05A4C25C-085E-4340-85A3-A5531E510DB2}">
-      <thm15:themeFamily xmlns:thm15="http://schemas.microsoft.com/office/thememl/2012/main" name="Office Theme" id="{2E142A2C-CD16-42D6-873A-C26D2A0506FA}" vid="{1BDDFF52-6CD6-40A5-AB3C-68EB2F1E4D0A}"/>
-    </a:ext>
-  </a:extLst>
-</a:theme>
 </file>
</xml_diff>